<commit_message>
Regenerate training deck with Aug 6-11 feature slides
Rebuilt PADB_Simple_and_Interactive.pptx from the updated archive/_build_slides.py (45 slides): adds GF export/import, in-page Help panel, padb_csv_check.py, and web app job-abort/exclusivity-guard slides. PDFs (GETTING_STARTED.pdf, PADB_Tools_Guide.pdf) stay gitignored/untracked as before.
</commit_message>
<xml_diff>
--- a/PADB_Simple_and_Interactive.pptx
+++ b/PADB_Simple_and_Interactive.pptx
@@ -46,6 +46,10 @@
     <p:sldId id="294" r:id="rId45"/>
     <p:sldId id="295" r:id="rId46"/>
     <p:sldId id="296" r:id="rId47"/>
+    <p:sldId id="297" r:id="rId48"/>
+    <p:sldId id="298" r:id="rId49"/>
+    <p:sldId id="299" r:id="rId50"/>
+    <p:sldId id="300" r:id="rId51"/>
   </p:sldIdLst>
   <p:sldSz cx="12191695" cy="6858000" type="screen4x3"/>
   <p:notesSz cx="6858000" cy="9144000"/>
@@ -9008,7 +9012,7 @@
                   <a:srgbClr val="555555"/>
                 </a:solidFill>
               </a:rPr>
-              <a:t>•  One card per native PNG, largest first</a:t>
+              <a:t>•  One card per native PNG, in pod/analytic order</a:t>
             </a:r>
           </a:p>
           <a:p>
@@ -13436,7 +13440,7 @@
               </a:defRPr>
             </a:pPr>
             <a:r>
-              <a:t>Tutorial 3 — /padb-tools</a:t>
+              <a:t>PADB Interactive — Deep Dive</a:t>
             </a:r>
           </a:p>
         </p:txBody>
@@ -13472,7 +13476,7 @@
               </a:defRPr>
             </a:pPr>
             <a:r>
-              <a:t>What It Is, When to Use It</a:t>
+              <a:t>Global Filter — Export/Import CSV, Copy PADB Filter</a:t>
             </a:r>
           </a:p>
         </p:txBody>
@@ -13611,13 +13615,29 @@
               </a:spcAft>
             </a:pPr>
             <a:r>
-              <a:rPr sz="1800">
+              <a:rPr sz="1700">
                 <a:solidFill>
                   <a:srgbClr val="1B2A4A"/>
                 </a:solidFill>
                 <a:latin typeface="Segoe UI"/>
               </a:rPr>
-              <a:t>•  A Claude Code command scoped to this repo (.claude/commands/padb-tools.md)</a:t>
+              <a:t>•  GF buttons (boxplot) are additive, not replacing — "Set filter as GF" / "Set outliers as GF" / "Set delta outliers as GF" all add to the existing filter</a:t>
+            </a:r>
+          </a:p>
+          <a:p>
+            <a:pPr lvl="1">
+              <a:spcAft>
+                <a:spcPts val="600"/>
+              </a:spcAft>
+            </a:pPr>
+            <a:r>
+              <a:rPr sz="1500">
+                <a:solidFill>
+                  <a:srgbClr val="555555"/>
+                </a:solidFill>
+                <a:latin typeface="Segoe UI"/>
+              </a:rPr>
+              <a:t>–  Use "Clear global filter" first if you want to start over from empty</a:t>
             </a:r>
           </a:p>
           <a:p>
@@ -13627,13 +13647,13 @@
               </a:spcAft>
             </a:pPr>
             <a:r>
-              <a:rPr sz="1800">
+              <a:rPr sz="1700">
                 <a:solidFill>
                   <a:srgbClr val="1B2A4A"/>
                 </a:solidFill>
                 <a:latin typeface="Segoe UI"/>
               </a:rPr>
-              <a:t>•  Surfaces a condensed index of the tool's architecture, gotchas, and a</a:t>
+              <a:t>•  Export GF CSV — downloads a human-readable CSV (Serial, Condition, Temperature, Start/Stop Freq, N Points)</a:t>
             </a:r>
           </a:p>
           <a:p>
@@ -13643,13 +13663,13 @@
               </a:spcAft>
             </a:pPr>
             <a:r>
-              <a:rPr sz="1600">
+              <a:rPr sz="1500">
                 <a:solidFill>
                   <a:srgbClr val="555555"/>
                 </a:solidFill>
                 <a:latin typeface="Segoe UI"/>
               </a:rPr>
-              <a:t>–  13-point new-pod checklist — without opening all six markdown docs</a:t>
+              <a:t>–  Frequency columns are display-only context — the runtime match is on serial+condition+temperature only</a:t>
             </a:r>
           </a:p>
           <a:p>
@@ -13659,29 +13679,13 @@
               </a:spcAft>
             </a:pPr>
             <a:r>
-              <a:rPr sz="1800">
+              <a:rPr sz="1700">
                 <a:solidFill>
                   <a:srgbClr val="1B2A4A"/>
                 </a:solidFill>
                 <a:latin typeface="Segoe UI"/>
               </a:rPr>
-              <a:t>•  Only works when Claude Code's working directory is inside the repo</a:t>
-            </a:r>
-          </a:p>
-          <a:p>
-            <a:pPr lvl="1">
-              <a:spcAft>
-                <a:spcPts val="600"/>
-              </a:spcAft>
-            </a:pPr>
-            <a:r>
-              <a:rPr sz="1600">
-                <a:solidFill>
-                  <a:srgbClr val="555555"/>
-                </a:solidFill>
-                <a:latin typeface="Segoe UI"/>
-              </a:rPr>
-              <a:t>–  (e.g. C:\apps\padb\tools) — that's what makes it "repo-scoped"</a:t>
+              <a:t>•  Import GF CSV — re-merges (adds to) the current filter from a previously exported CSV</a:t>
             </a:r>
           </a:p>
           <a:p>
@@ -13691,29 +13695,29 @@
               </a:spcAft>
             </a:pPr>
             <a:r>
-              <a:rPr sz="1800">
+              <a:rPr sz="1700">
                 <a:solidFill>
                   <a:srgbClr val="1B2A4A"/>
                 </a:solidFill>
                 <a:latin typeface="Segoe UI"/>
               </a:rPr>
-              <a:t>•  Use it when you're: onboarding a new pod, debugging a plot feature,</a:t>
-            </a:r>
-          </a:p>
-          <a:p>
-            <a:pPr lvl="1">
-              <a:spcAft>
-                <a:spcPts val="600"/>
-              </a:spcAft>
-            </a:pPr>
-            <a:r>
-              <a:rPr sz="1600">
-                <a:solidFill>
-                  <a:srgbClr val="555555"/>
-                </a:solidFill>
-                <a:latin typeface="Segoe UI"/>
-              </a:rPr>
-              <a:t>–  reviewing generated HTML, or just orienting yourself in a new session</a:t>
+              <a:t>•  Copy PADB Filter — best-effort 'Serial Number' NOT IN {...} expression for pasting into PADB itself (under development)</a:t>
+            </a:r>
+          </a:p>
+          <a:p>
+            <a:pPr>
+              <a:spcAft>
+                <a:spcPts val="1000"/>
+              </a:spcAft>
+            </a:pPr>
+            <a:r>
+              <a:rPr sz="1700">
+                <a:solidFill>
+                  <a:srgbClr val="1B2A4A"/>
+                </a:solidFill>
+                <a:latin typeface="Segoe UI"/>
+              </a:rPr>
+              <a:t>•  Once set, GF propagates automatically to summary and env_coverage — no need to re-select DUTs per view</a:t>
             </a:r>
           </a:p>
         </p:txBody>
@@ -13811,7 +13815,7 @@
               </a:defRPr>
             </a:pPr>
             <a:r>
-              <a:t>Tutorial 3 — /padb-tools</a:t>
+              <a:t>PADB Interactive — Deep Dive</a:t>
             </a:r>
           </a:p>
         </p:txBody>
@@ -13847,7 +13851,7 @@
               </a:defRPr>
             </a:pPr>
             <a:r>
-              <a:t>What It Actually Tells You</a:t>
+              <a:t>In-Page Help Panel — Explains Itself</a:t>
             </a:r>
           </a:p>
         </p:txBody>
@@ -13992,7 +13996,39 @@
                 </a:solidFill>
                 <a:latin typeface="Segoe UI"/>
               </a:rPr>
-              <a:t>•  A few of the 13 new-pod checklist items it surfaces immediately:</a:t>
+              <a:t>•  Every one of the 6 main views now has a collapsible ⓘ Help button</a:t>
+            </a:r>
+          </a:p>
+          <a:p>
+            <a:pPr>
+              <a:spcAft>
+                <a:spcPts val="1000"/>
+              </a:spcAft>
+            </a:pPr>
+            <a:r>
+              <a:rPr sz="1700">
+                <a:solidFill>
+                  <a:srgbClr val="1B2A4A"/>
+                </a:solidFill>
+                <a:latin typeface="Segoe UI"/>
+              </a:rPr>
+              <a:t>•  Static explanation: what Filter / Group by / Segment by actually do, and how an unfiltered dimension can pool into extra segments or legend entries</a:t>
+            </a:r>
+          </a:p>
+          <a:p>
+            <a:pPr>
+              <a:spcAft>
+                <a:spcPts val="1000"/>
+              </a:spcAft>
+            </a:pPr>
+            <a:r>
+              <a:rPr sz="1700">
+                <a:solidFill>
+                  <a:srgbClr val="1B2A4A"/>
+                </a:solidFill>
+                <a:latin typeface="Segoe UI"/>
+              </a:rPr>
+              <a:t>•  Dynamic check: flags rows where Upper_Limit &lt; Lower_Limit or Spec_Hi &lt; Spec_Lo (backwards from the usual convention)</a:t>
             </a:r>
           </a:p>
           <a:p>
@@ -14008,55 +14044,7 @@
                 </a:solidFill>
                 <a:latin typeface="Segoe UI"/>
               </a:rPr>
-              <a:t>–  TestRun_RunStatus — exit 0 but no CSV? Check the pod's default 'P'-only filter</a:t>
-            </a:r>
-          </a:p>
-          <a:p>
-            <a:pPr lvl="1">
-              <a:spcAft>
-                <a:spcPts val="600"/>
-              </a:spcAft>
-            </a:pPr>
-            <a:r>
-              <a:rPr sz="1500">
-                <a:solidFill>
-                  <a:srgbClr val="555555"/>
-                </a:solidFill>
-                <a:latin typeface="Segoe UI"/>
-              </a:rPr>
-              <a:t>–  Environment_TestStep must be {All} or distribution/env_coverage/summary go empty</a:t>
-            </a:r>
-          </a:p>
-          <a:p>
-            <a:pPr lvl="1">
-              <a:spcAft>
-                <a:spcPts val="600"/>
-              </a:spcAft>
-            </a:pPr>
-            <a:r>
-              <a:rPr sz="1500">
-                <a:solidFill>
-                  <a:srgbClr val="555555"/>
-                </a:solidFill>
-                <a:latin typeface="Segoe UI"/>
-              </a:rPr>
-              <a:t>–  OutputConfig_OutputCSV=False on a Scatter analytic — renders PNG, writes no CSV</a:t>
-            </a:r>
-          </a:p>
-          <a:p>
-            <a:pPr lvl="1">
-              <a:spcAft>
-                <a:spcPts val="600"/>
-              </a:spcAft>
-            </a:pPr>
-            <a:r>
-              <a:rPr sz="1500">
-                <a:solidFill>
-                  <a:srgbClr val="555555"/>
-                </a:solidFill>
-                <a:latin typeface="Segoe UI"/>
-              </a:rPr>
-              <a:t>–  Generated job.json path length — warns before Windows' 260-char limit bites</a:t>
+              <a:t>–  Names which filter-dimension value(s) the inverted rows are concentrated in</a:t>
             </a:r>
           </a:p>
           <a:p>
@@ -14072,23 +14060,23 @@
                 </a:solidFill>
                 <a:latin typeface="Segoe UI"/>
               </a:rPr>
-              <a:t>•  Plus: the architecture one-liner, common JS gotchas, and pointers to the</a:t>
-            </a:r>
-          </a:p>
-          <a:p>
-            <a:pPr lvl="1">
-              <a:spcAft>
-                <a:spcPts val="600"/>
-              </a:spcAft>
-            </a:pPr>
-            <a:r>
-              <a:rPr sz="1500">
-                <a:solidFill>
-                  <a:srgbClr val="555555"/>
-                </a:solidFill>
-                <a:latin typeface="Segoe UI"/>
-              </a:rPr>
-              <a:t>–  full doc for anything it only summarizes</a:t>
+              <a:t>•  Real example this caught: "14 segments where ~7 were expected" traced to one Serial Number with inverted spec rows across its whole dataset — a pod data issue, not a tool bug</a:t>
+            </a:r>
+          </a:p>
+          <a:p>
+            <a:pPr>
+              <a:spcAft>
+                <a:spcPts val="1000"/>
+              </a:spcAft>
+            </a:pPr>
+            <a:r>
+              <a:rPr sz="1700">
+                <a:solidFill>
+                  <a:srgbClr val="1B2A4A"/>
+                </a:solidFill>
+                <a:latin typeface="Segoe UI"/>
+              </a:rPr>
+              <a:t>•  Run padb_csv_check.py (next slide) to catch the same class of issue before you even open the HTML</a:t>
             </a:r>
           </a:p>
         </p:txBody>
@@ -14186,7 +14174,7 @@
               </a:defRPr>
             </a:pPr>
             <a:r>
-              <a:t>Tutorial 3 — /padb-tools</a:t>
+              <a:t>PADB Interactive — Deep Dive</a:t>
             </a:r>
           </a:p>
         </p:txBody>
@@ -14222,7 +14210,7 @@
               </a:defRPr>
             </a:pPr>
             <a:r>
-              <a:t>Worked Example: MaxPowerTutorial3.pod</a:t>
+              <a:t>Pre-Flight Check — padb_csv_check.py</a:t>
             </a:r>
           </a:p>
         </p:txBody>
@@ -14341,8 +14329,8 @@
         </p:nvSpPr>
         <p:spPr>
           <a:xfrm>
-            <a:off x="548640" y="1645920"/>
-            <a:ext cx="11064240" cy="4754880"/>
+            <a:off x="548640" y="1691640"/>
+            <a:ext cx="11064240" cy="457200"/>
           </a:xfrm>
           <a:prstGeom prst="rect">
             <a:avLst/>
@@ -14361,15 +14349,99 @@
               </a:spcAft>
             </a:pPr>
             <a:r>
-              <a:rPr sz="1800">
+              <a:rPr sz="1700">
                 <a:solidFill>
                   <a:srgbClr val="1B2A4A"/>
                 </a:solidFill>
                 <a:latin typeface="Segoe UI"/>
               </a:rPr>
-              <a:t>•  You've just been handed MaxPowerTutorial3.pod — 2 analytics, never run before</a:t>
-            </a:r>
-          </a:p>
+              <a:t>•  Run it between Step 2 (extraction) and Step 4 (build views) — before spending time on a build that turns out wrong:</a:t>
+            </a:r>
+          </a:p>
+        </p:txBody>
+      </p:sp>
+      <p:sp>
+        <p:nvSpPr>
+          <p:cNvPr id="9" name="Rounded Rectangle 8"/>
+          <p:cNvSpPr/>
+          <p:nvPr/>
+        </p:nvSpPr>
+        <p:spPr>
+          <a:xfrm>
+            <a:off x="548640" y="2148840"/>
+            <a:ext cx="11064240" cy="502920"/>
+          </a:xfrm>
+          <a:prstGeom prst="roundRect">
+            <a:avLst>
+              <a:gd name="adj" fmla="val 4000"/>
+            </a:avLst>
+          </a:prstGeom>
+          <a:solidFill>
+            <a:srgbClr val="282C34"/>
+          </a:solidFill>
+          <a:ln>
+            <a:solidFill>
+              <a:srgbClr val="111318"/>
+            </a:solidFill>
+          </a:ln>
+          <a:effectLst/>
+        </p:spPr>
+        <p:style>
+          <a:lnRef idx="1">
+            <a:schemeClr val="accent1"/>
+          </a:lnRef>
+          <a:fillRef idx="3">
+            <a:schemeClr val="accent1"/>
+          </a:fillRef>
+          <a:effectRef idx="2">
+            <a:schemeClr val="accent1"/>
+          </a:effectRef>
+          <a:fontRef idx="minor">
+            <a:schemeClr val="lt1"/>
+          </a:fontRef>
+        </p:style>
+        <p:txBody>
+          <a:bodyPr rtlCol="0" anchor="t" wrap="square" lIns="228600" rIns="228600" tIns="164592" bIns="164592"/>
+          <a:lstStyle/>
+          <a:p>
+            <a:pPr algn="l">
+              <a:spcAft>
+                <a:spcPts val="200"/>
+              </a:spcAft>
+            </a:pPr>
+            <a:r>
+              <a:rPr sz="1500">
+                <a:solidFill>
+                  <a:srgbClr val="E6E6E6"/>
+                </a:solidFill>
+                <a:latin typeface="Consolas"/>
+              </a:rPr>
+              <a:t>py padb_csv_check.py path\to\Scatter.csv</a:t>
+            </a:r>
+          </a:p>
+        </p:txBody>
+      </p:sp>
+      <p:sp>
+        <p:nvSpPr>
+          <p:cNvPr id="10" name="TextBox 9"/>
+          <p:cNvSpPr txBox="1"/>
+          <p:nvPr/>
+        </p:nvSpPr>
+        <p:spPr>
+          <a:xfrm>
+            <a:off x="548640" y="2834640"/>
+            <a:ext cx="11064240" cy="2743200"/>
+          </a:xfrm>
+          <a:prstGeom prst="rect">
+            <a:avLst/>
+          </a:prstGeom>
+          <a:noFill/>
+        </p:spPr>
+        <p:txBody>
+          <a:bodyPr wrap="square">
+            <a:spAutoFit/>
+          </a:bodyPr>
+          <a:lstStyle/>
           <a:p>
             <a:pPr>
               <a:spcAft>
@@ -14377,13 +14449,13 @@
               </a:spcAft>
             </a:pPr>
             <a:r>
-              <a:rPr sz="1800">
+              <a:rPr sz="1700">
                 <a:solidFill>
                   <a:srgbClr val="1B2A4A"/>
                 </a:solidFill>
                 <a:latin typeface="Segoe UI"/>
               </a:rPr>
-              <a:t>•  Open Claude Code with your working directory inside the padb-tools repo</a:t>
+              <a:t>•  Calls the exact same CSV-loading function padb_v2.py itself uses — findings can't drift out of sync with what actually gets plotted</a:t>
             </a:r>
           </a:p>
           <a:p>
@@ -14393,13 +14465,13 @@
               </a:spcAft>
             </a:pPr>
             <a:r>
-              <a:rPr sz="1800">
+              <a:rPr sz="1700">
                 <a:solidFill>
                   <a:srgbClr val="1B2A4A"/>
                 </a:solidFill>
                 <a:latin typeface="Segoe UI"/>
               </a:rPr>
-              <a:t>•  Type: /padb-tools</a:t>
+              <a:t>•  Flags orphaned numeric columns (a second swept dimension sitting unused), inverted spec rows, high Group cardinality (&gt;100 crowded, &gt;500 genuinely slow), and missing grouping items (Serial/Port/Spec/Uncertainty)</a:t>
             </a:r>
           </a:p>
           <a:p>
@@ -14409,61 +14481,13 @@
               </a:spcAft>
             </a:pPr>
             <a:r>
-              <a:rPr sz="1800">
+              <a:rPr sz="1700">
                 <a:solidFill>
                   <a:srgbClr val="1B2A4A"/>
                 </a:solidFill>
                 <a:latin typeface="Segoe UI"/>
               </a:rPr>
-              <a:t>•  Ask directly: "Is MaxPowerTutorial3.pod ready to run in Interactive mode?"</a:t>
-            </a:r>
-          </a:p>
-          <a:p>
-            <a:pPr>
-              <a:spcAft>
-                <a:spcPts val="1000"/>
-              </a:spcAft>
-            </a:pPr>
-            <a:r>
-              <a:rPr sz="1800">
-                <a:solidFill>
-                  <a:srgbClr val="1B2A4A"/>
-                </a:solidFill>
-                <a:latin typeface="Segoe UI"/>
-              </a:rPr>
-              <a:t>•  Claude reads the checklist above, then actually inspects the pod file —</a:t>
-            </a:r>
-          </a:p>
-          <a:p>
-            <a:pPr lvl="1">
-              <a:spcAft>
-                <a:spcPts val="600"/>
-              </a:spcAft>
-            </a:pPr>
-            <a:r>
-              <a:rPr sz="1600">
-                <a:solidFill>
-                  <a:srgbClr val="555555"/>
-                </a:solidFill>
-                <a:latin typeface="Segoe UI"/>
-              </a:rPr>
-              <a:t>–  Limits_YLimit, Environment_TestStep, OutputConfig_OutputCSV, Group strings</a:t>
-            </a:r>
-          </a:p>
-          <a:p>
-            <a:pPr>
-              <a:spcAft>
-                <a:spcPts val="1000"/>
-              </a:spcAft>
-            </a:pPr>
-            <a:r>
-              <a:rPr sz="1800">
-                <a:solidFill>
-                  <a:srgbClr val="1B2A4A"/>
-                </a:solidFill>
-                <a:latin typeface="Segoe UI"/>
-              </a:rPr>
-              <a:t>•  You get a direct answer grounded in this pod's real settings, not a guess</a:t>
+              <a:t>•  Exit code 1 on any WARN/FAIL — usable as a pre-flight gate in a script, not just an interactive read</a:t>
             </a:r>
           </a:p>
         </p:txBody>
@@ -14561,7 +14585,7 @@
               </a:defRPr>
             </a:pPr>
             <a:r>
-              <a:t>Multi-Site Testing</a:t>
+              <a:t>Web App Reliability</a:t>
             </a:r>
           </a:p>
         </p:txBody>
@@ -14597,7 +14621,7 @@
               </a:defRPr>
             </a:pPr>
             <a:r>
-              <a:t>Same Test, Different Database</a:t>
+              <a:t>Job Abort &amp; Cross-Process PADB-R.exe Exclusivity</a:t>
             </a:r>
           </a:p>
         </p:txBody>
@@ -14742,7 +14766,39 @@
                 </a:solidFill>
                 <a:latin typeface="Segoe UI"/>
               </a:rPr>
-              <a:t>•  Malaysia (AMC2) production ramp-up: the same test now also pulls from</a:t>
+              <a:t>•  Job abort — a queued or running job in the web app can now be cancelled from the status panel</a:t>
+            </a:r>
+          </a:p>
+          <a:p>
+            <a:pPr>
+              <a:spcAft>
+                <a:spcPts val="1000"/>
+              </a:spcAft>
+            </a:pPr>
+            <a:r>
+              <a:rPr sz="1700">
+                <a:solidFill>
+                  <a:srgbClr val="1B2A4A"/>
+                </a:solidFill>
+                <a:latin typeface="Segoe UI"/>
+              </a:rPr>
+              <a:t>•  Run jobs execute before plot jobs whenever a mixed selection is run</a:t>
+            </a:r>
+          </a:p>
+          <a:p>
+            <a:pPr>
+              <a:spcAft>
+                <a:spcPts val="1000"/>
+              </a:spcAft>
+            </a:pPr>
+            <a:r>
+              <a:rPr sz="1700">
+                <a:solidFill>
+                  <a:srgbClr val="1B2A4A"/>
+                </a:solidFill>
+                <a:latin typeface="Segoe UI"/>
+              </a:rPr>
+              <a:t>•  Cross-process exclusivity guard (padb_batch.py) — two PADB-R.exe instances interfere with and stall each other, even across separate process launches (e.g. a webapp restart mid-run)</a:t>
             </a:r>
           </a:p>
           <a:p>
@@ -14758,23 +14814,7 @@
                 </a:solidFill>
                 <a:latin typeface="Segoe UI"/>
               </a:rPr>
-              <a:t>–  AMC2's own PADB Oracle database, not just Santa Rosa's</a:t>
-            </a:r>
-          </a:p>
-          <a:p>
-            <a:pPr>
-              <a:spcAft>
-                <a:spcPts val="1000"/>
-              </a:spcAft>
-            </a:pPr>
-            <a:r>
-              <a:rPr sz="1700">
-                <a:solidFill>
-                  <a:srgbClr val="1B2A4A"/>
-                </a:solidFill>
-                <a:latin typeface="Segoe UI"/>
-              </a:rPr>
-              <a:t>•  Comparing a real Santa Rosa pod against its AMC2 counterpart: the only</a:t>
+              <a:t>–  Every entry point (CLI and web app alike) now waits on the live OS process table before launching, rather than trusting one process's own in-memory queue</a:t>
             </a:r>
           </a:p>
           <a:p>
@@ -14790,87 +14830,7 @@
                 </a:solidFill>
                 <a:latin typeface="Segoe UI"/>
               </a:rPr>
-              <a:t>–  genuine differences are Device_Server and Device_Database in [Extract]</a:t>
-            </a:r>
-          </a:p>
-          <a:p>
-            <a:pPr>
-              <a:spcAft>
-                <a:spcPts val="1000"/>
-              </a:spcAft>
-            </a:pPr>
-            <a:r>
-              <a:rPr sz="1700">
-                <a:solidFill>
-                  <a:srgbClr val="1B2A4A"/>
-                </a:solidFill>
-                <a:latin typeface="Segoe UI"/>
-              </a:rPr>
-              <a:t>•  Every AnalyticName and OutputConfig_OutputFile is otherwise identical —</a:t>
-            </a:r>
-          </a:p>
-          <a:p>
-            <a:pPr lvl="1">
-              <a:spcAft>
-                <a:spcPts val="600"/>
-              </a:spcAft>
-            </a:pPr>
-            <a:r>
-              <a:rPr sz="1500">
-                <a:solidFill>
-                  <a:srgbClr val="555555"/>
-                </a:solidFill>
-                <a:latin typeface="Segoe UI"/>
-              </a:rPr>
-              <a:t>–  running both site variants writes identically-named CSVs</a:t>
-            </a:r>
-          </a:p>
-          <a:p>
-            <a:pPr>
-              <a:spcAft>
-                <a:spcPts val="1000"/>
-              </a:spcAft>
-            </a:pPr>
-            <a:r>
-              <a:rPr sz="1700">
-                <a:solidFill>
-                  <a:srgbClr val="1B2A4A"/>
-                </a:solidFill>
-                <a:latin typeface="Segoe UI"/>
-              </a:rPr>
-              <a:t>•  Risk: point both at a shared results/publish location and one silently</a:t>
-            </a:r>
-          </a:p>
-          <a:p>
-            <a:pPr lvl="1">
-              <a:spcAft>
-                <a:spcPts val="600"/>
-              </a:spcAft>
-            </a:pPr>
-            <a:r>
-              <a:rPr sz="1500">
-                <a:solidFill>
-                  <a:srgbClr val="555555"/>
-                </a:solidFill>
-                <a:latin typeface="Segoe UI"/>
-              </a:rPr>
-              <a:t>–  overwrites the other — same class of problem unique_output_filenames</a:t>
-            </a:r>
-          </a:p>
-          <a:p>
-            <a:pPr lvl="1">
-              <a:spcAft>
-                <a:spcPts val="600"/>
-              </a:spcAft>
-            </a:pPr>
-            <a:r>
-              <a:rPr sz="1500">
-                <a:solidFill>
-                  <a:srgbClr val="555555"/>
-                </a:solidFill>
-                <a:latin typeface="Segoe UI"/>
-              </a:rPr>
-              <a:t>–  solves within one pod, but across two site-variant pods instead</a:t>
+              <a:t>–  If it never clears, it names the blocking PID(s) with the exact taskkill command to clear a genuinely-stuck instance by hand</a:t>
             </a:r>
           </a:p>
         </p:txBody>
@@ -14968,7 +14928,7 @@
               </a:defRPr>
             </a:pPr>
             <a:r>
-              <a:t>Multi-Site Testing</a:t>
+              <a:t>Tutorial 3 — /padb-tools</a:t>
             </a:r>
           </a:p>
         </p:txBody>
@@ -15004,7 +14964,7 @@
               </a:defRPr>
             </a:pPr>
             <a:r>
-              <a:t>padb_convert_site.py — Converting a Pod</a:t>
+              <a:t>What It Is, When to Use It</a:t>
             </a:r>
           </a:p>
         </p:txBody>
@@ -15123,8 +15083,8 @@
         </p:nvSpPr>
         <p:spPr>
           <a:xfrm>
-            <a:off x="548640" y="1600200"/>
-            <a:ext cx="11064240" cy="365760"/>
+            <a:off x="548640" y="1645920"/>
+            <a:ext cx="11064240" cy="4754880"/>
           </a:xfrm>
           <a:prstGeom prst="rect">
             <a:avLst/>
@@ -15143,256 +15103,79 @@
               </a:spcAft>
             </a:pPr>
             <a:r>
+              <a:rPr sz="1800">
+                <a:solidFill>
+                  <a:srgbClr val="1B2A4A"/>
+                </a:solidFill>
+                <a:latin typeface="Segoe UI"/>
+              </a:rPr>
+              <a:t>•  A Claude Code command scoped to this repo (.claude/commands/padb-tools.md)</a:t>
+            </a:r>
+          </a:p>
+          <a:p>
+            <a:pPr>
+              <a:spcAft>
+                <a:spcPts val="1000"/>
+              </a:spcAft>
+            </a:pPr>
+            <a:r>
+              <a:rPr sz="1800">
+                <a:solidFill>
+                  <a:srgbClr val="1B2A4A"/>
+                </a:solidFill>
+                <a:latin typeface="Segoe UI"/>
+              </a:rPr>
+              <a:t>•  Surfaces a condensed index of the tool's architecture, gotchas, and a</a:t>
+            </a:r>
+          </a:p>
+          <a:p>
+            <a:pPr lvl="1">
+              <a:spcAft>
+                <a:spcPts val="600"/>
+              </a:spcAft>
+            </a:pPr>
+            <a:r>
               <a:rPr sz="1600">
                 <a:solidFill>
+                  <a:srgbClr val="555555"/>
+                </a:solidFill>
+                <a:latin typeface="Segoe UI"/>
+              </a:rPr>
+              <a:t>–  13-point new-pod checklist — without opening all six markdown docs</a:t>
+            </a:r>
+          </a:p>
+          <a:p>
+            <a:pPr>
+              <a:spcAft>
+                <a:spcPts val="1000"/>
+              </a:spcAft>
+            </a:pPr>
+            <a:r>
+              <a:rPr sz="1800">
+                <a:solidFill>
                   <a:srgbClr val="1B2A4A"/>
                 </a:solidFill>
                 <a:latin typeface="Segoe UI"/>
               </a:rPr>
-              <a:t>•  Site registry lives in padb_sites.json — add a new site there, no code changes:</a:t>
-            </a:r>
-          </a:p>
-        </p:txBody>
-      </p:sp>
-      <p:sp>
-        <p:nvSpPr>
-          <p:cNvPr id="9" name="Rounded Rectangle 8"/>
-          <p:cNvSpPr/>
-          <p:nvPr/>
-        </p:nvSpPr>
-        <p:spPr>
-          <a:xfrm>
-            <a:off x="548640" y="1965960"/>
-            <a:ext cx="11064240" cy="502920"/>
-          </a:xfrm>
-          <a:prstGeom prst="roundRect">
-            <a:avLst>
-              <a:gd name="adj" fmla="val 4000"/>
-            </a:avLst>
-          </a:prstGeom>
-          <a:solidFill>
-            <a:srgbClr val="282C34"/>
-          </a:solidFill>
-          <a:ln>
-            <a:solidFill>
-              <a:srgbClr val="111318"/>
-            </a:solidFill>
-          </a:ln>
-          <a:effectLst/>
-        </p:spPr>
-        <p:style>
-          <a:lnRef idx="1">
-            <a:schemeClr val="accent1"/>
-          </a:lnRef>
-          <a:fillRef idx="3">
-            <a:schemeClr val="accent1"/>
-          </a:fillRef>
-          <a:effectRef idx="2">
-            <a:schemeClr val="accent1"/>
-          </a:effectRef>
-          <a:fontRef idx="minor">
-            <a:schemeClr val="lt1"/>
-          </a:fontRef>
-        </p:style>
-        <p:txBody>
-          <a:bodyPr rtlCol="0" anchor="t" wrap="square" lIns="228600" rIns="228600" tIns="164592" bIns="164592"/>
-          <a:lstStyle/>
-          <a:p>
-            <a:pPr algn="l">
-              <a:spcAft>
-                <a:spcPts val="200"/>
-              </a:spcAft>
-            </a:pPr>
-            <a:r>
-              <a:rPr sz="1450">
-                <a:solidFill>
-                  <a:srgbClr val="E6E6E6"/>
-                </a:solidFill>
-                <a:latin typeface="Consolas"/>
-              </a:rPr>
-              <a:t>py padb_convert_site.py --pod MyPod.pod --to AMC2</a:t>
-            </a:r>
-          </a:p>
-        </p:txBody>
-      </p:sp>
-      <p:sp>
-        <p:nvSpPr>
-          <p:cNvPr id="10" name="Rounded Rectangle 9"/>
-          <p:cNvSpPr/>
-          <p:nvPr/>
-        </p:nvSpPr>
-        <p:spPr>
-          <a:xfrm>
-            <a:off x="548640" y="2606040"/>
-            <a:ext cx="11064240" cy="2286000"/>
-          </a:xfrm>
-          <a:prstGeom prst="roundRect">
-            <a:avLst>
-              <a:gd name="adj" fmla="val 4000"/>
-            </a:avLst>
-          </a:prstGeom>
-          <a:solidFill>
-            <a:srgbClr val="282C34"/>
-          </a:solidFill>
-          <a:ln>
-            <a:solidFill>
-              <a:srgbClr val="111318"/>
-            </a:solidFill>
-          </a:ln>
-          <a:effectLst/>
-        </p:spPr>
-        <p:style>
-          <a:lnRef idx="1">
-            <a:schemeClr val="accent1"/>
-          </a:lnRef>
-          <a:fillRef idx="3">
-            <a:schemeClr val="accent1"/>
-          </a:fillRef>
-          <a:effectRef idx="2">
-            <a:schemeClr val="accent1"/>
-          </a:effectRef>
-          <a:fontRef idx="minor">
-            <a:schemeClr val="lt1"/>
-          </a:fontRef>
-        </p:style>
-        <p:txBody>
-          <a:bodyPr rtlCol="0" anchor="t" wrap="square" lIns="228600" rIns="228600" tIns="164592" bIns="164592"/>
-          <a:lstStyle/>
-          <a:p>
-            <a:pPr algn="l">
-              <a:spcAft>
-                <a:spcPts val="200"/>
-              </a:spcAft>
-            </a:pPr>
-            <a:r>
-              <a:rPr sz="1350">
-                <a:solidFill>
-                  <a:srgbClr val="E6E6E6"/>
-                </a:solidFill>
-                <a:latin typeface="Consolas"/>
-              </a:rPr>
-              <a:t>Wrote MyPod-AMC2.pod  (SantaRosa -&gt; AMC2)</a:t>
-            </a:r>
-          </a:p>
-          <a:p>
-            <a:pPr algn="l">
-              <a:spcAft>
-                <a:spcPts val="200"/>
-              </a:spcAft>
-            </a:pPr>
-            <a:r>
-              <a:rPr sz="1350">
-                <a:solidFill>
-                  <a:srgbClr val="E6E6E6"/>
-                </a:solidFill>
-                <a:latin typeface="Consolas"/>
-              </a:rPr>
-              <a:t>  Device_Server -&gt; PADB ORACLE AMC2</a:t>
-            </a:r>
-          </a:p>
-          <a:p>
-            <a:pPr algn="l">
-              <a:spcAft>
-                <a:spcPts val="200"/>
-              </a:spcAft>
-            </a:pPr>
-            <a:r>
-              <a:rPr sz="1350">
-                <a:solidFill>
-                  <a:srgbClr val="E6E6E6"/>
-                </a:solidFill>
-                <a:latin typeface="Consolas"/>
-              </a:rPr>
-              <a:t>  Device_Database -&gt; GALLEON_1</a:t>
-            </a:r>
-          </a:p>
-          <a:p>
-            <a:pPr algn="l">
-              <a:spcAft>
-                <a:spcPts val="200"/>
-              </a:spcAft>
-            </a:pPr>
-            <a:r>
-              <a:rPr sz="1350">
-                <a:solidFill>
-                  <a:srgbClr val="E6E6E6"/>
-                </a:solidFill>
-                <a:latin typeface="Consolas"/>
-              </a:rPr>
-              <a:t>  AnalyticName 'Leveled Linear' -&gt; 'Leveled Linear AMC2'</a:t>
-            </a:r>
-          </a:p>
-          <a:p>
-            <a:pPr algn="l">
-              <a:spcAft>
-                <a:spcPts val="200"/>
-              </a:spcAft>
-            </a:pPr>
-            <a:r>
-              <a:rPr sz="1350">
-                <a:solidFill>
-                  <a:srgbClr val="E6E6E6"/>
-                </a:solidFill>
-                <a:latin typeface="Consolas"/>
-              </a:rPr>
-              <a:t>  OutputConfig_OutputFile '..._Linear' -&gt; '..._Linear_AMC2'</a:t>
-            </a:r>
-          </a:p>
-          <a:p>
-            <a:pPr algn="l">
-              <a:spcAft>
-                <a:spcPts val="200"/>
-              </a:spcAft>
-            </a:pPr>
-            <a:r>
-              <a:rPr sz="1350">
-                <a:solidFill>
-                  <a:srgbClr val="E6E6E6"/>
-                </a:solidFill>
-                <a:latin typeface="Consolas"/>
-              </a:rPr>
-              <a:t>  WARNING: SaoFile now points at 'MyPod-AMC2.sao', which does not</a:t>
-            </a:r>
-          </a:p>
-          <a:p>
-            <a:pPr algn="l">
-              <a:spcAft>
-                <a:spcPts val="200"/>
-              </a:spcAft>
-            </a:pPr>
-            <a:r>
-              <a:rPr sz="1350">
-                <a:solidFill>
-                  <a:srgbClr val="E6E6E6"/>
-                </a:solidFill>
-                <a:latin typeface="Consolas"/>
-              </a:rPr>
-              <a:t>  exist yet -- supply a real .sao extracted at AMC2 before running</a:t>
-            </a:r>
-          </a:p>
-        </p:txBody>
-      </p:sp>
-      <p:sp>
-        <p:nvSpPr>
-          <p:cNvPr id="11" name="TextBox 10"/>
-          <p:cNvSpPr txBox="1"/>
-          <p:nvPr/>
-        </p:nvSpPr>
-        <p:spPr>
-          <a:xfrm>
-            <a:off x="548640" y="5074920"/>
-            <a:ext cx="11064240" cy="640080"/>
-          </a:xfrm>
-          <a:prstGeom prst="rect">
-            <a:avLst/>
-          </a:prstGeom>
-          <a:noFill/>
-        </p:spPr>
-        <p:txBody>
-          <a:bodyPr wrap="square">
-            <a:spAutoFit/>
-          </a:bodyPr>
-          <a:lstStyle/>
+              <a:t>•  Only works when Claude Code's working directory is inside the repo</a:t>
+            </a:r>
+          </a:p>
+          <a:p>
+            <a:pPr lvl="1">
+              <a:spcAft>
+                <a:spcPts val="600"/>
+              </a:spcAft>
+            </a:pPr>
+            <a:r>
+              <a:rPr sz="1600">
+                <a:solidFill>
+                  <a:srgbClr val="555555"/>
+                </a:solidFill>
+                <a:latin typeface="Segoe UI"/>
+              </a:rPr>
+              <a:t>–  (e.g. C:\apps\padb\tools) — that's what makes it "repo-scoped"</a:t>
+            </a:r>
+          </a:p>
           <a:p>
             <a:pPr>
               <a:spcAft>
@@ -15400,13 +15183,13 @@
               </a:spcAft>
             </a:pPr>
             <a:r>
-              <a:rPr sz="1500">
+              <a:rPr sz="1800">
                 <a:solidFill>
                   <a:srgbClr val="1B2A4A"/>
                 </a:solidFill>
                 <a:latin typeface="Segoe UI"/>
               </a:rPr>
-              <a:t>•  Source pod is never touched. Round-trip verified byte-identical</a:t>
+              <a:t>•  Use it when you're: onboarding a new pod, debugging a plot feature,</a:t>
             </a:r>
           </a:p>
           <a:p>
@@ -15416,13 +15199,13 @@
               </a:spcAft>
             </a:pPr>
             <a:r>
-              <a:rPr sz="1300">
+              <a:rPr sz="1600">
                 <a:solidFill>
                   <a:srgbClr val="555555"/>
                 </a:solidFill>
                 <a:latin typeface="Segoe UI"/>
               </a:rPr>
-              <a:t>–  (SantaRosa -&gt; AMC2 -&gt; SantaRosa reproduces the original exactly)</a:t>
+              <a:t>–  reviewing generated HTML, or just orienting yourself in a new session</a:t>
             </a:r>
           </a:p>
         </p:txBody>
@@ -15520,7 +15303,7 @@
               </a:defRPr>
             </a:pPr>
             <a:r>
-              <a:t>Multi-Site Testing</a:t>
+              <a:t>Tutorial 3 — /padb-tools</a:t>
             </a:r>
           </a:p>
         </p:txBody>
@@ -15556,7 +15339,7 @@
               </a:defRPr>
             </a:pPr>
             <a:r>
-              <a:t>padb_convert_site.py — Converting a Job</a:t>
+              <a:t>What It Actually Tells You</a:t>
             </a:r>
           </a:p>
         </p:txBody>
@@ -15669,75 +15452,14 @@
       </p:sp>
       <p:sp>
         <p:nvSpPr>
-          <p:cNvPr id="8" name="Rounded Rectangle 7"/>
-          <p:cNvSpPr/>
-          <p:nvPr/>
-        </p:nvSpPr>
-        <p:spPr>
-          <a:xfrm>
-            <a:off x="548640" y="1691640"/>
-            <a:ext cx="11064240" cy="502920"/>
-          </a:xfrm>
-          <a:prstGeom prst="roundRect">
-            <a:avLst>
-              <a:gd name="adj" fmla="val 4000"/>
-            </a:avLst>
-          </a:prstGeom>
-          <a:solidFill>
-            <a:srgbClr val="282C34"/>
-          </a:solidFill>
-          <a:ln>
-            <a:solidFill>
-              <a:srgbClr val="111318"/>
-            </a:solidFill>
-          </a:ln>
-          <a:effectLst/>
-        </p:spPr>
-        <p:style>
-          <a:lnRef idx="1">
-            <a:schemeClr val="accent1"/>
-          </a:lnRef>
-          <a:fillRef idx="3">
-            <a:schemeClr val="accent1"/>
-          </a:fillRef>
-          <a:effectRef idx="2">
-            <a:schemeClr val="accent1"/>
-          </a:effectRef>
-          <a:fontRef idx="minor">
-            <a:schemeClr val="lt1"/>
-          </a:fontRef>
-        </p:style>
-        <p:txBody>
-          <a:bodyPr rtlCol="0" anchor="t" wrap="square" lIns="228600" rIns="228600" tIns="164592" bIns="164592"/>
-          <a:lstStyle/>
-          <a:p>
-            <a:pPr algn="l">
-              <a:spcAft>
-                <a:spcPts val="200"/>
-              </a:spcAft>
-            </a:pPr>
-            <a:r>
-              <a:rPr sz="1450">
-                <a:solidFill>
-                  <a:srgbClr val="E6E6E6"/>
-                </a:solidFill>
-                <a:latin typeface="Consolas"/>
-              </a:rPr>
-              <a:t>py padb_convert_site.py --job my_run_job.json --to AMC2</a:t>
-            </a:r>
-          </a:p>
-        </p:txBody>
-      </p:sp>
-      <p:sp>
-        <p:nvSpPr>
-          <p:cNvPr id="9" name="TextBox 8"/>
-          <p:cNvSpPr txBox="1"/>
-          <p:nvPr/>
-        </p:nvSpPr>
-        <p:spPr>
-          <a:xfrm>
-            <a:off x="548640" y="2377440"/>
-            <a:ext cx="11064240" cy="365760"/>
+          <p:cNvPr id="8" name="TextBox 7"/>
+          <p:cNvSpPr txBox="1"/>
+          <p:nvPr/>
+        </p:nvSpPr>
+        <p:spPr>
+          <a:xfrm>
+            <a:off x="548640" y="1645920"/>
+            <a:ext cx="11064240" cy="4754880"/>
           </a:xfrm>
           <a:prstGeom prst="rect">
             <a:avLst/>
@@ -15762,173 +15484,73 @@
                 </a:solidFill>
                 <a:latin typeface="Segoe UI"/>
               </a:rPr>
-              <a:t>•  Repoints "pod" and swaps the pod stem everywhere it appears:</a:t>
-            </a:r>
-          </a:p>
-        </p:txBody>
-      </p:sp>
-      <p:sp>
-        <p:nvSpPr>
-          <p:cNvPr id="10" name="Rounded Rectangle 9"/>
-          <p:cNvSpPr/>
-          <p:nvPr/>
-        </p:nvSpPr>
-        <p:spPr>
-          <a:xfrm>
-            <a:off x="548640" y="2743200"/>
-            <a:ext cx="11064240" cy="2103120"/>
-          </a:xfrm>
-          <a:prstGeom prst="roundRect">
-            <a:avLst>
-              <a:gd name="adj" fmla="val 4000"/>
-            </a:avLst>
-          </a:prstGeom>
-          <a:solidFill>
-            <a:srgbClr val="282C34"/>
-          </a:solidFill>
-          <a:ln>
-            <a:solidFill>
-              <a:srgbClr val="111318"/>
-            </a:solidFill>
-          </a:ln>
-          <a:effectLst/>
-        </p:spPr>
-        <p:style>
-          <a:lnRef idx="1">
-            <a:schemeClr val="accent1"/>
-          </a:lnRef>
-          <a:fillRef idx="3">
-            <a:schemeClr val="accent1"/>
-          </a:fillRef>
-          <a:effectRef idx="2">
-            <a:schemeClr val="accent1"/>
-          </a:effectRef>
-          <a:fontRef idx="minor">
-            <a:schemeClr val="lt1"/>
-          </a:fontRef>
-        </p:style>
-        <p:txBody>
-          <a:bodyPr rtlCol="0" anchor="t" wrap="square" lIns="228600" rIns="228600" tIns="164592" bIns="164592"/>
-          <a:lstStyle/>
-          <a:p>
-            <a:pPr algn="l">
-              <a:spcAft>
-                <a:spcPts val="200"/>
-              </a:spcAft>
-            </a:pPr>
-            <a:r>
-              <a:rPr sz="1350">
-                <a:solidFill>
-                  <a:srgbClr val="E6E6E6"/>
-                </a:solidFill>
-                <a:latin typeface="Consolas"/>
-              </a:rPr>
-              <a:t>Converted pod not found yet -- creating it first: ...</a:t>
-            </a:r>
-          </a:p>
-          <a:p>
-            <a:pPr algn="l">
-              <a:spcAft>
-                <a:spcPts val="200"/>
-              </a:spcAft>
-            </a:pPr>
-            <a:r>
-              <a:rPr sz="1350">
-                <a:solidFill>
-                  <a:srgbClr val="E6E6E6"/>
-                </a:solidFill>
-                <a:latin typeface="Consolas"/>
-              </a:rPr>
-              <a:t>Wrote MyPod-AMC2_run_job.json  (SantaRosa -&gt; AMC2,</a:t>
-            </a:r>
-          </a:p>
-          <a:p>
-            <a:pPr algn="l">
-              <a:spcAft>
-                <a:spcPts val="200"/>
-              </a:spcAft>
-            </a:pPr>
-            <a:r>
-              <a:rPr sz="1350">
-                <a:solidFill>
-                  <a:srgbClr val="E6E6E6"/>
-                </a:solidFill>
-                <a:latin typeface="Consolas"/>
-              </a:rPr>
-              <a:t>  pod=MyPod-AMC2.pod)</a:t>
-            </a:r>
-          </a:p>
-          <a:p>
-            <a:pPr algn="l">
-              <a:spcAft>
-                <a:spcPts val="200"/>
-              </a:spcAft>
-            </a:pPr>
-            <a:r>
-              <a:rPr sz="1350">
-                <a:solidFill>
-                  <a:srgbClr val="E6E6E6"/>
-                </a:solidFill>
-                <a:latin typeface="Consolas"/>
-              </a:rPr>
-              <a:t>  This is a V2 run job -- also regenerate its plot</a:t>
-            </a:r>
-          </a:p>
-          <a:p>
-            <a:pPr algn="l">
-              <a:spcAft>
-                <a:spcPts val="200"/>
-              </a:spcAft>
-            </a:pPr>
-            <a:r>
-              <a:rPr sz="1350">
-                <a:solidFill>
-                  <a:srgbClr val="E6E6E6"/>
-                </a:solidFill>
-                <a:latin typeface="Consolas"/>
-              </a:rPr>
-              <a:t>  job(s) against the new pod:</a:t>
-            </a:r>
-          </a:p>
-          <a:p>
-            <a:pPr algn="l">
-              <a:spcAft>
-                <a:spcPts val="200"/>
-              </a:spcAft>
-            </a:pPr>
-            <a:r>
-              <a:rPr sz="1350">
-                <a:solidFill>
-                  <a:srgbClr val="E6E6E6"/>
-                </a:solidFill>
-                <a:latin typeface="Consolas"/>
-              </a:rPr>
-              <a:t>    py padb_make_v2_job.py MyPod-AMC2.pod --module &lt;YourModule&gt;</a:t>
-            </a:r>
-          </a:p>
-        </p:txBody>
-      </p:sp>
-      <p:sp>
-        <p:nvSpPr>
-          <p:cNvPr id="11" name="TextBox 10"/>
-          <p:cNvSpPr txBox="1"/>
-          <p:nvPr/>
-        </p:nvSpPr>
-        <p:spPr>
-          <a:xfrm>
-            <a:off x="548640" y="5074920"/>
-            <a:ext cx="11064240" cy="640080"/>
-          </a:xfrm>
-          <a:prstGeom prst="rect">
-            <a:avLst/>
-          </a:prstGeom>
-          <a:noFill/>
-        </p:spPr>
-        <p:txBody>
-          <a:bodyPr wrap="square">
-            <a:spAutoFit/>
-          </a:bodyPr>
-          <a:lstStyle/>
+              <a:t>•  A few of the 13 new-pod checklist items it surfaces immediately:</a:t>
+            </a:r>
+          </a:p>
+          <a:p>
+            <a:pPr lvl="1">
+              <a:spcAft>
+                <a:spcPts val="600"/>
+              </a:spcAft>
+            </a:pPr>
+            <a:r>
+              <a:rPr sz="1500">
+                <a:solidFill>
+                  <a:srgbClr val="555555"/>
+                </a:solidFill>
+                <a:latin typeface="Segoe UI"/>
+              </a:rPr>
+              <a:t>–  TestRun_RunStatus — exit 0 but no CSV? Check the pod's default 'P'-only filter</a:t>
+            </a:r>
+          </a:p>
+          <a:p>
+            <a:pPr lvl="1">
+              <a:spcAft>
+                <a:spcPts val="600"/>
+              </a:spcAft>
+            </a:pPr>
+            <a:r>
+              <a:rPr sz="1500">
+                <a:solidFill>
+                  <a:srgbClr val="555555"/>
+                </a:solidFill>
+                <a:latin typeface="Segoe UI"/>
+              </a:rPr>
+              <a:t>–  Environment_TestStep must be {All} or distribution/env_coverage/summary go empty</a:t>
+            </a:r>
+          </a:p>
+          <a:p>
+            <a:pPr lvl="1">
+              <a:spcAft>
+                <a:spcPts val="600"/>
+              </a:spcAft>
+            </a:pPr>
+            <a:r>
+              <a:rPr sz="1500">
+                <a:solidFill>
+                  <a:srgbClr val="555555"/>
+                </a:solidFill>
+                <a:latin typeface="Segoe UI"/>
+              </a:rPr>
+              <a:t>–  OutputConfig_OutputCSV=False on a Scatter analytic — renders PNG, writes no CSV</a:t>
+            </a:r>
+          </a:p>
+          <a:p>
+            <a:pPr lvl="1">
+              <a:spcAft>
+                <a:spcPts val="600"/>
+              </a:spcAft>
+            </a:pPr>
+            <a:r>
+              <a:rPr sz="1500">
+                <a:solidFill>
+                  <a:srgbClr val="555555"/>
+                </a:solidFill>
+                <a:latin typeface="Segoe UI"/>
+              </a:rPr>
+              <a:t>–  Generated job.json path length — warns before Windows' 260-char limit bites</a:t>
+            </a:r>
+          </a:p>
           <a:p>
             <a:pPr>
               <a:spcAft>
@@ -15936,29 +15558,29 @@
               </a:spcAft>
             </a:pPr>
             <a:r>
+              <a:rPr sz="1700">
+                <a:solidFill>
+                  <a:srgbClr val="1B2A4A"/>
+                </a:solidFill>
+                <a:latin typeface="Segoe UI"/>
+              </a:rPr>
+              <a:t>•  Plus: the architecture one-liner, common JS gotchas, and pointers to the</a:t>
+            </a:r>
+          </a:p>
+          <a:p>
+            <a:pPr lvl="1">
+              <a:spcAft>
+                <a:spcPts val="600"/>
+              </a:spcAft>
+            </a:pPr>
+            <a:r>
               <a:rPr sz="1500">
                 <a:solidFill>
-                  <a:srgbClr val="1B2A4A"/>
-                </a:solidFill>
-                <a:latin typeface="Segoe UI"/>
-              </a:rPr>
-              <a:t>•  Updates results_dir, publish/publish_to, and description too — not just "pod"</a:t>
-            </a:r>
-          </a:p>
-          <a:p>
-            <a:pPr>
-              <a:spcAft>
-                <a:spcPts val="1000"/>
-              </a:spcAft>
-            </a:pPr>
-            <a:r>
-              <a:rPr sz="1500">
-                <a:solidFill>
-                  <a:srgbClr val="1B2A4A"/>
-                </a:solidFill>
-                <a:latin typeface="Segoe UI"/>
-              </a:rPr>
-              <a:t>•  --force overwrites an existing output; --list-sites prints the registry</a:t>
+                  <a:srgbClr val="555555"/>
+                </a:solidFill>
+                <a:latin typeface="Segoe UI"/>
+              </a:rPr>
+              <a:t>–  full doc for anything it only summarizes</a:t>
             </a:r>
           </a:p>
         </p:txBody>
@@ -15996,7 +15618,7 @@
             <a:avLst/>
           </a:prstGeom>
           <a:solidFill>
-            <a:srgbClr val="1B2A4A"/>
+            <a:srgbClr val="FFFFFF"/>
           </a:solidFill>
           <a:ln>
             <a:noFill/>
@@ -16033,8 +15655,8 @@
         </p:nvSpPr>
         <p:spPr>
           <a:xfrm>
-            <a:off x="822960" y="2743200"/>
-            <a:ext cx="10515600" cy="1097280"/>
+            <a:off x="548640" y="320040"/>
+            <a:ext cx="7315200" cy="365760"/>
           </a:xfrm>
           <a:prstGeom prst="rect">
             <a:avLst/>
@@ -16048,14 +15670,15 @@
           <a:lstStyle/>
           <a:p>
             <a:pPr>
-              <a:defRPr sz="4800" b="1">
-                <a:solidFill>
-                  <a:srgbClr val="FFFFFF"/>
-                </a:solidFill>
+              <a:defRPr sz="1600" b="1">
+                <a:solidFill>
+                  <a:srgbClr val="0066CC"/>
+                </a:solidFill>
+                <a:latin typeface="Segoe UI"/>
               </a:defRPr>
             </a:pPr>
             <a:r>
-              <a:t>Questions?</a:t>
+              <a:t>Tutorial 3 — /padb-tools</a:t>
             </a:r>
           </a:p>
         </p:txBody>
@@ -16068,8 +15691,79 @@
         </p:nvSpPr>
         <p:spPr>
           <a:xfrm>
-            <a:off x="822960" y="3749039"/>
-            <a:ext cx="10515600" cy="640080"/>
+            <a:off x="548640" y="658368"/>
+            <a:ext cx="11064240" cy="822960"/>
+          </a:xfrm>
+          <a:prstGeom prst="rect">
+            <a:avLst/>
+          </a:prstGeom>
+          <a:noFill/>
+        </p:spPr>
+        <p:txBody>
+          <a:bodyPr wrap="square">
+            <a:spAutoFit/>
+          </a:bodyPr>
+          <a:lstStyle/>
+          <a:p>
+            <a:pPr>
+              <a:defRPr sz="3200" b="1">
+                <a:solidFill>
+                  <a:srgbClr val="1B2A4A"/>
+                </a:solidFill>
+                <a:latin typeface="Segoe UI"/>
+              </a:defRPr>
+            </a:pPr>
+            <a:r>
+              <a:t>Worked Example: MaxPowerTutorial3.pod</a:t>
+            </a:r>
+          </a:p>
+        </p:txBody>
+      </p:sp>
+      <p:cxnSp>
+        <p:nvCxnSpPr>
+          <p:cNvPr id="5" name="Connector 4"/>
+          <p:cNvCxnSpPr/>
+          <p:nvPr/>
+        </p:nvCxnSpPr>
+        <p:spPr>
+          <a:xfrm>
+            <a:off x="548640" y="1417320"/>
+            <a:ext cx="11091672" cy="0"/>
+          </a:xfrm>
+          <a:prstGeom prst="line">
+            <a:avLst/>
+          </a:prstGeom>
+          <a:ln w="28575">
+            <a:solidFill>
+              <a:srgbClr val="0066CC"/>
+            </a:solidFill>
+          </a:ln>
+        </p:spPr>
+        <p:style>
+          <a:lnRef idx="2">
+            <a:schemeClr val="accent1"/>
+          </a:lnRef>
+          <a:fillRef idx="0">
+            <a:schemeClr val="accent1"/>
+          </a:fillRef>
+          <a:effectRef idx="1">
+            <a:schemeClr val="accent1"/>
+          </a:effectRef>
+          <a:fontRef idx="minor">
+            <a:schemeClr val="tx1"/>
+          </a:fontRef>
+        </p:style>
+      </p:cxnSp>
+      <p:sp>
+        <p:nvSpPr>
+          <p:cNvPr id="6" name="TextBox 5"/>
+          <p:cNvSpPr txBox="1"/>
+          <p:nvPr/>
+        </p:nvSpPr>
+        <p:spPr>
+          <a:xfrm>
+            <a:off x="548640" y="6473952"/>
+            <a:ext cx="8229600" cy="320040"/>
           </a:xfrm>
           <a:prstGeom prst="rect">
             <a:avLst/>
@@ -16083,15 +15777,185 @@
           <a:lstStyle/>
           <a:p>
             <a:pPr>
-              <a:defRPr sz="1800">
-                <a:solidFill>
-                  <a:srgbClr val="9FC5FF"/>
-                </a:solidFill>
-                <a:latin typeface="Consolas"/>
+              <a:defRPr sz="1100">
+                <a:solidFill>
+                  <a:srgbClr val="555555"/>
+                </a:solidFill>
+                <a:latin typeface="Segoe UI"/>
               </a:defRPr>
             </a:pPr>
             <a:r>
-              <a:t>C:\apps\padb\tools   |   /padb-tools</a:t>
+              <a:t>padb-tools</a:t>
+            </a:r>
+          </a:p>
+        </p:txBody>
+      </p:sp>
+      <p:sp>
+        <p:nvSpPr>
+          <p:cNvPr id="7" name="TextBox 6"/>
+          <p:cNvSpPr txBox="1"/>
+          <p:nvPr/>
+        </p:nvSpPr>
+        <p:spPr>
+          <a:xfrm>
+            <a:off x="11338560" y="6473952"/>
+            <a:ext cx="548640" cy="320040"/>
+          </a:xfrm>
+          <a:prstGeom prst="rect">
+            <a:avLst/>
+          </a:prstGeom>
+          <a:noFill/>
+        </p:spPr>
+        <p:txBody>
+          <a:bodyPr wrap="none">
+            <a:spAutoFit/>
+          </a:bodyPr>
+          <a:lstStyle/>
+          <a:p>
+            <a:pPr algn="r">
+              <a:defRPr sz="1100">
+                <a:solidFill>
+                  <a:srgbClr val="555555"/>
+                </a:solidFill>
+              </a:defRPr>
+            </a:pPr>
+            <a:r>
+              <a:t>38</a:t>
+            </a:r>
+          </a:p>
+        </p:txBody>
+      </p:sp>
+      <p:sp>
+        <p:nvSpPr>
+          <p:cNvPr id="8" name="TextBox 7"/>
+          <p:cNvSpPr txBox="1"/>
+          <p:nvPr/>
+        </p:nvSpPr>
+        <p:spPr>
+          <a:xfrm>
+            <a:off x="548640" y="1645920"/>
+            <a:ext cx="11064240" cy="4754880"/>
+          </a:xfrm>
+          <a:prstGeom prst="rect">
+            <a:avLst/>
+          </a:prstGeom>
+          <a:noFill/>
+        </p:spPr>
+        <p:txBody>
+          <a:bodyPr wrap="square">
+            <a:spAutoFit/>
+          </a:bodyPr>
+          <a:lstStyle/>
+          <a:p>
+            <a:pPr>
+              <a:spcAft>
+                <a:spcPts val="1000"/>
+              </a:spcAft>
+            </a:pPr>
+            <a:r>
+              <a:rPr sz="1800">
+                <a:solidFill>
+                  <a:srgbClr val="1B2A4A"/>
+                </a:solidFill>
+                <a:latin typeface="Segoe UI"/>
+              </a:rPr>
+              <a:t>•  You've just been handed MaxPowerTutorial3.pod — 2 analytics, never run before</a:t>
+            </a:r>
+          </a:p>
+          <a:p>
+            <a:pPr>
+              <a:spcAft>
+                <a:spcPts val="1000"/>
+              </a:spcAft>
+            </a:pPr>
+            <a:r>
+              <a:rPr sz="1800">
+                <a:solidFill>
+                  <a:srgbClr val="1B2A4A"/>
+                </a:solidFill>
+                <a:latin typeface="Segoe UI"/>
+              </a:rPr>
+              <a:t>•  Open Claude Code with your working directory inside the padb-tools repo</a:t>
+            </a:r>
+          </a:p>
+          <a:p>
+            <a:pPr>
+              <a:spcAft>
+                <a:spcPts val="1000"/>
+              </a:spcAft>
+            </a:pPr>
+            <a:r>
+              <a:rPr sz="1800">
+                <a:solidFill>
+                  <a:srgbClr val="1B2A4A"/>
+                </a:solidFill>
+                <a:latin typeface="Segoe UI"/>
+              </a:rPr>
+              <a:t>•  Type: /padb-tools</a:t>
+            </a:r>
+          </a:p>
+          <a:p>
+            <a:pPr>
+              <a:spcAft>
+                <a:spcPts val="1000"/>
+              </a:spcAft>
+            </a:pPr>
+            <a:r>
+              <a:rPr sz="1800">
+                <a:solidFill>
+                  <a:srgbClr val="1B2A4A"/>
+                </a:solidFill>
+                <a:latin typeface="Segoe UI"/>
+              </a:rPr>
+              <a:t>•  Ask directly: "Is MaxPowerTutorial3.pod ready to run in Interactive mode?"</a:t>
+            </a:r>
+          </a:p>
+          <a:p>
+            <a:pPr>
+              <a:spcAft>
+                <a:spcPts val="1000"/>
+              </a:spcAft>
+            </a:pPr>
+            <a:r>
+              <a:rPr sz="1800">
+                <a:solidFill>
+                  <a:srgbClr val="1B2A4A"/>
+                </a:solidFill>
+                <a:latin typeface="Segoe UI"/>
+              </a:rPr>
+              <a:t>•  Claude reads the checklist above, then actually inspects the pod file —</a:t>
+            </a:r>
+          </a:p>
+          <a:p>
+            <a:pPr lvl="1">
+              <a:spcAft>
+                <a:spcPts val="600"/>
+              </a:spcAft>
+            </a:pPr>
+            <a:r>
+              <a:rPr sz="1600">
+                <a:solidFill>
+                  <a:srgbClr val="555555"/>
+                </a:solidFill>
+                <a:latin typeface="Segoe UI"/>
+              </a:rPr>
+              <a:t>–  Limits_YLimit, Environment_TestStep, OutputConfig_OutputCSV, Group strings</a:t>
+            </a:r>
+          </a:p>
+          <a:p>
+            <a:pPr>
+              <a:spcAft>
+                <a:spcPts val="1000"/>
+              </a:spcAft>
+            </a:pPr>
+            <a:r>
+              <a:rPr sz="1800">
+                <a:solidFill>
+                  <a:srgbClr val="1B2A4A"/>
+                </a:solidFill>
+                <a:latin typeface="Segoe UI"/>
+              </a:rPr>
+              <a:t>•  You get a direct answer grounded in this pod's real settings, not a guess</a:t>
             </a:r>
           </a:p>
         </p:txBody>
@@ -16129,7 +15993,7 @@
             <a:avLst/>
           </a:prstGeom>
           <a:solidFill>
-            <a:srgbClr val="F2F4F8"/>
+            <a:srgbClr val="FFFFFF"/>
           </a:solidFill>
           <a:ln>
             <a:noFill/>
@@ -16166,8 +16030,8 @@
         </p:nvSpPr>
         <p:spPr>
           <a:xfrm>
-            <a:off x="822960" y="2743200"/>
-            <a:ext cx="10515600" cy="914400"/>
+            <a:off x="548640" y="320040"/>
+            <a:ext cx="7315200" cy="365760"/>
           </a:xfrm>
           <a:prstGeom prst="rect">
             <a:avLst/>
@@ -16181,28 +16045,100 @@
           <a:lstStyle/>
           <a:p>
             <a:pPr>
-              <a:defRPr sz="4400" b="1">
+              <a:defRPr sz="1600" b="1">
+                <a:solidFill>
+                  <a:srgbClr val="0066CC"/>
+                </a:solidFill>
+                <a:latin typeface="Segoe UI"/>
+              </a:defRPr>
+            </a:pPr>
+            <a:r>
+              <a:t>Multi-Site Testing</a:t>
+            </a:r>
+          </a:p>
+        </p:txBody>
+      </p:sp>
+      <p:sp>
+        <p:nvSpPr>
+          <p:cNvPr id="4" name="TextBox 3"/>
+          <p:cNvSpPr txBox="1"/>
+          <p:nvPr/>
+        </p:nvSpPr>
+        <p:spPr>
+          <a:xfrm>
+            <a:off x="548640" y="658368"/>
+            <a:ext cx="11064240" cy="822960"/>
+          </a:xfrm>
+          <a:prstGeom prst="rect">
+            <a:avLst/>
+          </a:prstGeom>
+          <a:noFill/>
+        </p:spPr>
+        <p:txBody>
+          <a:bodyPr wrap="square">
+            <a:spAutoFit/>
+          </a:bodyPr>
+          <a:lstStyle/>
+          <a:p>
+            <a:pPr>
+              <a:defRPr sz="3200" b="1">
                 <a:solidFill>
                   <a:srgbClr val="1B2A4A"/>
                 </a:solidFill>
+                <a:latin typeface="Segoe UI"/>
               </a:defRPr>
             </a:pPr>
             <a:r>
-              <a:t>Appendix</a:t>
-            </a:r>
-          </a:p>
-        </p:txBody>
-      </p:sp>
-      <p:sp>
-        <p:nvSpPr>
-          <p:cNvPr id="4" name="TextBox 3"/>
-          <p:cNvSpPr txBox="1"/>
-          <p:nvPr/>
-        </p:nvSpPr>
-        <p:spPr>
-          <a:xfrm>
-            <a:off x="822960" y="3566160"/>
-            <a:ext cx="10515600" cy="640080"/>
+              <a:t>Same Test, Different Database</a:t>
+            </a:r>
+          </a:p>
+        </p:txBody>
+      </p:sp>
+      <p:cxnSp>
+        <p:nvCxnSpPr>
+          <p:cNvPr id="5" name="Connector 4"/>
+          <p:cNvCxnSpPr/>
+          <p:nvPr/>
+        </p:nvCxnSpPr>
+        <p:spPr>
+          <a:xfrm>
+            <a:off x="548640" y="1417320"/>
+            <a:ext cx="11091672" cy="0"/>
+          </a:xfrm>
+          <a:prstGeom prst="line">
+            <a:avLst/>
+          </a:prstGeom>
+          <a:ln w="28575">
+            <a:solidFill>
+              <a:srgbClr val="0066CC"/>
+            </a:solidFill>
+          </a:ln>
+        </p:spPr>
+        <p:style>
+          <a:lnRef idx="2">
+            <a:schemeClr val="accent1"/>
+          </a:lnRef>
+          <a:fillRef idx="0">
+            <a:schemeClr val="accent1"/>
+          </a:fillRef>
+          <a:effectRef idx="1">
+            <a:schemeClr val="accent1"/>
+          </a:effectRef>
+          <a:fontRef idx="minor">
+            <a:schemeClr val="tx1"/>
+          </a:fontRef>
+        </p:style>
+      </p:cxnSp>
+      <p:sp>
+        <p:nvSpPr>
+          <p:cNvPr id="6" name="TextBox 5"/>
+          <p:cNvSpPr txBox="1"/>
+          <p:nvPr/>
+        </p:nvSpPr>
+        <p:spPr>
+          <a:xfrm>
+            <a:off x="548640" y="6473952"/>
+            <a:ext cx="8229600" cy="320040"/>
           </a:xfrm>
           <a:prstGeom prst="rect">
             <a:avLst/>
@@ -16216,14 +16152,217 @@
           <a:lstStyle/>
           <a:p>
             <a:pPr>
-              <a:defRPr sz="2200">
-                <a:solidFill>
-                  <a:srgbClr val="0066CC"/>
-                </a:solidFill>
+              <a:defRPr sz="1100">
+                <a:solidFill>
+                  <a:srgbClr val="555555"/>
+                </a:solidFill>
+                <a:latin typeface="Segoe UI"/>
               </a:defRPr>
             </a:pPr>
             <a:r>
-              <a:t>Setting Up From Zero — Assumes No Prior Access</a:t>
+              <a:t>padb-tools</a:t>
+            </a:r>
+          </a:p>
+        </p:txBody>
+      </p:sp>
+      <p:sp>
+        <p:nvSpPr>
+          <p:cNvPr id="7" name="TextBox 6"/>
+          <p:cNvSpPr txBox="1"/>
+          <p:nvPr/>
+        </p:nvSpPr>
+        <p:spPr>
+          <a:xfrm>
+            <a:off x="11338560" y="6473952"/>
+            <a:ext cx="548640" cy="320040"/>
+          </a:xfrm>
+          <a:prstGeom prst="rect">
+            <a:avLst/>
+          </a:prstGeom>
+          <a:noFill/>
+        </p:spPr>
+        <p:txBody>
+          <a:bodyPr wrap="none">
+            <a:spAutoFit/>
+          </a:bodyPr>
+          <a:lstStyle/>
+          <a:p>
+            <a:pPr algn="r">
+              <a:defRPr sz="1100">
+                <a:solidFill>
+                  <a:srgbClr val="555555"/>
+                </a:solidFill>
+              </a:defRPr>
+            </a:pPr>
+            <a:r>
+              <a:t>39</a:t>
+            </a:r>
+          </a:p>
+        </p:txBody>
+      </p:sp>
+      <p:sp>
+        <p:nvSpPr>
+          <p:cNvPr id="8" name="TextBox 7"/>
+          <p:cNvSpPr txBox="1"/>
+          <p:nvPr/>
+        </p:nvSpPr>
+        <p:spPr>
+          <a:xfrm>
+            <a:off x="548640" y="1645920"/>
+            <a:ext cx="11064240" cy="4754880"/>
+          </a:xfrm>
+          <a:prstGeom prst="rect">
+            <a:avLst/>
+          </a:prstGeom>
+          <a:noFill/>
+        </p:spPr>
+        <p:txBody>
+          <a:bodyPr wrap="square">
+            <a:spAutoFit/>
+          </a:bodyPr>
+          <a:lstStyle/>
+          <a:p>
+            <a:pPr>
+              <a:spcAft>
+                <a:spcPts val="1000"/>
+              </a:spcAft>
+            </a:pPr>
+            <a:r>
+              <a:rPr sz="1700">
+                <a:solidFill>
+                  <a:srgbClr val="1B2A4A"/>
+                </a:solidFill>
+                <a:latin typeface="Segoe UI"/>
+              </a:rPr>
+              <a:t>•  Malaysia (AMC2) production ramp-up: the same test now also pulls from</a:t>
+            </a:r>
+          </a:p>
+          <a:p>
+            <a:pPr lvl="1">
+              <a:spcAft>
+                <a:spcPts val="600"/>
+              </a:spcAft>
+            </a:pPr>
+            <a:r>
+              <a:rPr sz="1500">
+                <a:solidFill>
+                  <a:srgbClr val="555555"/>
+                </a:solidFill>
+                <a:latin typeface="Segoe UI"/>
+              </a:rPr>
+              <a:t>–  AMC2's own PADB Oracle database, not just Santa Rosa's</a:t>
+            </a:r>
+          </a:p>
+          <a:p>
+            <a:pPr>
+              <a:spcAft>
+                <a:spcPts val="1000"/>
+              </a:spcAft>
+            </a:pPr>
+            <a:r>
+              <a:rPr sz="1700">
+                <a:solidFill>
+                  <a:srgbClr val="1B2A4A"/>
+                </a:solidFill>
+                <a:latin typeface="Segoe UI"/>
+              </a:rPr>
+              <a:t>•  Comparing a real Santa Rosa pod against its AMC2 counterpart: the only</a:t>
+            </a:r>
+          </a:p>
+          <a:p>
+            <a:pPr lvl="1">
+              <a:spcAft>
+                <a:spcPts val="600"/>
+              </a:spcAft>
+            </a:pPr>
+            <a:r>
+              <a:rPr sz="1500">
+                <a:solidFill>
+                  <a:srgbClr val="555555"/>
+                </a:solidFill>
+                <a:latin typeface="Segoe UI"/>
+              </a:rPr>
+              <a:t>–  genuine differences are Device_Server and Device_Database in [Extract]</a:t>
+            </a:r>
+          </a:p>
+          <a:p>
+            <a:pPr>
+              <a:spcAft>
+                <a:spcPts val="1000"/>
+              </a:spcAft>
+            </a:pPr>
+            <a:r>
+              <a:rPr sz="1700">
+                <a:solidFill>
+                  <a:srgbClr val="1B2A4A"/>
+                </a:solidFill>
+                <a:latin typeface="Segoe UI"/>
+              </a:rPr>
+              <a:t>•  Every AnalyticName and OutputConfig_OutputFile is otherwise identical —</a:t>
+            </a:r>
+          </a:p>
+          <a:p>
+            <a:pPr lvl="1">
+              <a:spcAft>
+                <a:spcPts val="600"/>
+              </a:spcAft>
+            </a:pPr>
+            <a:r>
+              <a:rPr sz="1500">
+                <a:solidFill>
+                  <a:srgbClr val="555555"/>
+                </a:solidFill>
+                <a:latin typeface="Segoe UI"/>
+              </a:rPr>
+              <a:t>–  running both site variants writes identically-named CSVs</a:t>
+            </a:r>
+          </a:p>
+          <a:p>
+            <a:pPr>
+              <a:spcAft>
+                <a:spcPts val="1000"/>
+              </a:spcAft>
+            </a:pPr>
+            <a:r>
+              <a:rPr sz="1700">
+                <a:solidFill>
+                  <a:srgbClr val="1B2A4A"/>
+                </a:solidFill>
+                <a:latin typeface="Segoe UI"/>
+              </a:rPr>
+              <a:t>•  Risk: point both at a shared results/publish location and one silently</a:t>
+            </a:r>
+          </a:p>
+          <a:p>
+            <a:pPr lvl="1">
+              <a:spcAft>
+                <a:spcPts val="600"/>
+              </a:spcAft>
+            </a:pPr>
+            <a:r>
+              <a:rPr sz="1500">
+                <a:solidFill>
+                  <a:srgbClr val="555555"/>
+                </a:solidFill>
+                <a:latin typeface="Segoe UI"/>
+              </a:rPr>
+              <a:t>–  overwrites the other — same class of problem unique_output_filenames</a:t>
+            </a:r>
+          </a:p>
+          <a:p>
+            <a:pPr lvl="1">
+              <a:spcAft>
+                <a:spcPts val="600"/>
+              </a:spcAft>
+            </a:pPr>
+            <a:r>
+              <a:rPr sz="1500">
+                <a:solidFill>
+                  <a:srgbClr val="555555"/>
+                </a:solidFill>
+                <a:latin typeface="Segoe UI"/>
+              </a:rPr>
+              <a:t>–  solves within one pod, but across two site-variant pods instead</a:t>
             </a:r>
           </a:p>
         </p:txBody>
@@ -17125,7 +17264,7 @@
               </a:defRPr>
             </a:pPr>
             <a:r>
-              <a:t>Appendix</a:t>
+              <a:t>Multi-Site Testing</a:t>
             </a:r>
           </a:p>
         </p:txBody>
@@ -17161,7 +17300,7 @@
               </a:defRPr>
             </a:pPr>
             <a:r>
-              <a:t>Getting the Code</a:t>
+              <a:t>padb_convert_site.py — Converting a Pod</a:t>
             </a:r>
           </a:p>
         </p:txBody>
@@ -17267,7 +17406,7 @@
               </a:defRPr>
             </a:pPr>
             <a:r>
-              <a:t>39</a:t>
+              <a:t>40</a:t>
             </a:r>
           </a:p>
         </p:txBody>
@@ -17280,7 +17419,7 @@
         </p:nvSpPr>
         <p:spPr>
           <a:xfrm>
-            <a:off x="548640" y="1691640"/>
+            <a:off x="548640" y="1600200"/>
             <a:ext cx="11064240" cy="365760"/>
           </a:xfrm>
           <a:prstGeom prst="rect">
@@ -17300,13 +17439,13 @@
               </a:spcAft>
             </a:pPr>
             <a:r>
-              <a:rPr sz="1900">
+              <a:rPr sz="1600">
                 <a:solidFill>
                   <a:srgbClr val="1B2A4A"/>
                 </a:solidFill>
                 <a:latin typeface="Segoe UI"/>
               </a:rPr>
-              <a:t>•  This repo isn't on a company-wide share by default — copy it from:</a:t>
+              <a:t>•  Site registry lives in padb_sites.json — add a new site there, no code changes:</a:t>
             </a:r>
           </a:p>
         </p:txBody>
@@ -17319,7 +17458,7 @@
         </p:nvSpPr>
         <p:spPr>
           <a:xfrm>
-            <a:off x="548640" y="2103120"/>
+            <a:off x="548640" y="1965960"/>
             <a:ext cx="11064240" cy="502920"/>
           </a:xfrm>
           <a:prstGeom prst="roundRect">
@@ -17361,27 +17500,184 @@
               </a:spcAft>
             </a:pPr>
             <a:r>
+              <a:rPr sz="1450">
+                <a:solidFill>
+                  <a:srgbClr val="E6E6E6"/>
+                </a:solidFill>
+                <a:latin typeface="Consolas"/>
+              </a:rPr>
+              <a:t>py padb_convert_site.py --pod MyPod.pod --to AMC2</a:t>
+            </a:r>
+          </a:p>
+        </p:txBody>
+      </p:sp>
+      <p:sp>
+        <p:nvSpPr>
+          <p:cNvPr id="10" name="Rounded Rectangle 9"/>
+          <p:cNvSpPr/>
+          <p:nvPr/>
+        </p:nvSpPr>
+        <p:spPr>
+          <a:xfrm>
+            <a:off x="548640" y="2606040"/>
+            <a:ext cx="11064240" cy="2286000"/>
+          </a:xfrm>
+          <a:prstGeom prst="roundRect">
+            <a:avLst>
+              <a:gd name="adj" fmla="val 4000"/>
+            </a:avLst>
+          </a:prstGeom>
+          <a:solidFill>
+            <a:srgbClr val="282C34"/>
+          </a:solidFill>
+          <a:ln>
+            <a:solidFill>
+              <a:srgbClr val="111318"/>
+            </a:solidFill>
+          </a:ln>
+          <a:effectLst/>
+        </p:spPr>
+        <p:style>
+          <a:lnRef idx="1">
+            <a:schemeClr val="accent1"/>
+          </a:lnRef>
+          <a:fillRef idx="3">
+            <a:schemeClr val="accent1"/>
+          </a:fillRef>
+          <a:effectRef idx="2">
+            <a:schemeClr val="accent1"/>
+          </a:effectRef>
+          <a:fontRef idx="minor">
+            <a:schemeClr val="lt1"/>
+          </a:fontRef>
+        </p:style>
+        <p:txBody>
+          <a:bodyPr rtlCol="0" anchor="t" wrap="square" lIns="228600" rIns="228600" tIns="164592" bIns="164592"/>
+          <a:lstStyle/>
+          <a:p>
+            <a:pPr algn="l">
+              <a:spcAft>
+                <a:spcPts val="200"/>
+              </a:spcAft>
+            </a:pPr>
+            <a:r>
               <a:rPr sz="1350">
                 <a:solidFill>
                   <a:srgbClr val="E6E6E6"/>
                 </a:solidFill>
                 <a:latin typeface="Consolas"/>
               </a:rPr>
-              <a:t>\\srsnas01.srs.is.keysight.com\prod\MIDRF3\SG6311A\Padb-tools\tools</a:t>
-            </a:r>
-          </a:p>
-        </p:txBody>
-      </p:sp>
-      <p:sp>
-        <p:nvSpPr>
-          <p:cNvPr id="10" name="TextBox 9"/>
-          <p:cNvSpPr txBox="1"/>
-          <p:nvPr/>
-        </p:nvSpPr>
-        <p:spPr>
-          <a:xfrm>
-            <a:off x="548640" y="2788920"/>
-            <a:ext cx="11064240" cy="365760"/>
+              <a:t>Wrote MyPod-AMC2.pod  (SantaRosa -&gt; AMC2)</a:t>
+            </a:r>
+          </a:p>
+          <a:p>
+            <a:pPr algn="l">
+              <a:spcAft>
+                <a:spcPts val="200"/>
+              </a:spcAft>
+            </a:pPr>
+            <a:r>
+              <a:rPr sz="1350">
+                <a:solidFill>
+                  <a:srgbClr val="E6E6E6"/>
+                </a:solidFill>
+                <a:latin typeface="Consolas"/>
+              </a:rPr>
+              <a:t>  Device_Server -&gt; PADB ORACLE AMC2</a:t>
+            </a:r>
+          </a:p>
+          <a:p>
+            <a:pPr algn="l">
+              <a:spcAft>
+                <a:spcPts val="200"/>
+              </a:spcAft>
+            </a:pPr>
+            <a:r>
+              <a:rPr sz="1350">
+                <a:solidFill>
+                  <a:srgbClr val="E6E6E6"/>
+                </a:solidFill>
+                <a:latin typeface="Consolas"/>
+              </a:rPr>
+              <a:t>  Device_Database -&gt; GALLEON_1</a:t>
+            </a:r>
+          </a:p>
+          <a:p>
+            <a:pPr algn="l">
+              <a:spcAft>
+                <a:spcPts val="200"/>
+              </a:spcAft>
+            </a:pPr>
+            <a:r>
+              <a:rPr sz="1350">
+                <a:solidFill>
+                  <a:srgbClr val="E6E6E6"/>
+                </a:solidFill>
+                <a:latin typeface="Consolas"/>
+              </a:rPr>
+              <a:t>  AnalyticName 'Leveled Linear' -&gt; 'Leveled Linear AMC2'</a:t>
+            </a:r>
+          </a:p>
+          <a:p>
+            <a:pPr algn="l">
+              <a:spcAft>
+                <a:spcPts val="200"/>
+              </a:spcAft>
+            </a:pPr>
+            <a:r>
+              <a:rPr sz="1350">
+                <a:solidFill>
+                  <a:srgbClr val="E6E6E6"/>
+                </a:solidFill>
+                <a:latin typeface="Consolas"/>
+              </a:rPr>
+              <a:t>  OutputConfig_OutputFile '..._Linear' -&gt; '..._Linear_AMC2'</a:t>
+            </a:r>
+          </a:p>
+          <a:p>
+            <a:pPr algn="l">
+              <a:spcAft>
+                <a:spcPts val="200"/>
+              </a:spcAft>
+            </a:pPr>
+            <a:r>
+              <a:rPr sz="1350">
+                <a:solidFill>
+                  <a:srgbClr val="E6E6E6"/>
+                </a:solidFill>
+                <a:latin typeface="Consolas"/>
+              </a:rPr>
+              <a:t>  WARNING: SaoFile now points at 'MyPod-AMC2.sao', which does not</a:t>
+            </a:r>
+          </a:p>
+          <a:p>
+            <a:pPr algn="l">
+              <a:spcAft>
+                <a:spcPts val="200"/>
+              </a:spcAft>
+            </a:pPr>
+            <a:r>
+              <a:rPr sz="1350">
+                <a:solidFill>
+                  <a:srgbClr val="E6E6E6"/>
+                </a:solidFill>
+                <a:latin typeface="Consolas"/>
+              </a:rPr>
+              <a:t>  exist yet -- supply a real .sao extracted at AMC2 before running</a:t>
+            </a:r>
+          </a:p>
+        </p:txBody>
+      </p:sp>
+      <p:sp>
+        <p:nvSpPr>
+          <p:cNvPr id="11" name="TextBox 10"/>
+          <p:cNvSpPr txBox="1"/>
+          <p:nvPr/>
+        </p:nvSpPr>
+        <p:spPr>
+          <a:xfrm>
+            <a:off x="548640" y="5074920"/>
+            <a:ext cx="11064240" cy="640080"/>
           </a:xfrm>
           <a:prstGeom prst="rect">
             <a:avLst/>
@@ -17400,52 +17696,13 @@
               </a:spcAft>
             </a:pPr>
             <a:r>
-              <a:rPr sz="1800">
+              <a:rPr sz="1500">
                 <a:solidFill>
                   <a:srgbClr val="1B2A4A"/>
                 </a:solidFill>
                 <a:latin typeface="Segoe UI"/>
               </a:rPr>
-              <a:t>•  Copy that whole "tools" folder to a local path, e.g. C:\apps\padb\tools</a:t>
-            </a:r>
-          </a:p>
-        </p:txBody>
-      </p:sp>
-      <p:sp>
-        <p:nvSpPr>
-          <p:cNvPr id="11" name="TextBox 10"/>
-          <p:cNvSpPr txBox="1"/>
-          <p:nvPr/>
-        </p:nvSpPr>
-        <p:spPr>
-          <a:xfrm>
-            <a:off x="548640" y="3429000"/>
-            <a:ext cx="11064240" cy="914400"/>
-          </a:xfrm>
-          <a:prstGeom prst="rect">
-            <a:avLst/>
-          </a:prstGeom>
-          <a:noFill/>
-        </p:spPr>
-        <p:txBody>
-          <a:bodyPr wrap="square">
-            <a:spAutoFit/>
-          </a:bodyPr>
-          <a:lstStyle/>
-          <a:p>
-            <a:pPr>
-              <a:spcAft>
-                <a:spcPts val="1000"/>
-              </a:spcAft>
-            </a:pPr>
-            <a:r>
-              <a:rPr sz="1700">
-                <a:solidFill>
-                  <a:srgbClr val="1B2A4A"/>
-                </a:solidFill>
-                <a:latin typeface="Segoe UI"/>
-              </a:rPr>
-              <a:t>•  padb_batch.py is bundled directly inside the tools folder (added 2026-08-05) —</a:t>
+              <a:t>•  Source pod is never touched. Round-trip verified byte-identical</a:t>
             </a:r>
           </a:p>
           <a:p>
@@ -17455,52 +17712,13 @@
               </a:spcAft>
             </a:pPr>
             <a:r>
-              <a:rPr sz="1500">
+              <a:rPr sz="1300">
                 <a:solidFill>
                   <a:srgbClr val="555555"/>
                 </a:solidFill>
                 <a:latin typeface="Segoe UI"/>
               </a:rPr>
-              <a:t>–  no separate dependency to track down; the whole repo is self-contained</a:t>
-            </a:r>
-          </a:p>
-        </p:txBody>
-      </p:sp>
-      <p:sp>
-        <p:nvSpPr>
-          <p:cNvPr id="12" name="TextBox 11"/>
-          <p:cNvSpPr txBox="1"/>
-          <p:nvPr/>
-        </p:nvSpPr>
-        <p:spPr>
-          <a:xfrm>
-            <a:off x="548640" y="4480560"/>
-            <a:ext cx="11064240" cy="457200"/>
-          </a:xfrm>
-          <a:prstGeom prst="rect">
-            <a:avLst/>
-          </a:prstGeom>
-          <a:noFill/>
-        </p:spPr>
-        <p:txBody>
-          <a:bodyPr wrap="square">
-            <a:spAutoFit/>
-          </a:bodyPr>
-          <a:lstStyle/>
-          <a:p>
-            <a:pPr>
-              <a:spcAft>
-                <a:spcPts val="1000"/>
-              </a:spcAft>
-            </a:pPr>
-            <a:r>
-              <a:rPr sz="1650">
-                <a:solidFill>
-                  <a:srgbClr val="1B2A4A"/>
-                </a:solidFill>
-                <a:latin typeface="Segoe UI"/>
-              </a:rPr>
-              <a:t>•  Then follow the Prerequisites and Per-User Config slides earlier in this deck</a:t>
+              <a:t>–  (SantaRosa -&gt; AMC2 -&gt; SantaRosa reproduces the original exactly)</a:t>
             </a:r>
           </a:p>
         </p:txBody>
@@ -17598,7 +17816,7 @@
               </a:defRPr>
             </a:pPr>
             <a:r>
-              <a:t>Appendix</a:t>
+              <a:t>Multi-Site Testing</a:t>
             </a:r>
           </a:p>
         </p:txBody>
@@ -17634,7 +17852,7 @@
               </a:defRPr>
             </a:pPr>
             <a:r>
-              <a:t>First Commands to Verify Your Setup</a:t>
+              <a:t>padb_convert_site.py — Converting a Job</a:t>
             </a:r>
           </a:p>
         </p:txBody>
@@ -17740,7 +17958,1281 @@
               </a:defRPr>
             </a:pPr>
             <a:r>
-              <a:t>40</a:t>
+              <a:t>41</a:t>
+            </a:r>
+          </a:p>
+        </p:txBody>
+      </p:sp>
+      <p:sp>
+        <p:nvSpPr>
+          <p:cNvPr id="8" name="Rounded Rectangle 7"/>
+          <p:cNvSpPr/>
+          <p:nvPr/>
+        </p:nvSpPr>
+        <p:spPr>
+          <a:xfrm>
+            <a:off x="548640" y="1691640"/>
+            <a:ext cx="11064240" cy="502920"/>
+          </a:xfrm>
+          <a:prstGeom prst="roundRect">
+            <a:avLst>
+              <a:gd name="adj" fmla="val 4000"/>
+            </a:avLst>
+          </a:prstGeom>
+          <a:solidFill>
+            <a:srgbClr val="282C34"/>
+          </a:solidFill>
+          <a:ln>
+            <a:solidFill>
+              <a:srgbClr val="111318"/>
+            </a:solidFill>
+          </a:ln>
+          <a:effectLst/>
+        </p:spPr>
+        <p:style>
+          <a:lnRef idx="1">
+            <a:schemeClr val="accent1"/>
+          </a:lnRef>
+          <a:fillRef idx="3">
+            <a:schemeClr val="accent1"/>
+          </a:fillRef>
+          <a:effectRef idx="2">
+            <a:schemeClr val="accent1"/>
+          </a:effectRef>
+          <a:fontRef idx="minor">
+            <a:schemeClr val="lt1"/>
+          </a:fontRef>
+        </p:style>
+        <p:txBody>
+          <a:bodyPr rtlCol="0" anchor="t" wrap="square" lIns="228600" rIns="228600" tIns="164592" bIns="164592"/>
+          <a:lstStyle/>
+          <a:p>
+            <a:pPr algn="l">
+              <a:spcAft>
+                <a:spcPts val="200"/>
+              </a:spcAft>
+            </a:pPr>
+            <a:r>
+              <a:rPr sz="1450">
+                <a:solidFill>
+                  <a:srgbClr val="E6E6E6"/>
+                </a:solidFill>
+                <a:latin typeface="Consolas"/>
+              </a:rPr>
+              <a:t>py padb_convert_site.py --job my_run_job.json --to AMC2</a:t>
+            </a:r>
+          </a:p>
+        </p:txBody>
+      </p:sp>
+      <p:sp>
+        <p:nvSpPr>
+          <p:cNvPr id="9" name="TextBox 8"/>
+          <p:cNvSpPr txBox="1"/>
+          <p:nvPr/>
+        </p:nvSpPr>
+        <p:spPr>
+          <a:xfrm>
+            <a:off x="548640" y="2377440"/>
+            <a:ext cx="11064240" cy="365760"/>
+          </a:xfrm>
+          <a:prstGeom prst="rect">
+            <a:avLst/>
+          </a:prstGeom>
+          <a:noFill/>
+        </p:spPr>
+        <p:txBody>
+          <a:bodyPr wrap="square">
+            <a:spAutoFit/>
+          </a:bodyPr>
+          <a:lstStyle/>
+          <a:p>
+            <a:pPr>
+              <a:spcAft>
+                <a:spcPts val="1000"/>
+              </a:spcAft>
+            </a:pPr>
+            <a:r>
+              <a:rPr sz="1700">
+                <a:solidFill>
+                  <a:srgbClr val="1B2A4A"/>
+                </a:solidFill>
+                <a:latin typeface="Segoe UI"/>
+              </a:rPr>
+              <a:t>•  Repoints "pod" and swaps the pod stem everywhere it appears:</a:t>
+            </a:r>
+          </a:p>
+        </p:txBody>
+      </p:sp>
+      <p:sp>
+        <p:nvSpPr>
+          <p:cNvPr id="10" name="Rounded Rectangle 9"/>
+          <p:cNvSpPr/>
+          <p:nvPr/>
+        </p:nvSpPr>
+        <p:spPr>
+          <a:xfrm>
+            <a:off x="548640" y="2743200"/>
+            <a:ext cx="11064240" cy="2103120"/>
+          </a:xfrm>
+          <a:prstGeom prst="roundRect">
+            <a:avLst>
+              <a:gd name="adj" fmla="val 4000"/>
+            </a:avLst>
+          </a:prstGeom>
+          <a:solidFill>
+            <a:srgbClr val="282C34"/>
+          </a:solidFill>
+          <a:ln>
+            <a:solidFill>
+              <a:srgbClr val="111318"/>
+            </a:solidFill>
+          </a:ln>
+          <a:effectLst/>
+        </p:spPr>
+        <p:style>
+          <a:lnRef idx="1">
+            <a:schemeClr val="accent1"/>
+          </a:lnRef>
+          <a:fillRef idx="3">
+            <a:schemeClr val="accent1"/>
+          </a:fillRef>
+          <a:effectRef idx="2">
+            <a:schemeClr val="accent1"/>
+          </a:effectRef>
+          <a:fontRef idx="minor">
+            <a:schemeClr val="lt1"/>
+          </a:fontRef>
+        </p:style>
+        <p:txBody>
+          <a:bodyPr rtlCol="0" anchor="t" wrap="square" lIns="228600" rIns="228600" tIns="164592" bIns="164592"/>
+          <a:lstStyle/>
+          <a:p>
+            <a:pPr algn="l">
+              <a:spcAft>
+                <a:spcPts val="200"/>
+              </a:spcAft>
+            </a:pPr>
+            <a:r>
+              <a:rPr sz="1350">
+                <a:solidFill>
+                  <a:srgbClr val="E6E6E6"/>
+                </a:solidFill>
+                <a:latin typeface="Consolas"/>
+              </a:rPr>
+              <a:t>Converted pod not found yet -- creating it first: ...</a:t>
+            </a:r>
+          </a:p>
+          <a:p>
+            <a:pPr algn="l">
+              <a:spcAft>
+                <a:spcPts val="200"/>
+              </a:spcAft>
+            </a:pPr>
+            <a:r>
+              <a:rPr sz="1350">
+                <a:solidFill>
+                  <a:srgbClr val="E6E6E6"/>
+                </a:solidFill>
+                <a:latin typeface="Consolas"/>
+              </a:rPr>
+              <a:t>Wrote MyPod-AMC2_run_job.json  (SantaRosa -&gt; AMC2,</a:t>
+            </a:r>
+          </a:p>
+          <a:p>
+            <a:pPr algn="l">
+              <a:spcAft>
+                <a:spcPts val="200"/>
+              </a:spcAft>
+            </a:pPr>
+            <a:r>
+              <a:rPr sz="1350">
+                <a:solidFill>
+                  <a:srgbClr val="E6E6E6"/>
+                </a:solidFill>
+                <a:latin typeface="Consolas"/>
+              </a:rPr>
+              <a:t>  pod=MyPod-AMC2.pod)</a:t>
+            </a:r>
+          </a:p>
+          <a:p>
+            <a:pPr algn="l">
+              <a:spcAft>
+                <a:spcPts val="200"/>
+              </a:spcAft>
+            </a:pPr>
+            <a:r>
+              <a:rPr sz="1350">
+                <a:solidFill>
+                  <a:srgbClr val="E6E6E6"/>
+                </a:solidFill>
+                <a:latin typeface="Consolas"/>
+              </a:rPr>
+              <a:t>  This is a V2 run job -- also regenerate its plot</a:t>
+            </a:r>
+          </a:p>
+          <a:p>
+            <a:pPr algn="l">
+              <a:spcAft>
+                <a:spcPts val="200"/>
+              </a:spcAft>
+            </a:pPr>
+            <a:r>
+              <a:rPr sz="1350">
+                <a:solidFill>
+                  <a:srgbClr val="E6E6E6"/>
+                </a:solidFill>
+                <a:latin typeface="Consolas"/>
+              </a:rPr>
+              <a:t>  job(s) against the new pod:</a:t>
+            </a:r>
+          </a:p>
+          <a:p>
+            <a:pPr algn="l">
+              <a:spcAft>
+                <a:spcPts val="200"/>
+              </a:spcAft>
+            </a:pPr>
+            <a:r>
+              <a:rPr sz="1350">
+                <a:solidFill>
+                  <a:srgbClr val="E6E6E6"/>
+                </a:solidFill>
+                <a:latin typeface="Consolas"/>
+              </a:rPr>
+              <a:t>    py padb_make_v2_job.py MyPod-AMC2.pod --module &lt;YourModule&gt;</a:t>
+            </a:r>
+          </a:p>
+        </p:txBody>
+      </p:sp>
+      <p:sp>
+        <p:nvSpPr>
+          <p:cNvPr id="11" name="TextBox 10"/>
+          <p:cNvSpPr txBox="1"/>
+          <p:nvPr/>
+        </p:nvSpPr>
+        <p:spPr>
+          <a:xfrm>
+            <a:off x="548640" y="5074920"/>
+            <a:ext cx="11064240" cy="640080"/>
+          </a:xfrm>
+          <a:prstGeom prst="rect">
+            <a:avLst/>
+          </a:prstGeom>
+          <a:noFill/>
+        </p:spPr>
+        <p:txBody>
+          <a:bodyPr wrap="square">
+            <a:spAutoFit/>
+          </a:bodyPr>
+          <a:lstStyle/>
+          <a:p>
+            <a:pPr>
+              <a:spcAft>
+                <a:spcPts val="1000"/>
+              </a:spcAft>
+            </a:pPr>
+            <a:r>
+              <a:rPr sz="1500">
+                <a:solidFill>
+                  <a:srgbClr val="1B2A4A"/>
+                </a:solidFill>
+                <a:latin typeface="Segoe UI"/>
+              </a:rPr>
+              <a:t>•  Updates results_dir, publish/publish_to, and description too — not just "pod"</a:t>
+            </a:r>
+          </a:p>
+          <a:p>
+            <a:pPr>
+              <a:spcAft>
+                <a:spcPts val="1000"/>
+              </a:spcAft>
+            </a:pPr>
+            <a:r>
+              <a:rPr sz="1500">
+                <a:solidFill>
+                  <a:srgbClr val="1B2A4A"/>
+                </a:solidFill>
+                <a:latin typeface="Segoe UI"/>
+              </a:rPr>
+              <a:t>•  --force overwrites an existing output; --list-sites prints the registry</a:t>
+            </a:r>
+          </a:p>
+        </p:txBody>
+      </p:sp>
+    </p:spTree>
+  </p:cSld>
+  <p:clrMapOvr>
+    <a:masterClrMapping/>
+  </p:clrMapOvr>
+</p:sld>
+</file>
+
+<file path=ppt/slides/slide42.xml><?xml version="1.0" encoding="utf-8"?>
+<p:sld xmlns:a="http://schemas.openxmlformats.org/drawingml/2006/main" xmlns:p="http://schemas.openxmlformats.org/presentationml/2006/main" xmlns:r="http://schemas.openxmlformats.org/officeDocument/2006/relationships">
+  <p:cSld>
+    <p:spTree>
+      <p:nvGrpSpPr>
+        <p:cNvPr id="1" name=""/>
+        <p:cNvGrpSpPr/>
+        <p:nvPr/>
+      </p:nvGrpSpPr>
+      <p:grpSpPr/>
+      <p:sp>
+        <p:nvSpPr>
+          <p:cNvPr id="2" name="Rectangle 1"/>
+          <p:cNvSpPr/>
+          <p:nvPr/>
+        </p:nvSpPr>
+        <p:spPr>
+          <a:xfrm>
+            <a:off x="0" y="0"/>
+            <a:ext cx="12191695" cy="6858000"/>
+          </a:xfrm>
+          <a:prstGeom prst="rect">
+            <a:avLst/>
+          </a:prstGeom>
+          <a:solidFill>
+            <a:srgbClr val="1B2A4A"/>
+          </a:solidFill>
+          <a:ln>
+            <a:noFill/>
+          </a:ln>
+          <a:effectLst/>
+        </p:spPr>
+        <p:style>
+          <a:lnRef idx="1">
+            <a:schemeClr val="accent1"/>
+          </a:lnRef>
+          <a:fillRef idx="3">
+            <a:schemeClr val="accent1"/>
+          </a:fillRef>
+          <a:effectRef idx="2">
+            <a:schemeClr val="accent1"/>
+          </a:effectRef>
+          <a:fontRef idx="minor">
+            <a:schemeClr val="lt1"/>
+          </a:fontRef>
+        </p:style>
+        <p:txBody>
+          <a:bodyPr rtlCol="0" anchor="ctr"/>
+          <a:lstStyle/>
+          <a:p>
+            <a:pPr algn="ctr"/>
+          </a:p>
+        </p:txBody>
+      </p:sp>
+      <p:sp>
+        <p:nvSpPr>
+          <p:cNvPr id="3" name="TextBox 2"/>
+          <p:cNvSpPr txBox="1"/>
+          <p:nvPr/>
+        </p:nvSpPr>
+        <p:spPr>
+          <a:xfrm>
+            <a:off x="822960" y="2743200"/>
+            <a:ext cx="10515600" cy="1097280"/>
+          </a:xfrm>
+          <a:prstGeom prst="rect">
+            <a:avLst/>
+          </a:prstGeom>
+          <a:noFill/>
+        </p:spPr>
+        <p:txBody>
+          <a:bodyPr wrap="none">
+            <a:spAutoFit/>
+          </a:bodyPr>
+          <a:lstStyle/>
+          <a:p>
+            <a:pPr>
+              <a:defRPr sz="4800" b="1">
+                <a:solidFill>
+                  <a:srgbClr val="FFFFFF"/>
+                </a:solidFill>
+              </a:defRPr>
+            </a:pPr>
+            <a:r>
+              <a:t>Questions?</a:t>
+            </a:r>
+          </a:p>
+        </p:txBody>
+      </p:sp>
+      <p:sp>
+        <p:nvSpPr>
+          <p:cNvPr id="4" name="TextBox 3"/>
+          <p:cNvSpPr txBox="1"/>
+          <p:nvPr/>
+        </p:nvSpPr>
+        <p:spPr>
+          <a:xfrm>
+            <a:off x="822960" y="3749039"/>
+            <a:ext cx="10515600" cy="640080"/>
+          </a:xfrm>
+          <a:prstGeom prst="rect">
+            <a:avLst/>
+          </a:prstGeom>
+          <a:noFill/>
+        </p:spPr>
+        <p:txBody>
+          <a:bodyPr wrap="none">
+            <a:spAutoFit/>
+          </a:bodyPr>
+          <a:lstStyle/>
+          <a:p>
+            <a:pPr>
+              <a:defRPr sz="1800">
+                <a:solidFill>
+                  <a:srgbClr val="9FC5FF"/>
+                </a:solidFill>
+                <a:latin typeface="Consolas"/>
+              </a:defRPr>
+            </a:pPr>
+            <a:r>
+              <a:t>C:\apps\padb\tools   |   /padb-tools</a:t>
+            </a:r>
+          </a:p>
+        </p:txBody>
+      </p:sp>
+    </p:spTree>
+  </p:cSld>
+  <p:clrMapOvr>
+    <a:masterClrMapping/>
+  </p:clrMapOvr>
+</p:sld>
+</file>
+
+<file path=ppt/slides/slide43.xml><?xml version="1.0" encoding="utf-8"?>
+<p:sld xmlns:a="http://schemas.openxmlformats.org/drawingml/2006/main" xmlns:p="http://schemas.openxmlformats.org/presentationml/2006/main" xmlns:r="http://schemas.openxmlformats.org/officeDocument/2006/relationships">
+  <p:cSld>
+    <p:spTree>
+      <p:nvGrpSpPr>
+        <p:cNvPr id="1" name=""/>
+        <p:cNvGrpSpPr/>
+        <p:nvPr/>
+      </p:nvGrpSpPr>
+      <p:grpSpPr/>
+      <p:sp>
+        <p:nvSpPr>
+          <p:cNvPr id="2" name="Rectangle 1"/>
+          <p:cNvSpPr/>
+          <p:nvPr/>
+        </p:nvSpPr>
+        <p:spPr>
+          <a:xfrm>
+            <a:off x="0" y="0"/>
+            <a:ext cx="12191695" cy="6858000"/>
+          </a:xfrm>
+          <a:prstGeom prst="rect">
+            <a:avLst/>
+          </a:prstGeom>
+          <a:solidFill>
+            <a:srgbClr val="F2F4F8"/>
+          </a:solidFill>
+          <a:ln>
+            <a:noFill/>
+          </a:ln>
+          <a:effectLst/>
+        </p:spPr>
+        <p:style>
+          <a:lnRef idx="1">
+            <a:schemeClr val="accent1"/>
+          </a:lnRef>
+          <a:fillRef idx="3">
+            <a:schemeClr val="accent1"/>
+          </a:fillRef>
+          <a:effectRef idx="2">
+            <a:schemeClr val="accent1"/>
+          </a:effectRef>
+          <a:fontRef idx="minor">
+            <a:schemeClr val="lt1"/>
+          </a:fontRef>
+        </p:style>
+        <p:txBody>
+          <a:bodyPr rtlCol="0" anchor="ctr"/>
+          <a:lstStyle/>
+          <a:p>
+            <a:pPr algn="ctr"/>
+          </a:p>
+        </p:txBody>
+      </p:sp>
+      <p:sp>
+        <p:nvSpPr>
+          <p:cNvPr id="3" name="TextBox 2"/>
+          <p:cNvSpPr txBox="1"/>
+          <p:nvPr/>
+        </p:nvSpPr>
+        <p:spPr>
+          <a:xfrm>
+            <a:off x="822960" y="2743200"/>
+            <a:ext cx="10515600" cy="914400"/>
+          </a:xfrm>
+          <a:prstGeom prst="rect">
+            <a:avLst/>
+          </a:prstGeom>
+          <a:noFill/>
+        </p:spPr>
+        <p:txBody>
+          <a:bodyPr wrap="none">
+            <a:spAutoFit/>
+          </a:bodyPr>
+          <a:lstStyle/>
+          <a:p>
+            <a:pPr>
+              <a:defRPr sz="4400" b="1">
+                <a:solidFill>
+                  <a:srgbClr val="1B2A4A"/>
+                </a:solidFill>
+              </a:defRPr>
+            </a:pPr>
+            <a:r>
+              <a:t>Appendix</a:t>
+            </a:r>
+          </a:p>
+        </p:txBody>
+      </p:sp>
+      <p:sp>
+        <p:nvSpPr>
+          <p:cNvPr id="4" name="TextBox 3"/>
+          <p:cNvSpPr txBox="1"/>
+          <p:nvPr/>
+        </p:nvSpPr>
+        <p:spPr>
+          <a:xfrm>
+            <a:off x="822960" y="3566160"/>
+            <a:ext cx="10515600" cy="640080"/>
+          </a:xfrm>
+          <a:prstGeom prst="rect">
+            <a:avLst/>
+          </a:prstGeom>
+          <a:noFill/>
+        </p:spPr>
+        <p:txBody>
+          <a:bodyPr wrap="none">
+            <a:spAutoFit/>
+          </a:bodyPr>
+          <a:lstStyle/>
+          <a:p>
+            <a:pPr>
+              <a:defRPr sz="2200">
+                <a:solidFill>
+                  <a:srgbClr val="0066CC"/>
+                </a:solidFill>
+              </a:defRPr>
+            </a:pPr>
+            <a:r>
+              <a:t>Setting Up From Zero — Assumes No Prior Access</a:t>
+            </a:r>
+          </a:p>
+        </p:txBody>
+      </p:sp>
+    </p:spTree>
+  </p:cSld>
+  <p:clrMapOvr>
+    <a:masterClrMapping/>
+  </p:clrMapOvr>
+</p:sld>
+</file>
+
+<file path=ppt/slides/slide44.xml><?xml version="1.0" encoding="utf-8"?>
+<p:sld xmlns:a="http://schemas.openxmlformats.org/drawingml/2006/main" xmlns:p="http://schemas.openxmlformats.org/presentationml/2006/main" xmlns:r="http://schemas.openxmlformats.org/officeDocument/2006/relationships">
+  <p:cSld>
+    <p:spTree>
+      <p:nvGrpSpPr>
+        <p:cNvPr id="1" name=""/>
+        <p:cNvGrpSpPr/>
+        <p:nvPr/>
+      </p:nvGrpSpPr>
+      <p:grpSpPr/>
+      <p:sp>
+        <p:nvSpPr>
+          <p:cNvPr id="2" name="Rectangle 1"/>
+          <p:cNvSpPr/>
+          <p:nvPr/>
+        </p:nvSpPr>
+        <p:spPr>
+          <a:xfrm>
+            <a:off x="0" y="0"/>
+            <a:ext cx="12191695" cy="6858000"/>
+          </a:xfrm>
+          <a:prstGeom prst="rect">
+            <a:avLst/>
+          </a:prstGeom>
+          <a:solidFill>
+            <a:srgbClr val="FFFFFF"/>
+          </a:solidFill>
+          <a:ln>
+            <a:noFill/>
+          </a:ln>
+          <a:effectLst/>
+        </p:spPr>
+        <p:style>
+          <a:lnRef idx="1">
+            <a:schemeClr val="accent1"/>
+          </a:lnRef>
+          <a:fillRef idx="3">
+            <a:schemeClr val="accent1"/>
+          </a:fillRef>
+          <a:effectRef idx="2">
+            <a:schemeClr val="accent1"/>
+          </a:effectRef>
+          <a:fontRef idx="minor">
+            <a:schemeClr val="lt1"/>
+          </a:fontRef>
+        </p:style>
+        <p:txBody>
+          <a:bodyPr rtlCol="0" anchor="ctr"/>
+          <a:lstStyle/>
+          <a:p>
+            <a:pPr algn="ctr"/>
+          </a:p>
+        </p:txBody>
+      </p:sp>
+      <p:sp>
+        <p:nvSpPr>
+          <p:cNvPr id="3" name="TextBox 2"/>
+          <p:cNvSpPr txBox="1"/>
+          <p:nvPr/>
+        </p:nvSpPr>
+        <p:spPr>
+          <a:xfrm>
+            <a:off x="548640" y="320040"/>
+            <a:ext cx="7315200" cy="365760"/>
+          </a:xfrm>
+          <a:prstGeom prst="rect">
+            <a:avLst/>
+          </a:prstGeom>
+          <a:noFill/>
+        </p:spPr>
+        <p:txBody>
+          <a:bodyPr wrap="none">
+            <a:spAutoFit/>
+          </a:bodyPr>
+          <a:lstStyle/>
+          <a:p>
+            <a:pPr>
+              <a:defRPr sz="1600" b="1">
+                <a:solidFill>
+                  <a:srgbClr val="0066CC"/>
+                </a:solidFill>
+                <a:latin typeface="Segoe UI"/>
+              </a:defRPr>
+            </a:pPr>
+            <a:r>
+              <a:t>Appendix</a:t>
+            </a:r>
+          </a:p>
+        </p:txBody>
+      </p:sp>
+      <p:sp>
+        <p:nvSpPr>
+          <p:cNvPr id="4" name="TextBox 3"/>
+          <p:cNvSpPr txBox="1"/>
+          <p:nvPr/>
+        </p:nvSpPr>
+        <p:spPr>
+          <a:xfrm>
+            <a:off x="548640" y="658368"/>
+            <a:ext cx="11064240" cy="822960"/>
+          </a:xfrm>
+          <a:prstGeom prst="rect">
+            <a:avLst/>
+          </a:prstGeom>
+          <a:noFill/>
+        </p:spPr>
+        <p:txBody>
+          <a:bodyPr wrap="square">
+            <a:spAutoFit/>
+          </a:bodyPr>
+          <a:lstStyle/>
+          <a:p>
+            <a:pPr>
+              <a:defRPr sz="3200" b="1">
+                <a:solidFill>
+                  <a:srgbClr val="1B2A4A"/>
+                </a:solidFill>
+                <a:latin typeface="Segoe UI"/>
+              </a:defRPr>
+            </a:pPr>
+            <a:r>
+              <a:t>Getting the Code</a:t>
+            </a:r>
+          </a:p>
+        </p:txBody>
+      </p:sp>
+      <p:cxnSp>
+        <p:nvCxnSpPr>
+          <p:cNvPr id="5" name="Connector 4"/>
+          <p:cNvCxnSpPr/>
+          <p:nvPr/>
+        </p:nvCxnSpPr>
+        <p:spPr>
+          <a:xfrm>
+            <a:off x="548640" y="1417320"/>
+            <a:ext cx="11091672" cy="0"/>
+          </a:xfrm>
+          <a:prstGeom prst="line">
+            <a:avLst/>
+          </a:prstGeom>
+          <a:ln w="28575">
+            <a:solidFill>
+              <a:srgbClr val="0066CC"/>
+            </a:solidFill>
+          </a:ln>
+        </p:spPr>
+        <p:style>
+          <a:lnRef idx="2">
+            <a:schemeClr val="accent1"/>
+          </a:lnRef>
+          <a:fillRef idx="0">
+            <a:schemeClr val="accent1"/>
+          </a:fillRef>
+          <a:effectRef idx="1">
+            <a:schemeClr val="accent1"/>
+          </a:effectRef>
+          <a:fontRef idx="minor">
+            <a:schemeClr val="tx1"/>
+          </a:fontRef>
+        </p:style>
+      </p:cxnSp>
+      <p:sp>
+        <p:nvSpPr>
+          <p:cNvPr id="6" name="TextBox 5"/>
+          <p:cNvSpPr txBox="1"/>
+          <p:nvPr/>
+        </p:nvSpPr>
+        <p:spPr>
+          <a:xfrm>
+            <a:off x="548640" y="6473952"/>
+            <a:ext cx="8229600" cy="320040"/>
+          </a:xfrm>
+          <a:prstGeom prst="rect">
+            <a:avLst/>
+          </a:prstGeom>
+          <a:noFill/>
+        </p:spPr>
+        <p:txBody>
+          <a:bodyPr wrap="none">
+            <a:spAutoFit/>
+          </a:bodyPr>
+          <a:lstStyle/>
+          <a:p>
+            <a:pPr>
+              <a:defRPr sz="1100">
+                <a:solidFill>
+                  <a:srgbClr val="555555"/>
+                </a:solidFill>
+                <a:latin typeface="Segoe UI"/>
+              </a:defRPr>
+            </a:pPr>
+            <a:r>
+              <a:t>padb-tools</a:t>
+            </a:r>
+          </a:p>
+        </p:txBody>
+      </p:sp>
+      <p:sp>
+        <p:nvSpPr>
+          <p:cNvPr id="7" name="TextBox 6"/>
+          <p:cNvSpPr txBox="1"/>
+          <p:nvPr/>
+        </p:nvSpPr>
+        <p:spPr>
+          <a:xfrm>
+            <a:off x="11338560" y="6473952"/>
+            <a:ext cx="548640" cy="320040"/>
+          </a:xfrm>
+          <a:prstGeom prst="rect">
+            <a:avLst/>
+          </a:prstGeom>
+          <a:noFill/>
+        </p:spPr>
+        <p:txBody>
+          <a:bodyPr wrap="none">
+            <a:spAutoFit/>
+          </a:bodyPr>
+          <a:lstStyle/>
+          <a:p>
+            <a:pPr algn="r">
+              <a:defRPr sz="1100">
+                <a:solidFill>
+                  <a:srgbClr val="555555"/>
+                </a:solidFill>
+              </a:defRPr>
+            </a:pPr>
+            <a:r>
+              <a:t>43</a:t>
+            </a:r>
+          </a:p>
+        </p:txBody>
+      </p:sp>
+      <p:sp>
+        <p:nvSpPr>
+          <p:cNvPr id="8" name="TextBox 7"/>
+          <p:cNvSpPr txBox="1"/>
+          <p:nvPr/>
+        </p:nvSpPr>
+        <p:spPr>
+          <a:xfrm>
+            <a:off x="548640" y="1691640"/>
+            <a:ext cx="11064240" cy="365760"/>
+          </a:xfrm>
+          <a:prstGeom prst="rect">
+            <a:avLst/>
+          </a:prstGeom>
+          <a:noFill/>
+        </p:spPr>
+        <p:txBody>
+          <a:bodyPr wrap="square">
+            <a:spAutoFit/>
+          </a:bodyPr>
+          <a:lstStyle/>
+          <a:p>
+            <a:pPr>
+              <a:spcAft>
+                <a:spcPts val="1000"/>
+              </a:spcAft>
+            </a:pPr>
+            <a:r>
+              <a:rPr sz="1900">
+                <a:solidFill>
+                  <a:srgbClr val="1B2A4A"/>
+                </a:solidFill>
+                <a:latin typeface="Segoe UI"/>
+              </a:rPr>
+              <a:t>•  This repo isn't on a company-wide share by default — copy it from:</a:t>
+            </a:r>
+          </a:p>
+        </p:txBody>
+      </p:sp>
+      <p:sp>
+        <p:nvSpPr>
+          <p:cNvPr id="9" name="Rounded Rectangle 8"/>
+          <p:cNvSpPr/>
+          <p:nvPr/>
+        </p:nvSpPr>
+        <p:spPr>
+          <a:xfrm>
+            <a:off x="548640" y="2103120"/>
+            <a:ext cx="11064240" cy="502920"/>
+          </a:xfrm>
+          <a:prstGeom prst="roundRect">
+            <a:avLst>
+              <a:gd name="adj" fmla="val 4000"/>
+            </a:avLst>
+          </a:prstGeom>
+          <a:solidFill>
+            <a:srgbClr val="282C34"/>
+          </a:solidFill>
+          <a:ln>
+            <a:solidFill>
+              <a:srgbClr val="111318"/>
+            </a:solidFill>
+          </a:ln>
+          <a:effectLst/>
+        </p:spPr>
+        <p:style>
+          <a:lnRef idx="1">
+            <a:schemeClr val="accent1"/>
+          </a:lnRef>
+          <a:fillRef idx="3">
+            <a:schemeClr val="accent1"/>
+          </a:fillRef>
+          <a:effectRef idx="2">
+            <a:schemeClr val="accent1"/>
+          </a:effectRef>
+          <a:fontRef idx="minor">
+            <a:schemeClr val="lt1"/>
+          </a:fontRef>
+        </p:style>
+        <p:txBody>
+          <a:bodyPr rtlCol="0" anchor="t" wrap="square" lIns="228600" rIns="228600" tIns="164592" bIns="164592"/>
+          <a:lstStyle/>
+          <a:p>
+            <a:pPr algn="l">
+              <a:spcAft>
+                <a:spcPts val="200"/>
+              </a:spcAft>
+            </a:pPr>
+            <a:r>
+              <a:rPr sz="1350">
+                <a:solidFill>
+                  <a:srgbClr val="E6E6E6"/>
+                </a:solidFill>
+                <a:latin typeface="Consolas"/>
+              </a:rPr>
+              <a:t>\\srsnas01.srs.is.keysight.com\prod\MIDRF3\SG6311A\Padb-tools\tools</a:t>
+            </a:r>
+          </a:p>
+        </p:txBody>
+      </p:sp>
+      <p:sp>
+        <p:nvSpPr>
+          <p:cNvPr id="10" name="TextBox 9"/>
+          <p:cNvSpPr txBox="1"/>
+          <p:nvPr/>
+        </p:nvSpPr>
+        <p:spPr>
+          <a:xfrm>
+            <a:off x="548640" y="2788920"/>
+            <a:ext cx="11064240" cy="365760"/>
+          </a:xfrm>
+          <a:prstGeom prst="rect">
+            <a:avLst/>
+          </a:prstGeom>
+          <a:noFill/>
+        </p:spPr>
+        <p:txBody>
+          <a:bodyPr wrap="square">
+            <a:spAutoFit/>
+          </a:bodyPr>
+          <a:lstStyle/>
+          <a:p>
+            <a:pPr>
+              <a:spcAft>
+                <a:spcPts val="1000"/>
+              </a:spcAft>
+            </a:pPr>
+            <a:r>
+              <a:rPr sz="1800">
+                <a:solidFill>
+                  <a:srgbClr val="1B2A4A"/>
+                </a:solidFill>
+                <a:latin typeface="Segoe UI"/>
+              </a:rPr>
+              <a:t>•  Copy that whole "tools" folder to a local path, e.g. C:\apps\padb\tools</a:t>
+            </a:r>
+          </a:p>
+        </p:txBody>
+      </p:sp>
+      <p:sp>
+        <p:nvSpPr>
+          <p:cNvPr id="11" name="TextBox 10"/>
+          <p:cNvSpPr txBox="1"/>
+          <p:nvPr/>
+        </p:nvSpPr>
+        <p:spPr>
+          <a:xfrm>
+            <a:off x="548640" y="3429000"/>
+            <a:ext cx="11064240" cy="914400"/>
+          </a:xfrm>
+          <a:prstGeom prst="rect">
+            <a:avLst/>
+          </a:prstGeom>
+          <a:noFill/>
+        </p:spPr>
+        <p:txBody>
+          <a:bodyPr wrap="square">
+            <a:spAutoFit/>
+          </a:bodyPr>
+          <a:lstStyle/>
+          <a:p>
+            <a:pPr>
+              <a:spcAft>
+                <a:spcPts val="1000"/>
+              </a:spcAft>
+            </a:pPr>
+            <a:r>
+              <a:rPr sz="1700">
+                <a:solidFill>
+                  <a:srgbClr val="1B2A4A"/>
+                </a:solidFill>
+                <a:latin typeface="Segoe UI"/>
+              </a:rPr>
+              <a:t>•  padb_batch.py is bundled directly inside the tools folder (added 2026-08-05) —</a:t>
+            </a:r>
+          </a:p>
+          <a:p>
+            <a:pPr lvl="1">
+              <a:spcAft>
+                <a:spcPts val="600"/>
+              </a:spcAft>
+            </a:pPr>
+            <a:r>
+              <a:rPr sz="1500">
+                <a:solidFill>
+                  <a:srgbClr val="555555"/>
+                </a:solidFill>
+                <a:latin typeface="Segoe UI"/>
+              </a:rPr>
+              <a:t>–  no separate dependency to track down; the whole repo is self-contained</a:t>
+            </a:r>
+          </a:p>
+        </p:txBody>
+      </p:sp>
+      <p:sp>
+        <p:nvSpPr>
+          <p:cNvPr id="12" name="TextBox 11"/>
+          <p:cNvSpPr txBox="1"/>
+          <p:nvPr/>
+        </p:nvSpPr>
+        <p:spPr>
+          <a:xfrm>
+            <a:off x="548640" y="4480560"/>
+            <a:ext cx="11064240" cy="457200"/>
+          </a:xfrm>
+          <a:prstGeom prst="rect">
+            <a:avLst/>
+          </a:prstGeom>
+          <a:noFill/>
+        </p:spPr>
+        <p:txBody>
+          <a:bodyPr wrap="square">
+            <a:spAutoFit/>
+          </a:bodyPr>
+          <a:lstStyle/>
+          <a:p>
+            <a:pPr>
+              <a:spcAft>
+                <a:spcPts val="1000"/>
+              </a:spcAft>
+            </a:pPr>
+            <a:r>
+              <a:rPr sz="1650">
+                <a:solidFill>
+                  <a:srgbClr val="1B2A4A"/>
+                </a:solidFill>
+                <a:latin typeface="Segoe UI"/>
+              </a:rPr>
+              <a:t>•  Then follow the Prerequisites and Per-User Config slides earlier in this deck</a:t>
+            </a:r>
+          </a:p>
+        </p:txBody>
+      </p:sp>
+    </p:spTree>
+  </p:cSld>
+  <p:clrMapOvr>
+    <a:masterClrMapping/>
+  </p:clrMapOvr>
+</p:sld>
+</file>
+
+<file path=ppt/slides/slide45.xml><?xml version="1.0" encoding="utf-8"?>
+<p:sld xmlns:a="http://schemas.openxmlformats.org/drawingml/2006/main" xmlns:p="http://schemas.openxmlformats.org/presentationml/2006/main" xmlns:r="http://schemas.openxmlformats.org/officeDocument/2006/relationships">
+  <p:cSld>
+    <p:spTree>
+      <p:nvGrpSpPr>
+        <p:cNvPr id="1" name=""/>
+        <p:cNvGrpSpPr/>
+        <p:nvPr/>
+      </p:nvGrpSpPr>
+      <p:grpSpPr/>
+      <p:sp>
+        <p:nvSpPr>
+          <p:cNvPr id="2" name="Rectangle 1"/>
+          <p:cNvSpPr/>
+          <p:nvPr/>
+        </p:nvSpPr>
+        <p:spPr>
+          <a:xfrm>
+            <a:off x="0" y="0"/>
+            <a:ext cx="12191695" cy="6858000"/>
+          </a:xfrm>
+          <a:prstGeom prst="rect">
+            <a:avLst/>
+          </a:prstGeom>
+          <a:solidFill>
+            <a:srgbClr val="FFFFFF"/>
+          </a:solidFill>
+          <a:ln>
+            <a:noFill/>
+          </a:ln>
+          <a:effectLst/>
+        </p:spPr>
+        <p:style>
+          <a:lnRef idx="1">
+            <a:schemeClr val="accent1"/>
+          </a:lnRef>
+          <a:fillRef idx="3">
+            <a:schemeClr val="accent1"/>
+          </a:fillRef>
+          <a:effectRef idx="2">
+            <a:schemeClr val="accent1"/>
+          </a:effectRef>
+          <a:fontRef idx="minor">
+            <a:schemeClr val="lt1"/>
+          </a:fontRef>
+        </p:style>
+        <p:txBody>
+          <a:bodyPr rtlCol="0" anchor="ctr"/>
+          <a:lstStyle/>
+          <a:p>
+            <a:pPr algn="ctr"/>
+          </a:p>
+        </p:txBody>
+      </p:sp>
+      <p:sp>
+        <p:nvSpPr>
+          <p:cNvPr id="3" name="TextBox 2"/>
+          <p:cNvSpPr txBox="1"/>
+          <p:nvPr/>
+        </p:nvSpPr>
+        <p:spPr>
+          <a:xfrm>
+            <a:off x="548640" y="320040"/>
+            <a:ext cx="7315200" cy="365760"/>
+          </a:xfrm>
+          <a:prstGeom prst="rect">
+            <a:avLst/>
+          </a:prstGeom>
+          <a:noFill/>
+        </p:spPr>
+        <p:txBody>
+          <a:bodyPr wrap="none">
+            <a:spAutoFit/>
+          </a:bodyPr>
+          <a:lstStyle/>
+          <a:p>
+            <a:pPr>
+              <a:defRPr sz="1600" b="1">
+                <a:solidFill>
+                  <a:srgbClr val="0066CC"/>
+                </a:solidFill>
+                <a:latin typeface="Segoe UI"/>
+              </a:defRPr>
+            </a:pPr>
+            <a:r>
+              <a:t>Appendix</a:t>
+            </a:r>
+          </a:p>
+        </p:txBody>
+      </p:sp>
+      <p:sp>
+        <p:nvSpPr>
+          <p:cNvPr id="4" name="TextBox 3"/>
+          <p:cNvSpPr txBox="1"/>
+          <p:nvPr/>
+        </p:nvSpPr>
+        <p:spPr>
+          <a:xfrm>
+            <a:off x="548640" y="658368"/>
+            <a:ext cx="11064240" cy="822960"/>
+          </a:xfrm>
+          <a:prstGeom prst="rect">
+            <a:avLst/>
+          </a:prstGeom>
+          <a:noFill/>
+        </p:spPr>
+        <p:txBody>
+          <a:bodyPr wrap="square">
+            <a:spAutoFit/>
+          </a:bodyPr>
+          <a:lstStyle/>
+          <a:p>
+            <a:pPr>
+              <a:defRPr sz="3200" b="1">
+                <a:solidFill>
+                  <a:srgbClr val="1B2A4A"/>
+                </a:solidFill>
+                <a:latin typeface="Segoe UI"/>
+              </a:defRPr>
+            </a:pPr>
+            <a:r>
+              <a:t>First Commands to Verify Your Setup</a:t>
+            </a:r>
+          </a:p>
+        </p:txBody>
+      </p:sp>
+      <p:cxnSp>
+        <p:nvCxnSpPr>
+          <p:cNvPr id="5" name="Connector 4"/>
+          <p:cNvCxnSpPr/>
+          <p:nvPr/>
+        </p:nvCxnSpPr>
+        <p:spPr>
+          <a:xfrm>
+            <a:off x="548640" y="1417320"/>
+            <a:ext cx="11091672" cy="0"/>
+          </a:xfrm>
+          <a:prstGeom prst="line">
+            <a:avLst/>
+          </a:prstGeom>
+          <a:ln w="28575">
+            <a:solidFill>
+              <a:srgbClr val="0066CC"/>
+            </a:solidFill>
+          </a:ln>
+        </p:spPr>
+        <p:style>
+          <a:lnRef idx="2">
+            <a:schemeClr val="accent1"/>
+          </a:lnRef>
+          <a:fillRef idx="0">
+            <a:schemeClr val="accent1"/>
+          </a:fillRef>
+          <a:effectRef idx="1">
+            <a:schemeClr val="accent1"/>
+          </a:effectRef>
+          <a:fontRef idx="minor">
+            <a:schemeClr val="tx1"/>
+          </a:fontRef>
+        </p:style>
+      </p:cxnSp>
+      <p:sp>
+        <p:nvSpPr>
+          <p:cNvPr id="6" name="TextBox 5"/>
+          <p:cNvSpPr txBox="1"/>
+          <p:nvPr/>
+        </p:nvSpPr>
+        <p:spPr>
+          <a:xfrm>
+            <a:off x="548640" y="6473952"/>
+            <a:ext cx="8229600" cy="320040"/>
+          </a:xfrm>
+          <a:prstGeom prst="rect">
+            <a:avLst/>
+          </a:prstGeom>
+          <a:noFill/>
+        </p:spPr>
+        <p:txBody>
+          <a:bodyPr wrap="none">
+            <a:spAutoFit/>
+          </a:bodyPr>
+          <a:lstStyle/>
+          <a:p>
+            <a:pPr>
+              <a:defRPr sz="1100">
+                <a:solidFill>
+                  <a:srgbClr val="555555"/>
+                </a:solidFill>
+                <a:latin typeface="Segoe UI"/>
+              </a:defRPr>
+            </a:pPr>
+            <a:r>
+              <a:t>padb-tools</a:t>
+            </a:r>
+          </a:p>
+        </p:txBody>
+      </p:sp>
+      <p:sp>
+        <p:nvSpPr>
+          <p:cNvPr id="7" name="TextBox 6"/>
+          <p:cNvSpPr txBox="1"/>
+          <p:nvPr/>
+        </p:nvSpPr>
+        <p:spPr>
+          <a:xfrm>
+            <a:off x="11338560" y="6473952"/>
+            <a:ext cx="548640" cy="320040"/>
+          </a:xfrm>
+          <a:prstGeom prst="rect">
+            <a:avLst/>
+          </a:prstGeom>
+          <a:noFill/>
+        </p:spPr>
+        <p:txBody>
+          <a:bodyPr wrap="none">
+            <a:spAutoFit/>
+          </a:bodyPr>
+          <a:lstStyle/>
+          <a:p>
+            <a:pPr algn="r">
+              <a:defRPr sz="1100">
+                <a:solidFill>
+                  <a:srgbClr val="555555"/>
+                </a:solidFill>
+              </a:defRPr>
+            </a:pPr>
+            <a:r>
+              <a:t>44</a:t>
             </a:r>
           </a:p>
         </p:txBody>

</xml_diff>

<commit_message>
Correct slide 27's stale TLL-selector claim and regenerate the deck
MaxPowerTutorial2's stat_summary/summary pages no longer show a live TLL
selector -- the pod's CSV has real two-sided spec limits (30/23 dBm), which
always override spec_direction with no selector (data beats config). The
screenshot/script predates the null-limit-filling fix that made both sides
consistently detected. Slide now correctly points at the Lower spec line
as the operative one for MaxPower, instead of an instruction to click a
control that no longer exists on this page.
</commit_message>
<xml_diff>
--- a/PADB_Simple_and_Interactive.pptx
+++ b/PADB_Simple_and_Interactive.pptx
@@ -10979,7 +10979,7 @@
               </a:defRPr>
             </a:pPr>
             <a:r>
-              <a:t>The Result — Try the TLL Selector</a:t>
+              <a:t>The Result — Spec Pass/Fail</a:t>
             </a:r>
           </a:p>
         </p:txBody>
@@ -11099,7 +11099,7 @@
         <p:spPr>
           <a:xfrm>
             <a:off x="548640" y="1600200"/>
-            <a:ext cx="11064240" cy="731520"/>
+            <a:ext cx="11064240" cy="1005840"/>
           </a:xfrm>
           <a:prstGeom prst="rect">
             <a:avLst/>
@@ -11124,7 +11124,7 @@
                 </a:solidFill>
                 <a:latin typeface="Segoe UI"/>
               </a:rPr>
-              <a:t>•  This pod has no spec limits, so the live "TLL display" selector appears (circled) —</a:t>
+              <a:t>•  This pod's CSV has real Upper (30 dBm) and Lower (23 dBm) limits, so both are detected</a:t>
             </a:r>
           </a:p>
           <a:p>
@@ -11140,7 +11140,39 @@
                 </a:solidFill>
                 <a:latin typeface="Segoe UI"/>
               </a:rPr>
-              <a:t>•  MaxPower is a guaranteed-minimum-power measurement, so try switching it to "Lower only"</a:t>
+              <a:t>•  automatically -- no manual override needed, and no live selector to switch (data beats config)</a:t>
+            </a:r>
+          </a:p>
+          <a:p>
+            <a:pPr>
+              <a:spcAft>
+                <a:spcPts val="1000"/>
+              </a:spcAft>
+            </a:pPr>
+            <a:r>
+              <a:rPr sz="1500">
+                <a:solidFill>
+                  <a:srgbClr val="1B2A4A"/>
+                </a:solidFill>
+                <a:latin typeface="Segoe UI"/>
+              </a:rPr>
+              <a:t>•  MaxPower is a guaranteed-minimum-power measurement, so the Lower limit is the one that</a:t>
+            </a:r>
+          </a:p>
+          <a:p>
+            <a:pPr>
+              <a:spcAft>
+                <a:spcPts val="1000"/>
+              </a:spcAft>
+            </a:pPr>
+            <a:r>
+              <a:rPr sz="1500">
+                <a:solidFill>
+                  <a:srgbClr val="1B2A4A"/>
+                </a:solidFill>
+                <a:latin typeface="Segoe UI"/>
+              </a:rPr>
+              <a:t>•  actually matters here -- watch the dashed lower spec line against the TTL band as you filter</a:t>
             </a:r>
           </a:p>
         </p:txBody>
@@ -11161,7 +11193,7 @@
         </p:blipFill>
         <p:spPr>
           <a:xfrm>
-            <a:off x="1892807" y="2423160"/>
+            <a:off x="1892807" y="2514600"/>
             <a:ext cx="8412480" cy="3905794"/>
           </a:xfrm>
           <a:prstGeom prst="rect">
@@ -11174,50 +11206,6 @@
           </a:ln>
         </p:spPr>
       </p:pic>
-      <p:sp>
-        <p:nvSpPr>
-          <p:cNvPr id="10" name="Rounded Rectangle 9"/>
-          <p:cNvSpPr/>
-          <p:nvPr/>
-        </p:nvSpPr>
-        <p:spPr>
-          <a:xfrm>
-            <a:off x="5363504" y="2978950"/>
-            <a:ext cx="2219797" cy="224241"/>
-          </a:xfrm>
-          <a:prstGeom prst="roundRect">
-            <a:avLst/>
-          </a:prstGeom>
-          <a:noFill/>
-          <a:ln w="28575">
-            <a:solidFill>
-              <a:srgbClr val="CC0000"/>
-            </a:solidFill>
-          </a:ln>
-          <a:effectLst/>
-        </p:spPr>
-        <p:style>
-          <a:lnRef idx="1">
-            <a:schemeClr val="accent1"/>
-          </a:lnRef>
-          <a:fillRef idx="3">
-            <a:schemeClr val="accent1"/>
-          </a:fillRef>
-          <a:effectRef idx="2">
-            <a:schemeClr val="accent1"/>
-          </a:effectRef>
-          <a:fontRef idx="minor">
-            <a:schemeClr val="lt1"/>
-          </a:fontRef>
-        </p:style>
-        <p:txBody>
-          <a:bodyPr rtlCol="0" anchor="ctr"/>
-          <a:lstStyle/>
-          <a:p>
-            <a:pPr algn="ctr"/>
-          </a:p>
-        </p:txBody>
-      </p:sp>
     </p:spTree>
   </p:cSld>
   <p:clrMapOvr>

</xml_diff>

<commit_message>
Fix slide 43 title overflow in the training deck
Verified all 3 new slides by actually rendering them via PowerPoint COM
automation -- caught a real layout bug this way: "Boxplot Site
Population Check -- Bad DUT or Bad Station?" was too long and wrapped
onto a second line, overlapping the divider rule and the first bullet.
Shortened to "Site Population Check -- DUT or Station?", re-rendered
to confirm it now fits on one line like every other slide title.

Co-Authored-By: Claude Sonnet 5 <noreply@anthropic.com>
</commit_message>
<xml_diff>
--- a/PADB_Simple_and_Interactive.pptx
+++ b/PADB_Simple_and_Interactive.pptx
@@ -18283,7 +18283,7 @@
             <a:avLst/>
           </a:prstGeom>
           <a:solidFill>
-            <a:srgbClr val="1B2A4A"/>
+            <a:srgbClr val="FFFFFF"/>
           </a:solidFill>
           <a:ln>
             <a:noFill/>
@@ -18320,8 +18320,8 @@
         </p:nvSpPr>
         <p:spPr>
           <a:xfrm>
-            <a:off x="822960" y="2743200"/>
-            <a:ext cx="10515600" cy="1097280"/>
+            <a:off x="548640" y="320040"/>
+            <a:ext cx="7315200" cy="365760"/>
           </a:xfrm>
           <a:prstGeom prst="rect">
             <a:avLst/>
@@ -18335,14 +18335,15 @@
           <a:lstStyle/>
           <a:p>
             <a:pPr>
-              <a:defRPr sz="4800" b="1">
-                <a:solidFill>
-                  <a:srgbClr val="FFFFFF"/>
-                </a:solidFill>
+              <a:defRPr sz="1600" b="1">
+                <a:solidFill>
+                  <a:srgbClr val="0066CC"/>
+                </a:solidFill>
+                <a:latin typeface="Segoe UI"/>
               </a:defRPr>
             </a:pPr>
             <a:r>
-              <a:t>Questions?</a:t>
+              <a:t>Multi-Site Testing</a:t>
             </a:r>
           </a:p>
         </p:txBody>
@@ -18355,8 +18356,79 @@
         </p:nvSpPr>
         <p:spPr>
           <a:xfrm>
-            <a:off x="822960" y="3749039"/>
-            <a:ext cx="10515600" cy="640080"/>
+            <a:off x="548640" y="658368"/>
+            <a:ext cx="11064240" cy="822960"/>
+          </a:xfrm>
+          <a:prstGeom prst="rect">
+            <a:avLst/>
+          </a:prstGeom>
+          <a:noFill/>
+        </p:spPr>
+        <p:txBody>
+          <a:bodyPr wrap="square">
+            <a:spAutoFit/>
+          </a:bodyPr>
+          <a:lstStyle/>
+          <a:p>
+            <a:pPr>
+              <a:defRPr sz="3200" b="1">
+                <a:solidFill>
+                  <a:srgbClr val="1B2A4A"/>
+                </a:solidFill>
+                <a:latin typeface="Segoe UI"/>
+              </a:defRPr>
+            </a:pPr>
+            <a:r>
+              <a:t>Cross-Site Comparison — compare_csv</a:t>
+            </a:r>
+          </a:p>
+        </p:txBody>
+      </p:sp>
+      <p:cxnSp>
+        <p:nvCxnSpPr>
+          <p:cNvPr id="5" name="Connector 4"/>
+          <p:cNvCxnSpPr/>
+          <p:nvPr/>
+        </p:nvCxnSpPr>
+        <p:spPr>
+          <a:xfrm>
+            <a:off x="548640" y="1417320"/>
+            <a:ext cx="11091672" cy="0"/>
+          </a:xfrm>
+          <a:prstGeom prst="line">
+            <a:avLst/>
+          </a:prstGeom>
+          <a:ln w="28575">
+            <a:solidFill>
+              <a:srgbClr val="0066CC"/>
+            </a:solidFill>
+          </a:ln>
+        </p:spPr>
+        <p:style>
+          <a:lnRef idx="2">
+            <a:schemeClr val="accent1"/>
+          </a:lnRef>
+          <a:fillRef idx="0">
+            <a:schemeClr val="accent1"/>
+          </a:fillRef>
+          <a:effectRef idx="1">
+            <a:schemeClr val="accent1"/>
+          </a:effectRef>
+          <a:fontRef idx="minor">
+            <a:schemeClr val="tx1"/>
+          </a:fontRef>
+        </p:style>
+      </p:cxnSp>
+      <p:sp>
+        <p:nvSpPr>
+          <p:cNvPr id="6" name="TextBox 5"/>
+          <p:cNvSpPr txBox="1"/>
+          <p:nvPr/>
+        </p:nvSpPr>
+        <p:spPr>
+          <a:xfrm>
+            <a:off x="548640" y="6473952"/>
+            <a:ext cx="8229600" cy="320040"/>
           </a:xfrm>
           <a:prstGeom prst="rect">
             <a:avLst/>
@@ -18370,15 +18442,185 @@
           <a:lstStyle/>
           <a:p>
             <a:pPr>
-              <a:defRPr sz="1800">
-                <a:solidFill>
-                  <a:srgbClr val="9FC5FF"/>
-                </a:solidFill>
-                <a:latin typeface="Consolas"/>
+              <a:defRPr sz="1100">
+                <a:solidFill>
+                  <a:srgbClr val="555555"/>
+                </a:solidFill>
+                <a:latin typeface="Segoe UI"/>
               </a:defRPr>
             </a:pPr>
             <a:r>
-              <a:t>C:\apps\padb\tools   |   /padb-tools</a:t>
+              <a:t>padb-tools</a:t>
+            </a:r>
+          </a:p>
+        </p:txBody>
+      </p:sp>
+      <p:sp>
+        <p:nvSpPr>
+          <p:cNvPr id="7" name="TextBox 6"/>
+          <p:cNvSpPr txBox="1"/>
+          <p:nvPr/>
+        </p:nvSpPr>
+        <p:spPr>
+          <a:xfrm>
+            <a:off x="11338560" y="6473952"/>
+            <a:ext cx="548640" cy="320040"/>
+          </a:xfrm>
+          <a:prstGeom prst="rect">
+            <a:avLst/>
+          </a:prstGeom>
+          <a:noFill/>
+        </p:spPr>
+        <p:txBody>
+          <a:bodyPr wrap="none">
+            <a:spAutoFit/>
+          </a:bodyPr>
+          <a:lstStyle/>
+          <a:p>
+            <a:pPr algn="r">
+              <a:defRPr sz="1100">
+                <a:solidFill>
+                  <a:srgbClr val="555555"/>
+                </a:solidFill>
+              </a:defRPr>
+            </a:pPr>
+            <a:r>
+              <a:t>42</a:t>
+            </a:r>
+          </a:p>
+        </p:txBody>
+      </p:sp>
+      <p:sp>
+        <p:nvSpPr>
+          <p:cNvPr id="8" name="TextBox 7"/>
+          <p:cNvSpPr txBox="1"/>
+          <p:nvPr/>
+        </p:nvSpPr>
+        <p:spPr>
+          <a:xfrm>
+            <a:off x="548640" y="1645920"/>
+            <a:ext cx="11064240" cy="4754880"/>
+          </a:xfrm>
+          <a:prstGeom prst="rect">
+            <a:avLst/>
+          </a:prstGeom>
+          <a:noFill/>
+        </p:spPr>
+        <p:txBody>
+          <a:bodyPr wrap="square">
+            <a:spAutoFit/>
+          </a:bodyPr>
+          <a:lstStyle/>
+          <a:p>
+            <a:pPr>
+              <a:spcAft>
+                <a:spcPts val="1000"/>
+              </a:spcAft>
+            </a:pPr>
+            <a:r>
+              <a:rPr sz="1700">
+                <a:solidFill>
+                  <a:srgbClr val="1B2A4A"/>
+                </a:solidFill>
+                <a:latin typeface="Segoe UI"/>
+              </a:rPr>
+              <a:t>•  Compares two sites' data (e.g. an established site vs. a newly-stood-up site) without hand-merging CSVs</a:t>
+            </a:r>
+          </a:p>
+          <a:p>
+            <a:pPr>
+              <a:spcAft>
+                <a:spcPts val="1000"/>
+              </a:spcAft>
+            </a:pPr>
+            <a:r>
+              <a:rPr sz="1700">
+                <a:solidFill>
+                  <a:srgbClr val="1B2A4A"/>
+                </a:solidFill>
+                <a:latin typeface="Segoe UI"/>
+              </a:rPr>
+              <a:t>•  job.json: "compare_csv": {"SR": "path...", "AMC2": "path..."}, "primary_site": "SR"</a:t>
+            </a:r>
+          </a:p>
+          <a:p>
+            <a:pPr lvl="1">
+              <a:spcAft>
+                <a:spcPts val="1000"/>
+              </a:spcAft>
+            </a:pPr>
+            <a:r>
+              <a:rPr sz="1500">
+                <a:solidFill>
+                  <a:srgbClr val="1B2A4A"/>
+                </a:solidFill>
+                <a:latin typeface="Segoe UI"/>
+              </a:rPr>
+              <a:t>–  primary_site is the reference population for the boxplot check below — no effect on other views</a:t>
+            </a:r>
+          </a:p>
+          <a:p>
+            <a:pPr>
+              <a:spcAft>
+                <a:spcPts val="1000"/>
+              </a:spcAft>
+            </a:pPr>
+            <a:r>
+              <a:rPr sz="1700">
+                <a:solidFill>
+                  <a:srgbClr val="1B2A4A"/>
+                </a:solidFill>
+                <a:latin typeface="Segoe UI"/>
+              </a:rPr>
+              <a:t>•  Mechanism: each site's own CSV is tagged "Site: &lt;name&gt;" in its Group text and merged — the normal single-CSV pipeline runs completely unchanged</a:t>
+            </a:r>
+          </a:p>
+          <a:p>
+            <a:pPr lvl="1">
+              <a:spcAft>
+                <a:spcPts val="1000"/>
+              </a:spcAft>
+            </a:pPr>
+            <a:r>
+              <a:rPr sz="1500">
+                <a:solidFill>
+                  <a:srgbClr val="1B2A4A"/>
+                </a:solidFill>
+                <a:latin typeface="Segoe UI"/>
+              </a:rPr>
+              <a:t>–  "Site" becomes a real, filterable/groupable condition dimension for free, same as Port or Serial</a:t>
+            </a:r>
+          </a:p>
+          <a:p>
+            <a:pPr>
+              <a:spcAft>
+                <a:spcPts val="1000"/>
+              </a:spcAft>
+            </a:pPr>
+            <a:r>
+              <a:rPr sz="1700">
+                <a:solidFill>
+                  <a:srgbClr val="1B2A4A"/>
+                </a:solidFill>
+                <a:latin typeface="Segoe UI"/>
+              </a:rPr>
+              <a:t>•  Deliberately tolerant of imperfect data — mismatched columns, one site missing spec limits, narrower temperature/port coverage are all expected, not errors</a:t>
+            </a:r>
+          </a:p>
+          <a:p>
+            <a:pPr>
+              <a:spcAft>
+                <a:spcPts val="1000"/>
+              </a:spcAft>
+            </a:pPr>
+            <a:r>
+              <a:rPr sz="1700">
+                <a:solidFill>
+                  <a:srgbClr val="1B2A4A"/>
+                </a:solidFill>
+                <a:latin typeface="Segoe UI"/>
+              </a:rPr>
+              <a:t>•  An always-visible banner flags real coverage gaps between sites (e.g. missing temperatures/ports) — numeric formatting differences between sites never falsely count as a gap</a:t>
             </a:r>
           </a:p>
         </p:txBody>
@@ -18416,7 +18658,7 @@
             <a:avLst/>
           </a:prstGeom>
           <a:solidFill>
-            <a:srgbClr val="F2F4F8"/>
+            <a:srgbClr val="FFFFFF"/>
           </a:solidFill>
           <a:ln>
             <a:noFill/>
@@ -18453,8 +18695,8 @@
         </p:nvSpPr>
         <p:spPr>
           <a:xfrm>
-            <a:off x="822960" y="2743200"/>
-            <a:ext cx="10515600" cy="914400"/>
+            <a:off x="548640" y="320040"/>
+            <a:ext cx="7315200" cy="365760"/>
           </a:xfrm>
           <a:prstGeom prst="rect">
             <a:avLst/>
@@ -18468,28 +18710,100 @@
           <a:lstStyle/>
           <a:p>
             <a:pPr>
-              <a:defRPr sz="4400" b="1">
+              <a:defRPr sz="1600" b="1">
+                <a:solidFill>
+                  <a:srgbClr val="0066CC"/>
+                </a:solidFill>
+                <a:latin typeface="Segoe UI"/>
+              </a:defRPr>
+            </a:pPr>
+            <a:r>
+              <a:t>Multi-Site Testing</a:t>
+            </a:r>
+          </a:p>
+        </p:txBody>
+      </p:sp>
+      <p:sp>
+        <p:nvSpPr>
+          <p:cNvPr id="4" name="TextBox 3"/>
+          <p:cNvSpPr txBox="1"/>
+          <p:nvPr/>
+        </p:nvSpPr>
+        <p:spPr>
+          <a:xfrm>
+            <a:off x="548640" y="658368"/>
+            <a:ext cx="11064240" cy="822960"/>
+          </a:xfrm>
+          <a:prstGeom prst="rect">
+            <a:avLst/>
+          </a:prstGeom>
+          <a:noFill/>
+        </p:spPr>
+        <p:txBody>
+          <a:bodyPr wrap="square">
+            <a:spAutoFit/>
+          </a:bodyPr>
+          <a:lstStyle/>
+          <a:p>
+            <a:pPr>
+              <a:defRPr sz="3200" b="1">
                 <a:solidFill>
                   <a:srgbClr val="1B2A4A"/>
                 </a:solidFill>
+                <a:latin typeface="Segoe UI"/>
               </a:defRPr>
             </a:pPr>
             <a:r>
-              <a:t>Appendix</a:t>
-            </a:r>
-          </a:p>
-        </p:txBody>
-      </p:sp>
-      <p:sp>
-        <p:nvSpPr>
-          <p:cNvPr id="4" name="TextBox 3"/>
-          <p:cNvSpPr txBox="1"/>
-          <p:nvPr/>
-        </p:nvSpPr>
-        <p:spPr>
-          <a:xfrm>
-            <a:off x="822960" y="3566160"/>
-            <a:ext cx="10515600" cy="640080"/>
+              <a:t>Site Population Check — DUT or Station?</a:t>
+            </a:r>
+          </a:p>
+        </p:txBody>
+      </p:sp>
+      <p:cxnSp>
+        <p:nvCxnSpPr>
+          <p:cNvPr id="5" name="Connector 4"/>
+          <p:cNvCxnSpPr/>
+          <p:nvPr/>
+        </p:nvCxnSpPr>
+        <p:spPr>
+          <a:xfrm>
+            <a:off x="548640" y="1417320"/>
+            <a:ext cx="11091672" cy="0"/>
+          </a:xfrm>
+          <a:prstGeom prst="line">
+            <a:avLst/>
+          </a:prstGeom>
+          <a:ln w="28575">
+            <a:solidFill>
+              <a:srgbClr val="0066CC"/>
+            </a:solidFill>
+          </a:ln>
+        </p:spPr>
+        <p:style>
+          <a:lnRef idx="2">
+            <a:schemeClr val="accent1"/>
+          </a:lnRef>
+          <a:fillRef idx="0">
+            <a:schemeClr val="accent1"/>
+          </a:fillRef>
+          <a:effectRef idx="1">
+            <a:schemeClr val="accent1"/>
+          </a:effectRef>
+          <a:fontRef idx="minor">
+            <a:schemeClr val="tx1"/>
+          </a:fontRef>
+        </p:style>
+      </p:cxnSp>
+      <p:sp>
+        <p:nvSpPr>
+          <p:cNvPr id="6" name="TextBox 5"/>
+          <p:cNvSpPr txBox="1"/>
+          <p:nvPr/>
+        </p:nvSpPr>
+        <p:spPr>
+          <a:xfrm>
+            <a:off x="548640" y="6473952"/>
+            <a:ext cx="8229600" cy="320040"/>
           </a:xfrm>
           <a:prstGeom prst="rect">
             <a:avLst/>
@@ -18503,14 +18817,169 @@
           <a:lstStyle/>
           <a:p>
             <a:pPr>
-              <a:defRPr sz="2200">
-                <a:solidFill>
-                  <a:srgbClr val="0066CC"/>
-                </a:solidFill>
+              <a:defRPr sz="1100">
+                <a:solidFill>
+                  <a:srgbClr val="555555"/>
+                </a:solidFill>
+                <a:latin typeface="Segoe UI"/>
               </a:defRPr>
             </a:pPr>
             <a:r>
-              <a:t>Setting Up From Zero — Assumes No Prior Access</a:t>
+              <a:t>padb-tools</a:t>
+            </a:r>
+          </a:p>
+        </p:txBody>
+      </p:sp>
+      <p:sp>
+        <p:nvSpPr>
+          <p:cNvPr id="7" name="TextBox 6"/>
+          <p:cNvSpPr txBox="1"/>
+          <p:nvPr/>
+        </p:nvSpPr>
+        <p:spPr>
+          <a:xfrm>
+            <a:off x="11338560" y="6473952"/>
+            <a:ext cx="548640" cy="320040"/>
+          </a:xfrm>
+          <a:prstGeom prst="rect">
+            <a:avLst/>
+          </a:prstGeom>
+          <a:noFill/>
+        </p:spPr>
+        <p:txBody>
+          <a:bodyPr wrap="none">
+            <a:spAutoFit/>
+          </a:bodyPr>
+          <a:lstStyle/>
+          <a:p>
+            <a:pPr algn="r">
+              <a:defRPr sz="1100">
+                <a:solidFill>
+                  <a:srgbClr val="555555"/>
+                </a:solidFill>
+              </a:defRPr>
+            </a:pPr>
+            <a:r>
+              <a:t>43</a:t>
+            </a:r>
+          </a:p>
+        </p:txBody>
+      </p:sp>
+      <p:sp>
+        <p:nvSpPr>
+          <p:cNvPr id="8" name="TextBox 7"/>
+          <p:cNvSpPr txBox="1"/>
+          <p:nvPr/>
+        </p:nvSpPr>
+        <p:spPr>
+          <a:xfrm>
+            <a:off x="548640" y="1645920"/>
+            <a:ext cx="11064240" cy="4754880"/>
+          </a:xfrm>
+          <a:prstGeom prst="rect">
+            <a:avLst/>
+          </a:prstGeom>
+          <a:noFill/>
+        </p:spPr>
+        <p:txBody>
+          <a:bodyPr wrap="square">
+            <a:spAutoFit/>
+          </a:bodyPr>
+          <a:lstStyle/>
+          <a:p>
+            <a:pPr>
+              <a:spcAft>
+                <a:spcPts val="1000"/>
+              </a:spcAft>
+            </a:pPr>
+            <a:r>
+              <a:rPr sz="1700">
+                <a:solidFill>
+                  <a:srgbClr val="1B2A4A"/>
+                </a:solidFill>
+                <a:latin typeface="Segoe UI"/>
+              </a:rPr>
+              <a:t>•  Tests each non-primary-site DUT's value at each frequency/temperature against the k×IQR fence built from the primary site's own population there</a:t>
+            </a:r>
+          </a:p>
+          <a:p>
+            <a:pPr lvl="1">
+              <a:spcAft>
+                <a:spcPts val="1000"/>
+              </a:spcAft>
+            </a:pPr>
+            <a:r>
+              <a:rPr sz="1500">
+                <a:solidFill>
+                  <a:srgbClr val="1B2A4A"/>
+                </a:solidFill>
+                <a:latin typeface="Segoe UI"/>
+              </a:rPr>
+              <a:t>–  Reuses the exact fence and live k×IQR control the page's own outlier detection already uses — no new statistical method</a:t>
+            </a:r>
+          </a:p>
+          <a:p>
+            <a:pPr>
+              <a:spcAft>
+                <a:spcPts val="1000"/>
+              </a:spcAft>
+            </a:pPr>
+            <a:r>
+              <a:rPr sz="1700">
+                <a:solidFill>
+                  <a:srgbClr val="1B2A4A"/>
+                </a:solidFill>
+                <a:latin typeface="Segoe UI"/>
+              </a:rPr>
+              <a:t>•  Per-DUT summary — checked/outside counts, high/low split, and how many of a DUT's outside points are shared with another DUT at the same spot</a:t>
+            </a:r>
+          </a:p>
+          <a:p>
+            <a:pPr>
+              <a:spcAft>
+                <a:spcPts val="1000"/>
+              </a:spcAft>
+            </a:pPr>
+            <a:r>
+              <a:rPr sz="1700">
+                <a:solidFill>
+                  <a:srgbClr val="1B2A4A"/>
+                </a:solidFill>
+                <a:latin typeface="Segoe UI"/>
+              </a:rPr>
+              <a:t>•  Frequency clusters — every (temp, freq) where 2+ distinct DUTs are simultaneously outside — the strongest signal for a station/fixture issue, not one bad DUT</a:t>
+            </a:r>
+          </a:p>
+          <a:p>
+            <a:pPr>
+              <a:spcAft>
+                <a:spcPts val="1000"/>
+              </a:spcAft>
+            </a:pPr>
+            <a:r>
+              <a:rPr sz="1700">
+                <a:solidFill>
+                  <a:srgbClr val="1B2A4A"/>
+                </a:solidFill>
+                <a:latin typeface="Segoe UI"/>
+              </a:rPr>
+              <a:t>•  Suggested triage tag per DUT: station/systemic &gt; bad DUT &gt; isolated &gt; below-population (benign) &gt; ambiguous — a suggestion, not a verdict</a:t>
+            </a:r>
+          </a:p>
+          <a:p>
+            <a:pPr>
+              <a:spcAft>
+                <a:spcPts val="1000"/>
+              </a:spcAft>
+            </a:pPr>
+            <a:r>
+              <a:rPr sz="1700">
+                <a:solidFill>
+                  <a:srgbClr val="1B2A4A"/>
+                </a:solidFill>
+                <a:latin typeface="Segoe UI"/>
+              </a:rPr>
+              <a:t>•  Real finding on ClockSpurs SR-vs-AMC2 data: all 8 AMC2 DUTs came back "Likely station/systemic," reading systematically quieter than SR — a site calibration signature, not 8 bad units</a:t>
             </a:r>
           </a:p>
         </p:txBody>
@@ -18608,7 +19077,7 @@
               </a:defRPr>
             </a:pPr>
             <a:r>
-              <a:t>Appendix</a:t>
+              <a:t>Multi-Site Testing</a:t>
             </a:r>
           </a:p>
         </p:txBody>
@@ -18644,7 +19113,7 @@
               </a:defRPr>
             </a:pPr>
             <a:r>
-              <a:t>Getting the Code</a:t>
+              <a:t>Webapp: Compare Two Datasets</a:t>
             </a:r>
           </a:p>
         </p:txBody>
@@ -18750,7 +19219,7 @@
               </a:defRPr>
             </a:pPr>
             <a:r>
-              <a:t>43</a:t>
+              <a:t>44</a:t>
             </a:r>
           </a:p>
         </p:txBody>
@@ -18763,8 +19232,8 @@
         </p:nvSpPr>
         <p:spPr>
           <a:xfrm>
-            <a:off x="548640" y="1691640"/>
-            <a:ext cx="11064240" cy="365760"/>
+            <a:off x="548640" y="1645920"/>
+            <a:ext cx="11064240" cy="4754880"/>
           </a:xfrm>
           <a:prstGeom prst="rect">
             <a:avLst/>
@@ -18783,99 +19252,15 @@
               </a:spcAft>
             </a:pPr>
             <a:r>
-              <a:rPr sz="1900">
+              <a:rPr sz="1700">
                 <a:solidFill>
                   <a:srgbClr val="1B2A4A"/>
                 </a:solidFill>
                 <a:latin typeface="Segoe UI"/>
               </a:rPr>
-              <a:t>•  This repo isn't on a company-wide share by default — copy it from:</a:t>
-            </a:r>
-          </a:p>
-        </p:txBody>
-      </p:sp>
-      <p:sp>
-        <p:nvSpPr>
-          <p:cNvPr id="9" name="Rounded Rectangle 8"/>
-          <p:cNvSpPr/>
-          <p:nvPr/>
-        </p:nvSpPr>
-        <p:spPr>
-          <a:xfrm>
-            <a:off x="548640" y="2103120"/>
-            <a:ext cx="11064240" cy="502920"/>
-          </a:xfrm>
-          <a:prstGeom prst="roundRect">
-            <a:avLst>
-              <a:gd name="adj" fmla="val 4000"/>
-            </a:avLst>
-          </a:prstGeom>
-          <a:solidFill>
-            <a:srgbClr val="282C34"/>
-          </a:solidFill>
-          <a:ln>
-            <a:solidFill>
-              <a:srgbClr val="111318"/>
-            </a:solidFill>
-          </a:ln>
-          <a:effectLst/>
-        </p:spPr>
-        <p:style>
-          <a:lnRef idx="1">
-            <a:schemeClr val="accent1"/>
-          </a:lnRef>
-          <a:fillRef idx="3">
-            <a:schemeClr val="accent1"/>
-          </a:fillRef>
-          <a:effectRef idx="2">
-            <a:schemeClr val="accent1"/>
-          </a:effectRef>
-          <a:fontRef idx="minor">
-            <a:schemeClr val="lt1"/>
-          </a:fontRef>
-        </p:style>
-        <p:txBody>
-          <a:bodyPr rtlCol="0" anchor="t" wrap="square" lIns="228600" rIns="228600" tIns="164592" bIns="164592"/>
-          <a:lstStyle/>
-          <a:p>
-            <a:pPr algn="l">
-              <a:spcAft>
-                <a:spcPts val="200"/>
-              </a:spcAft>
-            </a:pPr>
-            <a:r>
-              <a:rPr sz="1350">
-                <a:solidFill>
-                  <a:srgbClr val="E6E6E6"/>
-                </a:solidFill>
-                <a:latin typeface="Consolas"/>
-              </a:rPr>
-              <a:t>\\srsnas01.srs.is.keysight.com\prod\MIDRF3\SG6311A\Padb-tools\tools</a:t>
-            </a:r>
-          </a:p>
-        </p:txBody>
-      </p:sp>
-      <p:sp>
-        <p:nvSpPr>
-          <p:cNvPr id="10" name="TextBox 9"/>
-          <p:cNvSpPr txBox="1"/>
-          <p:nvPr/>
-        </p:nvSpPr>
-        <p:spPr>
-          <a:xfrm>
-            <a:off x="548640" y="2788920"/>
-            <a:ext cx="11064240" cy="365760"/>
-          </a:xfrm>
-          <a:prstGeom prst="rect">
-            <a:avLst/>
-          </a:prstGeom>
-          <a:noFill/>
-        </p:spPr>
-        <p:txBody>
-          <a:bodyPr wrap="square">
-            <a:spAutoFit/>
-          </a:bodyPr>
-          <a:lstStyle/>
+              <a:t>•  Collapsed-by-default panel in the web app (a corner case — mainly useful the first time a new site comes online)</a:t>
+            </a:r>
+          </a:p>
           <a:p>
             <a:pPr>
               <a:spcAft>
@@ -18883,38 +19268,15 @@
               </a:spcAft>
             </a:pPr>
             <a:r>
-              <a:rPr sz="1800">
+              <a:rPr sz="1700">
                 <a:solidFill>
                   <a:srgbClr val="1B2A4A"/>
                 </a:solidFill>
                 <a:latin typeface="Segoe UI"/>
               </a:rPr>
-              <a:t>•  Copy that whole "tools" folder to a local path, e.g. C:\apps\padb\tools</a:t>
-            </a:r>
-          </a:p>
-        </p:txBody>
-      </p:sp>
-      <p:sp>
-        <p:nvSpPr>
-          <p:cNvPr id="11" name="TextBox 10"/>
-          <p:cNvSpPr txBox="1"/>
-          <p:nvPr/>
-        </p:nvSpPr>
-        <p:spPr>
-          <a:xfrm>
-            <a:off x="548640" y="3429000"/>
-            <a:ext cx="11064240" cy="914400"/>
-          </a:xfrm>
-          <a:prstGeom prst="rect">
-            <a:avLst/>
-          </a:prstGeom>
-          <a:noFill/>
-        </p:spPr>
-        <p:txBody>
-          <a:bodyPr wrap="square">
-            <a:spAutoFit/>
-          </a:bodyPr>
-          <a:lstStyle/>
+              <a:t>•  Pick two already-extracted CSVs (auto-discovered from disk), name each site, pick the primary, and Create &amp; Run in one step — no hand-written job.json needed</a:t>
+            </a:r>
+          </a:p>
           <a:p>
             <a:pPr>
               <a:spcAft>
@@ -18928,48 +19290,25 @@
                 </a:solidFill>
                 <a:latin typeface="Segoe UI"/>
               </a:rPr>
-              <a:t>•  padb_batch.py is bundled directly inside the tools folder (added 2026-08-05) —</a:t>
+              <a:t>•  Validates first: a genuine measurement-unit mismatch (e.g. dBc vs. dBm) blocks with an explanation, with an explicit override to proceed anyway</a:t>
             </a:r>
           </a:p>
           <a:p>
             <a:pPr lvl="1">
               <a:spcAft>
-                <a:spcPts val="600"/>
+                <a:spcPts val="1000"/>
               </a:spcAft>
             </a:pPr>
             <a:r>
               <a:rPr sz="1500">
                 <a:solidFill>
-                  <a:srgbClr val="555555"/>
-                </a:solidFill>
-                <a:latin typeface="Segoe UI"/>
-              </a:rPr>
-              <a:t>–  no separate dependency to track down; the whole repo is self-contained</a:t>
-            </a:r>
-          </a:p>
-        </p:txBody>
-      </p:sp>
-      <p:sp>
-        <p:nvSpPr>
-          <p:cNvPr id="12" name="TextBox 11"/>
-          <p:cNvSpPr txBox="1"/>
-          <p:nvPr/>
-        </p:nvSpPr>
-        <p:spPr>
-          <a:xfrm>
-            <a:off x="548640" y="4480560"/>
-            <a:ext cx="11064240" cy="457200"/>
-          </a:xfrm>
-          <a:prstGeom prst="rect">
-            <a:avLst/>
-          </a:prstGeom>
-          <a:noFill/>
-        </p:spPr>
-        <p:txBody>
-          <a:bodyPr wrap="square">
-            <a:spAutoFit/>
-          </a:bodyPr>
-          <a:lstStyle/>
+                  <a:srgbClr val="1B2A4A"/>
+                </a:solidFill>
+                <a:latin typeface="Segoe UI"/>
+              </a:rPr>
+              <a:t>–  Softer gaps — missing temperatures/ports, non-overlapping frequency ranges — only warn, never block</a:t>
+            </a:r>
+          </a:p>
           <a:p>
             <a:pPr>
               <a:spcAft>
@@ -18977,13 +19316,29 @@
               </a:spcAft>
             </a:pPr>
             <a:r>
-              <a:rPr sz="1650">
+              <a:rPr sz="1700">
                 <a:solidFill>
                   <a:srgbClr val="1B2A4A"/>
                 </a:solidFill>
                 <a:latin typeface="Segoe UI"/>
               </a:rPr>
-              <a:t>•  Then follow the Prerequisites and Per-User Config slides earlier in this deck</a:t>
+              <a:t>•  New job defaults to local-only (publish_to left empty) — publishing an ad-hoc comparison test is a deliberate, separate choice</a:t>
+            </a:r>
+          </a:p>
+          <a:p>
+            <a:pPr>
+              <a:spcAft>
+                <a:spcPts val="1000"/>
+              </a:spcAft>
+            </a:pPr>
+            <a:r>
+              <a:rPr sz="1700">
+                <a:solidFill>
+                  <a:srgbClr val="1B2A4A"/>
+                </a:solidFill>
+                <a:latin typeface="Segoe UI"/>
+              </a:rPr>
+              <a:t>•  "Show tooltip help" checkbox (top of every page) toggles hover help across the whole app on/off, remembered across reloads</a:t>
             </a:r>
           </a:p>
         </p:txBody>
@@ -19021,7 +19376,7 @@
             <a:avLst/>
           </a:prstGeom>
           <a:solidFill>
-            <a:srgbClr val="FFFFFF"/>
+            <a:srgbClr val="1B2A4A"/>
           </a:solidFill>
           <a:ln>
             <a:noFill/>
@@ -19058,8 +19413,8 @@
         </p:nvSpPr>
         <p:spPr>
           <a:xfrm>
-            <a:off x="548640" y="320040"/>
-            <a:ext cx="7315200" cy="365760"/>
+            <a:off x="822960" y="2743200"/>
+            <a:ext cx="10515600" cy="1097280"/>
           </a:xfrm>
           <a:prstGeom prst="rect">
             <a:avLst/>
@@ -19073,15 +19428,14 @@
           <a:lstStyle/>
           <a:p>
             <a:pPr>
-              <a:defRPr sz="1600" b="1">
-                <a:solidFill>
-                  <a:srgbClr val="0066CC"/>
-                </a:solidFill>
-                <a:latin typeface="Segoe UI"/>
+              <a:defRPr sz="4800" b="1">
+                <a:solidFill>
+                  <a:srgbClr val="FFFFFF"/>
+                </a:solidFill>
               </a:defRPr>
             </a:pPr>
             <a:r>
-              <a:t>Appendix</a:t>
+              <a:t>Questions?</a:t>
             </a:r>
           </a:p>
         </p:txBody>
@@ -19094,446 +19448,30 @@
         </p:nvSpPr>
         <p:spPr>
           <a:xfrm>
-            <a:off x="548640" y="658368"/>
-            <a:ext cx="11064240" cy="822960"/>
-          </a:xfrm>
-          <a:prstGeom prst="rect">
-            <a:avLst/>
-          </a:prstGeom>
-          <a:noFill/>
-        </p:spPr>
-        <p:txBody>
-          <a:bodyPr wrap="square">
-            <a:spAutoFit/>
-          </a:bodyPr>
-          <a:lstStyle/>
-          <a:p>
-            <a:pPr>
-              <a:defRPr sz="3200" b="1">
-                <a:solidFill>
-                  <a:srgbClr val="1B2A4A"/>
-                </a:solidFill>
-                <a:latin typeface="Segoe UI"/>
+            <a:off x="822960" y="3749039"/>
+            <a:ext cx="10515600" cy="640080"/>
+          </a:xfrm>
+          <a:prstGeom prst="rect">
+            <a:avLst/>
+          </a:prstGeom>
+          <a:noFill/>
+        </p:spPr>
+        <p:txBody>
+          <a:bodyPr wrap="none">
+            <a:spAutoFit/>
+          </a:bodyPr>
+          <a:lstStyle/>
+          <a:p>
+            <a:pPr>
+              <a:defRPr sz="1800">
+                <a:solidFill>
+                  <a:srgbClr val="9FC5FF"/>
+                </a:solidFill>
+                <a:latin typeface="Consolas"/>
               </a:defRPr>
             </a:pPr>
             <a:r>
-              <a:t>First Commands to Verify Your Setup</a:t>
-            </a:r>
-          </a:p>
-        </p:txBody>
-      </p:sp>
-      <p:cxnSp>
-        <p:nvCxnSpPr>
-          <p:cNvPr id="5" name="Connector 4"/>
-          <p:cNvCxnSpPr/>
-          <p:nvPr/>
-        </p:nvCxnSpPr>
-        <p:spPr>
-          <a:xfrm>
-            <a:off x="548640" y="1417320"/>
-            <a:ext cx="11091672" cy="0"/>
-          </a:xfrm>
-          <a:prstGeom prst="line">
-            <a:avLst/>
-          </a:prstGeom>
-          <a:ln w="28575">
-            <a:solidFill>
-              <a:srgbClr val="0066CC"/>
-            </a:solidFill>
-          </a:ln>
-        </p:spPr>
-        <p:style>
-          <a:lnRef idx="2">
-            <a:schemeClr val="accent1"/>
-          </a:lnRef>
-          <a:fillRef idx="0">
-            <a:schemeClr val="accent1"/>
-          </a:fillRef>
-          <a:effectRef idx="1">
-            <a:schemeClr val="accent1"/>
-          </a:effectRef>
-          <a:fontRef idx="minor">
-            <a:schemeClr val="tx1"/>
-          </a:fontRef>
-        </p:style>
-      </p:cxnSp>
-      <p:sp>
-        <p:nvSpPr>
-          <p:cNvPr id="6" name="TextBox 5"/>
-          <p:cNvSpPr txBox="1"/>
-          <p:nvPr/>
-        </p:nvSpPr>
-        <p:spPr>
-          <a:xfrm>
-            <a:off x="548640" y="6473952"/>
-            <a:ext cx="8229600" cy="320040"/>
-          </a:xfrm>
-          <a:prstGeom prst="rect">
-            <a:avLst/>
-          </a:prstGeom>
-          <a:noFill/>
-        </p:spPr>
-        <p:txBody>
-          <a:bodyPr wrap="none">
-            <a:spAutoFit/>
-          </a:bodyPr>
-          <a:lstStyle/>
-          <a:p>
-            <a:pPr>
-              <a:defRPr sz="1100">
-                <a:solidFill>
-                  <a:srgbClr val="555555"/>
-                </a:solidFill>
-                <a:latin typeface="Segoe UI"/>
-              </a:defRPr>
-            </a:pPr>
-            <a:r>
-              <a:t>padb-tools</a:t>
-            </a:r>
-          </a:p>
-        </p:txBody>
-      </p:sp>
-      <p:sp>
-        <p:nvSpPr>
-          <p:cNvPr id="7" name="TextBox 6"/>
-          <p:cNvSpPr txBox="1"/>
-          <p:nvPr/>
-        </p:nvSpPr>
-        <p:spPr>
-          <a:xfrm>
-            <a:off x="11338560" y="6473952"/>
-            <a:ext cx="548640" cy="320040"/>
-          </a:xfrm>
-          <a:prstGeom prst="rect">
-            <a:avLst/>
-          </a:prstGeom>
-          <a:noFill/>
-        </p:spPr>
-        <p:txBody>
-          <a:bodyPr wrap="none">
-            <a:spAutoFit/>
-          </a:bodyPr>
-          <a:lstStyle/>
-          <a:p>
-            <a:pPr algn="r">
-              <a:defRPr sz="1100">
-                <a:solidFill>
-                  <a:srgbClr val="555555"/>
-                </a:solidFill>
-              </a:defRPr>
-            </a:pPr>
-            <a:r>
-              <a:t>44</a:t>
-            </a:r>
-          </a:p>
-        </p:txBody>
-      </p:sp>
-      <p:sp>
-        <p:nvSpPr>
-          <p:cNvPr id="8" name="TextBox 7"/>
-          <p:cNvSpPr txBox="1"/>
-          <p:nvPr/>
-        </p:nvSpPr>
-        <p:spPr>
-          <a:xfrm>
-            <a:off x="548640" y="1691640"/>
-            <a:ext cx="11064240" cy="365760"/>
-          </a:xfrm>
-          <a:prstGeom prst="rect">
-            <a:avLst/>
-          </a:prstGeom>
-          <a:noFill/>
-        </p:spPr>
-        <p:txBody>
-          <a:bodyPr wrap="square">
-            <a:spAutoFit/>
-          </a:bodyPr>
-          <a:lstStyle/>
-          <a:p>
-            <a:pPr>
-              <a:spcAft>
-                <a:spcPts val="1000"/>
-              </a:spcAft>
-            </a:pPr>
-            <a:r>
-              <a:rPr sz="1800">
-                <a:solidFill>
-                  <a:srgbClr val="1B2A4A"/>
-                </a:solidFill>
-                <a:latin typeface="Segoe UI"/>
-              </a:rPr>
-              <a:t>•  From inside the tools folder, confirm everything imports cleanly:</a:t>
-            </a:r>
-          </a:p>
-        </p:txBody>
-      </p:sp>
-      <p:sp>
-        <p:nvSpPr>
-          <p:cNvPr id="9" name="Rounded Rectangle 8"/>
-          <p:cNvSpPr/>
-          <p:nvPr/>
-        </p:nvSpPr>
-        <p:spPr>
-          <a:xfrm>
-            <a:off x="548640" y="2103120"/>
-            <a:ext cx="11064240" cy="502920"/>
-          </a:xfrm>
-          <a:prstGeom prst="roundRect">
-            <a:avLst>
-              <a:gd name="adj" fmla="val 4000"/>
-            </a:avLst>
-          </a:prstGeom>
-          <a:solidFill>
-            <a:srgbClr val="282C34"/>
-          </a:solidFill>
-          <a:ln>
-            <a:solidFill>
-              <a:srgbClr val="111318"/>
-            </a:solidFill>
-          </a:ln>
-          <a:effectLst/>
-        </p:spPr>
-        <p:style>
-          <a:lnRef idx="1">
-            <a:schemeClr val="accent1"/>
-          </a:lnRef>
-          <a:fillRef idx="3">
-            <a:schemeClr val="accent1"/>
-          </a:fillRef>
-          <a:effectRef idx="2">
-            <a:schemeClr val="accent1"/>
-          </a:effectRef>
-          <a:fontRef idx="minor">
-            <a:schemeClr val="lt1"/>
-          </a:fontRef>
-        </p:style>
-        <p:txBody>
-          <a:bodyPr rtlCol="0" anchor="t" wrap="square" lIns="228600" rIns="228600" tIns="164592" bIns="164592"/>
-          <a:lstStyle/>
-          <a:p>
-            <a:pPr algn="l">
-              <a:spcAft>
-                <a:spcPts val="200"/>
-              </a:spcAft>
-            </a:pPr>
-            <a:r>
-              <a:rPr sz="1450">
-                <a:solidFill>
-                  <a:srgbClr val="E6E6E6"/>
-                </a:solidFill>
-                <a:latin typeface="Consolas"/>
-              </a:rPr>
-              <a:t>py -c "import padb_run, padb_v2, padb_config"</a:t>
-            </a:r>
-          </a:p>
-        </p:txBody>
-      </p:sp>
-      <p:sp>
-        <p:nvSpPr>
-          <p:cNvPr id="10" name="TextBox 9"/>
-          <p:cNvSpPr txBox="1"/>
-          <p:nvPr/>
-        </p:nvSpPr>
-        <p:spPr>
-          <a:xfrm>
-            <a:off x="548640" y="2743200"/>
-            <a:ext cx="11064240" cy="365760"/>
-          </a:xfrm>
-          <a:prstGeom prst="rect">
-            <a:avLst/>
-          </a:prstGeom>
-          <a:noFill/>
-        </p:spPr>
-        <p:txBody>
-          <a:bodyPr wrap="square">
-            <a:spAutoFit/>
-          </a:bodyPr>
-          <a:lstStyle/>
-          <a:p>
-            <a:pPr>
-              <a:spcAft>
-                <a:spcPts val="1000"/>
-              </a:spcAft>
-            </a:pPr>
-            <a:r>
-              <a:rPr sz="1700">
-                <a:solidFill>
-                  <a:srgbClr val="1B2A4A"/>
-                </a:solidFill>
-                <a:latin typeface="Segoe UI"/>
-              </a:rPr>
-              <a:t>•  No output and no traceback = success</a:t>
-            </a:r>
-          </a:p>
-        </p:txBody>
-      </p:sp>
-      <p:sp>
-        <p:nvSpPr>
-          <p:cNvPr id="11" name="TextBox 10"/>
-          <p:cNvSpPr txBox="1"/>
-          <p:nvPr/>
-        </p:nvSpPr>
-        <p:spPr>
-          <a:xfrm>
-            <a:off x="548640" y="3291840"/>
-            <a:ext cx="11064240" cy="365760"/>
-          </a:xfrm>
-          <a:prstGeom prst="rect">
-            <a:avLst/>
-          </a:prstGeom>
-          <a:noFill/>
-        </p:spPr>
-        <p:txBody>
-          <a:bodyPr wrap="square">
-            <a:spAutoFit/>
-          </a:bodyPr>
-          <a:lstStyle/>
-          <a:p>
-            <a:pPr>
-              <a:spcAft>
-                <a:spcPts val="1000"/>
-              </a:spcAft>
-            </a:pPr>
-            <a:r>
-              <a:rPr sz="1800">
-                <a:solidFill>
-                  <a:srgbClr val="1B2A4A"/>
-                </a:solidFill>
-                <a:latin typeface="Segoe UI"/>
-              </a:rPr>
-              <a:t>•  Then generate your first job.json from any pod you have access to:</a:t>
-            </a:r>
-          </a:p>
-        </p:txBody>
-      </p:sp>
-      <p:sp>
-        <p:nvSpPr>
-          <p:cNvPr id="12" name="Rounded Rectangle 11"/>
-          <p:cNvSpPr/>
-          <p:nvPr/>
-        </p:nvSpPr>
-        <p:spPr>
-          <a:xfrm>
-            <a:off x="548640" y="3703320"/>
-            <a:ext cx="11064240" cy="502920"/>
-          </a:xfrm>
-          <a:prstGeom prst="roundRect">
-            <a:avLst>
-              <a:gd name="adj" fmla="val 4000"/>
-            </a:avLst>
-          </a:prstGeom>
-          <a:solidFill>
-            <a:srgbClr val="282C34"/>
-          </a:solidFill>
-          <a:ln>
-            <a:solidFill>
-              <a:srgbClr val="111318"/>
-            </a:solidFill>
-          </a:ln>
-          <a:effectLst/>
-        </p:spPr>
-        <p:style>
-          <a:lnRef idx="1">
-            <a:schemeClr val="accent1"/>
-          </a:lnRef>
-          <a:fillRef idx="3">
-            <a:schemeClr val="accent1"/>
-          </a:fillRef>
-          <a:effectRef idx="2">
-            <a:schemeClr val="accent1"/>
-          </a:effectRef>
-          <a:fontRef idx="minor">
-            <a:schemeClr val="lt1"/>
-          </a:fontRef>
-        </p:style>
-        <p:txBody>
-          <a:bodyPr rtlCol="0" anchor="t" wrap="square" lIns="228600" rIns="228600" tIns="164592" bIns="164592"/>
-          <a:lstStyle/>
-          <a:p>
-            <a:pPr algn="l">
-              <a:spcAft>
-                <a:spcPts val="200"/>
-              </a:spcAft>
-            </a:pPr>
-            <a:r>
-              <a:rPr sz="1450">
-                <a:solidFill>
-                  <a:srgbClr val="E6E6E6"/>
-                </a:solidFill>
-                <a:latin typeface="Consolas"/>
-              </a:rPr>
-              <a:t>py padb_make_job.py YourPod.pod --module YourModule</a:t>
-            </a:r>
-          </a:p>
-        </p:txBody>
-      </p:sp>
-      <p:sp>
-        <p:nvSpPr>
-          <p:cNvPr id="13" name="TextBox 12"/>
-          <p:cNvSpPr txBox="1"/>
-          <p:nvPr/>
-        </p:nvSpPr>
-        <p:spPr>
-          <a:xfrm>
-            <a:off x="548640" y="4343400"/>
-            <a:ext cx="11064240" cy="1463040"/>
-          </a:xfrm>
-          <a:prstGeom prst="rect">
-            <a:avLst/>
-          </a:prstGeom>
-          <a:noFill/>
-        </p:spPr>
-        <p:txBody>
-          <a:bodyPr wrap="square">
-            <a:spAutoFit/>
-          </a:bodyPr>
-          <a:lstStyle/>
-          <a:p>
-            <a:pPr>
-              <a:spcAft>
-                <a:spcPts val="1000"/>
-              </a:spcAft>
-            </a:pPr>
-            <a:r>
-              <a:rPr sz="1700">
-                <a:solidFill>
-                  <a:srgbClr val="1B2A4A"/>
-                </a:solidFill>
-                <a:latin typeface="Segoe UI"/>
-              </a:rPr>
-              <a:t>•  If PADB-R.exe launches and a real window briefly appears, you're fully set up</a:t>
-            </a:r>
-          </a:p>
-          <a:p>
-            <a:pPr>
-              <a:spcAft>
-                <a:spcPts val="1000"/>
-              </a:spcAft>
-            </a:pPr>
-            <a:r>
-              <a:rPr sz="1700">
-                <a:solidFill>
-                  <a:srgbClr val="1B2A4A"/>
-                </a:solidFill>
-                <a:latin typeface="Segoe UI"/>
-              </a:rPr>
-              <a:t>•  Stuck? GETTING_STARTED.md → Quick_Start.md, or type /padb-tools once you're</a:t>
-            </a:r>
-          </a:p>
-          <a:p>
-            <a:pPr lvl="1">
-              <a:spcAft>
-                <a:spcPts val="600"/>
-              </a:spcAft>
-            </a:pPr>
-            <a:r>
-              <a:rPr sz="1500">
-                <a:solidFill>
-                  <a:srgbClr val="555555"/>
-                </a:solidFill>
-                <a:latin typeface="Segoe UI"/>
-              </a:rPr>
-              <a:t>–  working inside the repo</a:t>
+              <a:t>C:\apps\padb\tools   |   /padb-tools</a:t>
             </a:r>
           </a:p>
         </p:txBody>
@@ -19571,7 +19509,7 @@
             <a:avLst/>
           </a:prstGeom>
           <a:solidFill>
-            <a:srgbClr val="FFFFFF"/>
+            <a:srgbClr val="F2F4F8"/>
           </a:solidFill>
           <a:ln>
             <a:noFill/>
@@ -19608,8 +19546,8 @@
         </p:nvSpPr>
         <p:spPr>
           <a:xfrm>
-            <a:off x="548640" y="320040"/>
-            <a:ext cx="7315200" cy="365760"/>
+            <a:off x="822960" y="2743200"/>
+            <a:ext cx="10515600" cy="914400"/>
           </a:xfrm>
           <a:prstGeom prst="rect">
             <a:avLst/>
@@ -19623,292 +19561,49 @@
           <a:lstStyle/>
           <a:p>
             <a:pPr>
-              <a:defRPr sz="1600" b="1">
+              <a:defRPr sz="4400" b="1">
+                <a:solidFill>
+                  <a:srgbClr val="1B2A4A"/>
+                </a:solidFill>
+              </a:defRPr>
+            </a:pPr>
+            <a:r>
+              <a:t>Appendix</a:t>
+            </a:r>
+          </a:p>
+        </p:txBody>
+      </p:sp>
+      <p:sp>
+        <p:nvSpPr>
+          <p:cNvPr id="4" name="TextBox 3"/>
+          <p:cNvSpPr txBox="1"/>
+          <p:nvPr/>
+        </p:nvSpPr>
+        <p:spPr>
+          <a:xfrm>
+            <a:off x="822960" y="3566160"/>
+            <a:ext cx="10515600" cy="640080"/>
+          </a:xfrm>
+          <a:prstGeom prst="rect">
+            <a:avLst/>
+          </a:prstGeom>
+          <a:noFill/>
+        </p:spPr>
+        <p:txBody>
+          <a:bodyPr wrap="none">
+            <a:spAutoFit/>
+          </a:bodyPr>
+          <a:lstStyle/>
+          <a:p>
+            <a:pPr>
+              <a:defRPr sz="2200">
                 <a:solidFill>
                   <a:srgbClr val="0066CC"/>
                 </a:solidFill>
-                <a:latin typeface="Segoe UI"/>
               </a:defRPr>
             </a:pPr>
             <a:r>
-              <a:t>Multi-Site Testing</a:t>
-            </a:r>
-          </a:p>
-        </p:txBody>
-      </p:sp>
-      <p:sp>
-        <p:nvSpPr>
-          <p:cNvPr id="4" name="TextBox 3"/>
-          <p:cNvSpPr txBox="1"/>
-          <p:nvPr/>
-        </p:nvSpPr>
-        <p:spPr>
-          <a:xfrm>
-            <a:off x="548640" y="658368"/>
-            <a:ext cx="11064240" cy="822960"/>
-          </a:xfrm>
-          <a:prstGeom prst="rect">
-            <a:avLst/>
-          </a:prstGeom>
-          <a:noFill/>
-        </p:spPr>
-        <p:txBody>
-          <a:bodyPr wrap="square">
-            <a:spAutoFit/>
-          </a:bodyPr>
-          <a:lstStyle/>
-          <a:p>
-            <a:pPr>
-              <a:defRPr sz="3200" b="1">
-                <a:solidFill>
-                  <a:srgbClr val="1B2A4A"/>
-                </a:solidFill>
-                <a:latin typeface="Segoe UI"/>
-              </a:defRPr>
-            </a:pPr>
-            <a:r>
-              <a:t>Cross-Site Comparison — compare_csv</a:t>
-            </a:r>
-          </a:p>
-        </p:txBody>
-      </p:sp>
-      <p:cxnSp>
-        <p:nvCxnSpPr>
-          <p:cNvPr id="5" name="Connector 4"/>
-          <p:cNvCxnSpPr/>
-          <p:nvPr/>
-        </p:nvCxnSpPr>
-        <p:spPr>
-          <a:xfrm>
-            <a:off x="548640" y="1417320"/>
-            <a:ext cx="11091672" cy="0"/>
-          </a:xfrm>
-          <a:prstGeom prst="line">
-            <a:avLst/>
-          </a:prstGeom>
-          <a:ln w="28575">
-            <a:solidFill>
-              <a:srgbClr val="0066CC"/>
-            </a:solidFill>
-          </a:ln>
-        </p:spPr>
-        <p:style>
-          <a:lnRef idx="2">
-            <a:schemeClr val="accent1"/>
-          </a:lnRef>
-          <a:fillRef idx="0">
-            <a:schemeClr val="accent1"/>
-          </a:fillRef>
-          <a:effectRef idx="1">
-            <a:schemeClr val="accent1"/>
-          </a:effectRef>
-          <a:fontRef idx="minor">
-            <a:schemeClr val="tx1"/>
-          </a:fontRef>
-        </p:style>
-      </p:cxnSp>
-      <p:sp>
-        <p:nvSpPr>
-          <p:cNvPr id="6" name="TextBox 5"/>
-          <p:cNvSpPr txBox="1"/>
-          <p:nvPr/>
-        </p:nvSpPr>
-        <p:spPr>
-          <a:xfrm>
-            <a:off x="548640" y="6473952"/>
-            <a:ext cx="8229600" cy="320040"/>
-          </a:xfrm>
-          <a:prstGeom prst="rect">
-            <a:avLst/>
-          </a:prstGeom>
-          <a:noFill/>
-        </p:spPr>
-        <p:txBody>
-          <a:bodyPr wrap="none">
-            <a:spAutoFit/>
-          </a:bodyPr>
-          <a:lstStyle/>
-          <a:p>
-            <a:pPr>
-              <a:defRPr sz="1100">
-                <a:solidFill>
-                  <a:srgbClr val="555555"/>
-                </a:solidFill>
-                <a:latin typeface="Segoe UI"/>
-              </a:defRPr>
-            </a:pPr>
-            <a:r>
-              <a:t>padb-tools</a:t>
-            </a:r>
-          </a:p>
-        </p:txBody>
-      </p:sp>
-      <p:sp>
-        <p:nvSpPr>
-          <p:cNvPr id="7" name="TextBox 6"/>
-          <p:cNvSpPr txBox="1"/>
-          <p:nvPr/>
-        </p:nvSpPr>
-        <p:spPr>
-          <a:xfrm>
-            <a:off x="11338560" y="6473952"/>
-            <a:ext cx="548640" cy="320040"/>
-          </a:xfrm>
-          <a:prstGeom prst="rect">
-            <a:avLst/>
-          </a:prstGeom>
-          <a:noFill/>
-        </p:spPr>
-        <p:txBody>
-          <a:bodyPr wrap="none">
-            <a:spAutoFit/>
-          </a:bodyPr>
-          <a:lstStyle/>
-          <a:p>
-            <a:pPr algn="r">
-              <a:defRPr sz="1100">
-                <a:solidFill>
-                  <a:srgbClr val="555555"/>
-                </a:solidFill>
-              </a:defRPr>
-            </a:pPr>
-            <a:r>
-              <a:t>42</a:t>
-            </a:r>
-          </a:p>
-        </p:txBody>
-      </p:sp>
-      <p:sp>
-        <p:nvSpPr>
-          <p:cNvPr id="8" name="TextBox 7"/>
-          <p:cNvSpPr txBox="1"/>
-          <p:nvPr/>
-        </p:nvSpPr>
-        <p:spPr>
-          <a:xfrm>
-            <a:off x="548640" y="1645920"/>
-            <a:ext cx="11064240" cy="4754880"/>
-          </a:xfrm>
-          <a:prstGeom prst="rect">
-            <a:avLst/>
-          </a:prstGeom>
-          <a:noFill/>
-        </p:spPr>
-        <p:txBody>
-          <a:bodyPr wrap="square">
-            <a:spAutoFit/>
-          </a:bodyPr>
-          <a:lstStyle/>
-          <a:p>
-            <a:pPr>
-              <a:spcAft>
-                <a:spcPts val="1000"/>
-              </a:spcAft>
-            </a:pPr>
-            <a:r>
-              <a:rPr sz="1700">
-                <a:solidFill>
-                  <a:srgbClr val="1B2A4A"/>
-                </a:solidFill>
-                <a:latin typeface="Segoe UI"/>
-              </a:rPr>
-              <a:t>•  Compares two sites' data (e.g. an established site vs. a newly-stood-up site) without hand-merging CSVs</a:t>
-            </a:r>
-          </a:p>
-          <a:p>
-            <a:pPr>
-              <a:spcAft>
-                <a:spcPts val="1000"/>
-              </a:spcAft>
-            </a:pPr>
-            <a:r>
-              <a:rPr sz="1700">
-                <a:solidFill>
-                  <a:srgbClr val="1B2A4A"/>
-                </a:solidFill>
-                <a:latin typeface="Segoe UI"/>
-              </a:rPr>
-              <a:t>•  job.json: "compare_csv": {"SR": "path...", "AMC2": "path..."}, "primary_site": "SR"</a:t>
-            </a:r>
-          </a:p>
-          <a:p>
-            <a:pPr lvl="1">
-              <a:spcAft>
-                <a:spcPts val="1000"/>
-              </a:spcAft>
-            </a:pPr>
-            <a:r>
-              <a:rPr sz="1500">
-                <a:solidFill>
-                  <a:srgbClr val="1B2A4A"/>
-                </a:solidFill>
-                <a:latin typeface="Segoe UI"/>
-              </a:rPr>
-              <a:t>–  primary_site is the reference population for the boxplot check below — no effect on other views</a:t>
-            </a:r>
-          </a:p>
-          <a:p>
-            <a:pPr>
-              <a:spcAft>
-                <a:spcPts val="1000"/>
-              </a:spcAft>
-            </a:pPr>
-            <a:r>
-              <a:rPr sz="1700">
-                <a:solidFill>
-                  <a:srgbClr val="1B2A4A"/>
-                </a:solidFill>
-                <a:latin typeface="Segoe UI"/>
-              </a:rPr>
-              <a:t>•  Mechanism: each site's own CSV is tagged "Site: &lt;name&gt;" in its Group text and merged — the normal single-CSV pipeline runs completely unchanged</a:t>
-            </a:r>
-          </a:p>
-          <a:p>
-            <a:pPr lvl="1">
-              <a:spcAft>
-                <a:spcPts val="1000"/>
-              </a:spcAft>
-            </a:pPr>
-            <a:r>
-              <a:rPr sz="1500">
-                <a:solidFill>
-                  <a:srgbClr val="1B2A4A"/>
-                </a:solidFill>
-                <a:latin typeface="Segoe UI"/>
-              </a:rPr>
-              <a:t>–  "Site" becomes a real, filterable/groupable condition dimension for free, same as Port or Serial</a:t>
-            </a:r>
-          </a:p>
-          <a:p>
-            <a:pPr>
-              <a:spcAft>
-                <a:spcPts val="1000"/>
-              </a:spcAft>
-            </a:pPr>
-            <a:r>
-              <a:rPr sz="1700">
-                <a:solidFill>
-                  <a:srgbClr val="1B2A4A"/>
-                </a:solidFill>
-                <a:latin typeface="Segoe UI"/>
-              </a:rPr>
-              <a:t>•  Deliberately tolerant of imperfect data — mismatched columns, one site missing spec limits, narrower temperature/port coverage are all expected, not errors</a:t>
-            </a:r>
-          </a:p>
-          <a:p>
-            <a:pPr>
-              <a:spcAft>
-                <a:spcPts val="1000"/>
-              </a:spcAft>
-            </a:pPr>
-            <a:r>
-              <a:rPr sz="1700">
-                <a:solidFill>
-                  <a:srgbClr val="1B2A4A"/>
-                </a:solidFill>
-                <a:latin typeface="Segoe UI"/>
-              </a:rPr>
-              <a:t>•  An always-visible banner flags real coverage gaps between sites (e.g. missing temperatures/ports) — numeric formatting differences between sites never falsely count as a gap</a:t>
+              <a:t>Setting Up From Zero — Assumes No Prior Access</a:t>
             </a:r>
           </a:p>
         </p:txBody>
@@ -20006,7 +19701,7 @@
               </a:defRPr>
             </a:pPr>
             <a:r>
-              <a:t>Multi-Site Testing</a:t>
+              <a:t>Appendix</a:t>
             </a:r>
           </a:p>
         </p:txBody>
@@ -20042,7 +19737,7 @@
               </a:defRPr>
             </a:pPr>
             <a:r>
-              <a:t>Boxplot Site Population Check — Bad DUT or Bad Station?</a:t>
+              <a:t>Getting the Code</a:t>
             </a:r>
           </a:p>
         </p:txBody>
@@ -20161,8 +19856,8 @@
         </p:nvSpPr>
         <p:spPr>
           <a:xfrm>
-            <a:off x="548640" y="1645920"/>
-            <a:ext cx="11064240" cy="4754880"/>
+            <a:off x="548640" y="1691640"/>
+            <a:ext cx="11064240" cy="365760"/>
           </a:xfrm>
           <a:prstGeom prst="rect">
             <a:avLst/>
@@ -20181,93 +19876,207 @@
               </a:spcAft>
             </a:pPr>
             <a:r>
+              <a:rPr sz="1900">
+                <a:solidFill>
+                  <a:srgbClr val="1B2A4A"/>
+                </a:solidFill>
+                <a:latin typeface="Segoe UI"/>
+              </a:rPr>
+              <a:t>•  This repo isn't on a company-wide share by default — copy it from:</a:t>
+            </a:r>
+          </a:p>
+        </p:txBody>
+      </p:sp>
+      <p:sp>
+        <p:nvSpPr>
+          <p:cNvPr id="9" name="Rounded Rectangle 8"/>
+          <p:cNvSpPr/>
+          <p:nvPr/>
+        </p:nvSpPr>
+        <p:spPr>
+          <a:xfrm>
+            <a:off x="548640" y="2103120"/>
+            <a:ext cx="11064240" cy="502920"/>
+          </a:xfrm>
+          <a:prstGeom prst="roundRect">
+            <a:avLst>
+              <a:gd name="adj" fmla="val 4000"/>
+            </a:avLst>
+          </a:prstGeom>
+          <a:solidFill>
+            <a:srgbClr val="282C34"/>
+          </a:solidFill>
+          <a:ln>
+            <a:solidFill>
+              <a:srgbClr val="111318"/>
+            </a:solidFill>
+          </a:ln>
+          <a:effectLst/>
+        </p:spPr>
+        <p:style>
+          <a:lnRef idx="1">
+            <a:schemeClr val="accent1"/>
+          </a:lnRef>
+          <a:fillRef idx="3">
+            <a:schemeClr val="accent1"/>
+          </a:fillRef>
+          <a:effectRef idx="2">
+            <a:schemeClr val="accent1"/>
+          </a:effectRef>
+          <a:fontRef idx="minor">
+            <a:schemeClr val="lt1"/>
+          </a:fontRef>
+        </p:style>
+        <p:txBody>
+          <a:bodyPr rtlCol="0" anchor="t" wrap="square" lIns="228600" rIns="228600" tIns="164592" bIns="164592"/>
+          <a:lstStyle/>
+          <a:p>
+            <a:pPr algn="l">
+              <a:spcAft>
+                <a:spcPts val="200"/>
+              </a:spcAft>
+            </a:pPr>
+            <a:r>
+              <a:rPr sz="1350">
+                <a:solidFill>
+                  <a:srgbClr val="E6E6E6"/>
+                </a:solidFill>
+                <a:latin typeface="Consolas"/>
+              </a:rPr>
+              <a:t>\\srsnas01.srs.is.keysight.com\prod\MIDRF3\SG6311A\Padb-tools\tools</a:t>
+            </a:r>
+          </a:p>
+        </p:txBody>
+      </p:sp>
+      <p:sp>
+        <p:nvSpPr>
+          <p:cNvPr id="10" name="TextBox 9"/>
+          <p:cNvSpPr txBox="1"/>
+          <p:nvPr/>
+        </p:nvSpPr>
+        <p:spPr>
+          <a:xfrm>
+            <a:off x="548640" y="2788920"/>
+            <a:ext cx="11064240" cy="365760"/>
+          </a:xfrm>
+          <a:prstGeom prst="rect">
+            <a:avLst/>
+          </a:prstGeom>
+          <a:noFill/>
+        </p:spPr>
+        <p:txBody>
+          <a:bodyPr wrap="square">
+            <a:spAutoFit/>
+          </a:bodyPr>
+          <a:lstStyle/>
+          <a:p>
+            <a:pPr>
+              <a:spcAft>
+                <a:spcPts val="1000"/>
+              </a:spcAft>
+            </a:pPr>
+            <a:r>
+              <a:rPr sz="1800">
+                <a:solidFill>
+                  <a:srgbClr val="1B2A4A"/>
+                </a:solidFill>
+                <a:latin typeface="Segoe UI"/>
+              </a:rPr>
+              <a:t>•  Copy that whole "tools" folder to a local path, e.g. C:\apps\padb\tools</a:t>
+            </a:r>
+          </a:p>
+        </p:txBody>
+      </p:sp>
+      <p:sp>
+        <p:nvSpPr>
+          <p:cNvPr id="11" name="TextBox 10"/>
+          <p:cNvSpPr txBox="1"/>
+          <p:nvPr/>
+        </p:nvSpPr>
+        <p:spPr>
+          <a:xfrm>
+            <a:off x="548640" y="3429000"/>
+            <a:ext cx="11064240" cy="914400"/>
+          </a:xfrm>
+          <a:prstGeom prst="rect">
+            <a:avLst/>
+          </a:prstGeom>
+          <a:noFill/>
+        </p:spPr>
+        <p:txBody>
+          <a:bodyPr wrap="square">
+            <a:spAutoFit/>
+          </a:bodyPr>
+          <a:lstStyle/>
+          <a:p>
+            <a:pPr>
+              <a:spcAft>
+                <a:spcPts val="1000"/>
+              </a:spcAft>
+            </a:pPr>
+            <a:r>
               <a:rPr sz="1700">
                 <a:solidFill>
                   <a:srgbClr val="1B2A4A"/>
                 </a:solidFill>
                 <a:latin typeface="Segoe UI"/>
               </a:rPr>
-              <a:t>•  Tests each non-primary-site DUT's value at each frequency/temperature against the k×IQR fence built from the primary site's own population there</a:t>
+              <a:t>•  padb_batch.py is bundled directly inside the tools folder (added 2026-08-05) —</a:t>
             </a:r>
           </a:p>
           <a:p>
             <a:pPr lvl="1">
               <a:spcAft>
+                <a:spcPts val="600"/>
+              </a:spcAft>
+            </a:pPr>
+            <a:r>
+              <a:rPr sz="1500">
+                <a:solidFill>
+                  <a:srgbClr val="555555"/>
+                </a:solidFill>
+                <a:latin typeface="Segoe UI"/>
+              </a:rPr>
+              <a:t>–  no separate dependency to track down; the whole repo is self-contained</a:t>
+            </a:r>
+          </a:p>
+        </p:txBody>
+      </p:sp>
+      <p:sp>
+        <p:nvSpPr>
+          <p:cNvPr id="12" name="TextBox 11"/>
+          <p:cNvSpPr txBox="1"/>
+          <p:nvPr/>
+        </p:nvSpPr>
+        <p:spPr>
+          <a:xfrm>
+            <a:off x="548640" y="4480560"/>
+            <a:ext cx="11064240" cy="457200"/>
+          </a:xfrm>
+          <a:prstGeom prst="rect">
+            <a:avLst/>
+          </a:prstGeom>
+          <a:noFill/>
+        </p:spPr>
+        <p:txBody>
+          <a:bodyPr wrap="square">
+            <a:spAutoFit/>
+          </a:bodyPr>
+          <a:lstStyle/>
+          <a:p>
+            <a:pPr>
+              <a:spcAft>
                 <a:spcPts val="1000"/>
               </a:spcAft>
             </a:pPr>
             <a:r>
-              <a:rPr sz="1500">
+              <a:rPr sz="1650">
                 <a:solidFill>
                   <a:srgbClr val="1B2A4A"/>
                 </a:solidFill>
                 <a:latin typeface="Segoe UI"/>
               </a:rPr>
-              <a:t>–  Reuses the exact fence and live k×IQR control the page's own outlier detection already uses — no new statistical method</a:t>
-            </a:r>
-          </a:p>
-          <a:p>
-            <a:pPr>
-              <a:spcAft>
-                <a:spcPts val="1000"/>
-              </a:spcAft>
-            </a:pPr>
-            <a:r>
-              <a:rPr sz="1700">
-                <a:solidFill>
-                  <a:srgbClr val="1B2A4A"/>
-                </a:solidFill>
-                <a:latin typeface="Segoe UI"/>
-              </a:rPr>
-              <a:t>•  Per-DUT summary — checked/outside counts, high/low split, and how many of a DUT's outside points are shared with another DUT at the same spot</a:t>
-            </a:r>
-          </a:p>
-          <a:p>
-            <a:pPr>
-              <a:spcAft>
-                <a:spcPts val="1000"/>
-              </a:spcAft>
-            </a:pPr>
-            <a:r>
-              <a:rPr sz="1700">
-                <a:solidFill>
-                  <a:srgbClr val="1B2A4A"/>
-                </a:solidFill>
-                <a:latin typeface="Segoe UI"/>
-              </a:rPr>
-              <a:t>•  Frequency clusters — every (temp, freq) where 2+ distinct DUTs are simultaneously outside — the strongest signal for a station/fixture issue, not one bad DUT</a:t>
-            </a:r>
-          </a:p>
-          <a:p>
-            <a:pPr>
-              <a:spcAft>
-                <a:spcPts val="1000"/>
-              </a:spcAft>
-            </a:pPr>
-            <a:r>
-              <a:rPr sz="1700">
-                <a:solidFill>
-                  <a:srgbClr val="1B2A4A"/>
-                </a:solidFill>
-                <a:latin typeface="Segoe UI"/>
-              </a:rPr>
-              <a:t>•  Suggested triage tag per DUT: station/systemic &gt; bad DUT &gt; isolated &gt; below-population (benign) &gt; ambiguous — a suggestion, not a verdict</a:t>
-            </a:r>
-          </a:p>
-          <a:p>
-            <a:pPr>
-              <a:spcAft>
-                <a:spcPts val="1000"/>
-              </a:spcAft>
-            </a:pPr>
-            <a:r>
-              <a:rPr sz="1700">
-                <a:solidFill>
-                  <a:srgbClr val="1B2A4A"/>
-                </a:solidFill>
-                <a:latin typeface="Segoe UI"/>
-              </a:rPr>
-              <a:t>•  Real finding on ClockSpurs SR-vs-AMC2 data: all 8 AMC2 DUTs came back "Likely station/systemic," reading systematically quieter than SR — a site calibration signature, not 8 bad units</a:t>
+              <a:t>•  Then follow the Prerequisites and Per-User Config slides earlier in this deck</a:t>
             </a:r>
           </a:p>
         </p:txBody>
@@ -20365,7 +20174,7 @@
               </a:defRPr>
             </a:pPr>
             <a:r>
-              <a:t>Multi-Site Testing</a:t>
+              <a:t>Appendix</a:t>
             </a:r>
           </a:p>
         </p:txBody>
@@ -20401,7 +20210,7 @@
               </a:defRPr>
             </a:pPr>
             <a:r>
-              <a:t>Webapp: Compare Two Datasets</a:t>
+              <a:t>First Commands to Verify Your Setup</a:t>
             </a:r>
           </a:p>
         </p:txBody>
@@ -20520,8 +20329,8 @@
         </p:nvSpPr>
         <p:spPr>
           <a:xfrm>
-            <a:off x="548640" y="1645920"/>
-            <a:ext cx="11064240" cy="4754880"/>
+            <a:off x="548640" y="1691640"/>
+            <a:ext cx="11064240" cy="365760"/>
           </a:xfrm>
           <a:prstGeom prst="rect">
             <a:avLst/>
@@ -20540,15 +20349,138 @@
               </a:spcAft>
             </a:pPr>
             <a:r>
+              <a:rPr sz="1800">
+                <a:solidFill>
+                  <a:srgbClr val="1B2A4A"/>
+                </a:solidFill>
+                <a:latin typeface="Segoe UI"/>
+              </a:rPr>
+              <a:t>•  From inside the tools folder, confirm everything imports cleanly:</a:t>
+            </a:r>
+          </a:p>
+        </p:txBody>
+      </p:sp>
+      <p:sp>
+        <p:nvSpPr>
+          <p:cNvPr id="9" name="Rounded Rectangle 8"/>
+          <p:cNvSpPr/>
+          <p:nvPr/>
+        </p:nvSpPr>
+        <p:spPr>
+          <a:xfrm>
+            <a:off x="548640" y="2103120"/>
+            <a:ext cx="11064240" cy="502920"/>
+          </a:xfrm>
+          <a:prstGeom prst="roundRect">
+            <a:avLst>
+              <a:gd name="adj" fmla="val 4000"/>
+            </a:avLst>
+          </a:prstGeom>
+          <a:solidFill>
+            <a:srgbClr val="282C34"/>
+          </a:solidFill>
+          <a:ln>
+            <a:solidFill>
+              <a:srgbClr val="111318"/>
+            </a:solidFill>
+          </a:ln>
+          <a:effectLst/>
+        </p:spPr>
+        <p:style>
+          <a:lnRef idx="1">
+            <a:schemeClr val="accent1"/>
+          </a:lnRef>
+          <a:fillRef idx="3">
+            <a:schemeClr val="accent1"/>
+          </a:fillRef>
+          <a:effectRef idx="2">
+            <a:schemeClr val="accent1"/>
+          </a:effectRef>
+          <a:fontRef idx="minor">
+            <a:schemeClr val="lt1"/>
+          </a:fontRef>
+        </p:style>
+        <p:txBody>
+          <a:bodyPr rtlCol="0" anchor="t" wrap="square" lIns="228600" rIns="228600" tIns="164592" bIns="164592"/>
+          <a:lstStyle/>
+          <a:p>
+            <a:pPr algn="l">
+              <a:spcAft>
+                <a:spcPts val="200"/>
+              </a:spcAft>
+            </a:pPr>
+            <a:r>
+              <a:rPr sz="1450">
+                <a:solidFill>
+                  <a:srgbClr val="E6E6E6"/>
+                </a:solidFill>
+                <a:latin typeface="Consolas"/>
+              </a:rPr>
+              <a:t>py -c "import padb_run, padb_v2, padb_config"</a:t>
+            </a:r>
+          </a:p>
+        </p:txBody>
+      </p:sp>
+      <p:sp>
+        <p:nvSpPr>
+          <p:cNvPr id="10" name="TextBox 9"/>
+          <p:cNvSpPr txBox="1"/>
+          <p:nvPr/>
+        </p:nvSpPr>
+        <p:spPr>
+          <a:xfrm>
+            <a:off x="548640" y="2743200"/>
+            <a:ext cx="11064240" cy="365760"/>
+          </a:xfrm>
+          <a:prstGeom prst="rect">
+            <a:avLst/>
+          </a:prstGeom>
+          <a:noFill/>
+        </p:spPr>
+        <p:txBody>
+          <a:bodyPr wrap="square">
+            <a:spAutoFit/>
+          </a:bodyPr>
+          <a:lstStyle/>
+          <a:p>
+            <a:pPr>
+              <a:spcAft>
+                <a:spcPts val="1000"/>
+              </a:spcAft>
+            </a:pPr>
+            <a:r>
               <a:rPr sz="1700">
                 <a:solidFill>
                   <a:srgbClr val="1B2A4A"/>
                 </a:solidFill>
                 <a:latin typeface="Segoe UI"/>
               </a:rPr>
-              <a:t>•  Collapsed-by-default panel in the web app (a corner case — mainly useful the first time a new site comes online)</a:t>
-            </a:r>
-          </a:p>
+              <a:t>•  No output and no traceback = success</a:t>
+            </a:r>
+          </a:p>
+        </p:txBody>
+      </p:sp>
+      <p:sp>
+        <p:nvSpPr>
+          <p:cNvPr id="11" name="TextBox 10"/>
+          <p:cNvSpPr txBox="1"/>
+          <p:nvPr/>
+        </p:nvSpPr>
+        <p:spPr>
+          <a:xfrm>
+            <a:off x="548640" y="3291840"/>
+            <a:ext cx="11064240" cy="365760"/>
+          </a:xfrm>
+          <a:prstGeom prst="rect">
+            <a:avLst/>
+          </a:prstGeom>
+          <a:noFill/>
+        </p:spPr>
+        <p:txBody>
+          <a:bodyPr wrap="square">
+            <a:spAutoFit/>
+          </a:bodyPr>
+          <a:lstStyle/>
           <a:p>
             <a:pPr>
               <a:spcAft>
@@ -20556,13 +20488,113 @@
               </a:spcAft>
             </a:pPr>
             <a:r>
+              <a:rPr sz="1800">
+                <a:solidFill>
+                  <a:srgbClr val="1B2A4A"/>
+                </a:solidFill>
+                <a:latin typeface="Segoe UI"/>
+              </a:rPr>
+              <a:t>•  Then generate your first job.json from any pod you have access to:</a:t>
+            </a:r>
+          </a:p>
+        </p:txBody>
+      </p:sp>
+      <p:sp>
+        <p:nvSpPr>
+          <p:cNvPr id="12" name="Rounded Rectangle 11"/>
+          <p:cNvSpPr/>
+          <p:nvPr/>
+        </p:nvSpPr>
+        <p:spPr>
+          <a:xfrm>
+            <a:off x="548640" y="3703320"/>
+            <a:ext cx="11064240" cy="502920"/>
+          </a:xfrm>
+          <a:prstGeom prst="roundRect">
+            <a:avLst>
+              <a:gd name="adj" fmla="val 4000"/>
+            </a:avLst>
+          </a:prstGeom>
+          <a:solidFill>
+            <a:srgbClr val="282C34"/>
+          </a:solidFill>
+          <a:ln>
+            <a:solidFill>
+              <a:srgbClr val="111318"/>
+            </a:solidFill>
+          </a:ln>
+          <a:effectLst/>
+        </p:spPr>
+        <p:style>
+          <a:lnRef idx="1">
+            <a:schemeClr val="accent1"/>
+          </a:lnRef>
+          <a:fillRef idx="3">
+            <a:schemeClr val="accent1"/>
+          </a:fillRef>
+          <a:effectRef idx="2">
+            <a:schemeClr val="accent1"/>
+          </a:effectRef>
+          <a:fontRef idx="minor">
+            <a:schemeClr val="lt1"/>
+          </a:fontRef>
+        </p:style>
+        <p:txBody>
+          <a:bodyPr rtlCol="0" anchor="t" wrap="square" lIns="228600" rIns="228600" tIns="164592" bIns="164592"/>
+          <a:lstStyle/>
+          <a:p>
+            <a:pPr algn="l">
+              <a:spcAft>
+                <a:spcPts val="200"/>
+              </a:spcAft>
+            </a:pPr>
+            <a:r>
+              <a:rPr sz="1450">
+                <a:solidFill>
+                  <a:srgbClr val="E6E6E6"/>
+                </a:solidFill>
+                <a:latin typeface="Consolas"/>
+              </a:rPr>
+              <a:t>py padb_make_job.py YourPod.pod --module YourModule</a:t>
+            </a:r>
+          </a:p>
+        </p:txBody>
+      </p:sp>
+      <p:sp>
+        <p:nvSpPr>
+          <p:cNvPr id="13" name="TextBox 12"/>
+          <p:cNvSpPr txBox="1"/>
+          <p:nvPr/>
+        </p:nvSpPr>
+        <p:spPr>
+          <a:xfrm>
+            <a:off x="548640" y="4343400"/>
+            <a:ext cx="11064240" cy="1463040"/>
+          </a:xfrm>
+          <a:prstGeom prst="rect">
+            <a:avLst/>
+          </a:prstGeom>
+          <a:noFill/>
+        </p:spPr>
+        <p:txBody>
+          <a:bodyPr wrap="square">
+            <a:spAutoFit/>
+          </a:bodyPr>
+          <a:lstStyle/>
+          <a:p>
+            <a:pPr>
+              <a:spcAft>
+                <a:spcPts val="1000"/>
+              </a:spcAft>
+            </a:pPr>
+            <a:r>
               <a:rPr sz="1700">
                 <a:solidFill>
                   <a:srgbClr val="1B2A4A"/>
                 </a:solidFill>
                 <a:latin typeface="Segoe UI"/>
               </a:rPr>
-              <a:t>•  Pick two already-extracted CSVs (auto-discovered from disk), name each site, pick the primary, and Create &amp; Run in one step — no hand-written job.json needed</a:t>
+              <a:t>•  If PADB-R.exe launches and a real window briefly appears, you're fully set up</a:t>
             </a:r>
           </a:p>
           <a:p>
@@ -20578,55 +20610,23 @@
                 </a:solidFill>
                 <a:latin typeface="Segoe UI"/>
               </a:rPr>
-              <a:t>•  Validates first: a genuine measurement-unit mismatch (e.g. dBc vs. dBm) blocks with an explanation, with an explicit override to proceed anyway</a:t>
+              <a:t>•  Stuck? GETTING_STARTED.md → Quick_Start.md, or type /padb-tools once you're</a:t>
             </a:r>
           </a:p>
           <a:p>
             <a:pPr lvl="1">
               <a:spcAft>
-                <a:spcPts val="1000"/>
+                <a:spcPts val="600"/>
               </a:spcAft>
             </a:pPr>
             <a:r>
               <a:rPr sz="1500">
                 <a:solidFill>
-                  <a:srgbClr val="1B2A4A"/>
-                </a:solidFill>
-                <a:latin typeface="Segoe UI"/>
-              </a:rPr>
-              <a:t>–  Softer gaps — missing temperatures/ports, non-overlapping frequency ranges — only warn, never block</a:t>
-            </a:r>
-          </a:p>
-          <a:p>
-            <a:pPr>
-              <a:spcAft>
-                <a:spcPts val="1000"/>
-              </a:spcAft>
-            </a:pPr>
-            <a:r>
-              <a:rPr sz="1700">
-                <a:solidFill>
-                  <a:srgbClr val="1B2A4A"/>
-                </a:solidFill>
-                <a:latin typeface="Segoe UI"/>
-              </a:rPr>
-              <a:t>•  New job defaults to local-only (publish_to left empty) — publishing an ad-hoc comparison test is a deliberate, separate choice</a:t>
-            </a:r>
-          </a:p>
-          <a:p>
-            <a:pPr>
-              <a:spcAft>
-                <a:spcPts val="1000"/>
-              </a:spcAft>
-            </a:pPr>
-            <a:r>
-              <a:rPr sz="1700">
-                <a:solidFill>
-                  <a:srgbClr val="1B2A4A"/>
-                </a:solidFill>
-                <a:latin typeface="Segoe UI"/>
-              </a:rPr>
-              <a:t>•  "Show tooltip help" checkbox (top of every page) toggles hover help across the whole app on/off, remembered across reloads</a:t>
+                  <a:srgbClr val="555555"/>
+                </a:solidFill>
+                <a:latin typeface="Segoe UI"/>
+              </a:rPr>
+              <a:t>–  working inside the repo</a:t>
             </a:r>
           </a:p>
         </p:txBody>

</xml_diff>

<commit_message>
Update training deck: duplicate-run tracking slide, Site Population Check parity, noise-disclaimer note
Slide 43 now reflects Site Population Check being on boxplot/stat_summary/summary
(not boxplot-only) plus the CSV export feature. New slide 44 explains why
Statistics Table "n" counts raw rows, not distinct DUTs, and how Dup runs/port
identity/condition pooling/Collapse dup runs fit together. Slide 33 gets a
one-line addendum for the noise-sensitivity disclaimers added across 4 views.
Slides 45-49 renumbered accordingly.

Co-Authored-By: Claude Sonnet 5 <noreply@anthropic.com>
</commit_message>
<xml_diff>
--- a/PADB_Simple_and_Interactive.pptx
+++ b/PADB_Simple_and_Interactive.pptx
@@ -48,6 +48,7 @@
     <p:sldId id="296" r:id="rId47"/>
     <p:sldId id="301" r:id="rId52"/>
     <p:sldId id="302" r:id="rId53"/>
+    <p:sldId id="304" r:id="rId55"/>
     <p:sldId id="303" r:id="rId54"/>
     <p:sldId id="297" r:id="rId48"/>
     <p:sldId id="298" r:id="rId49"/>
@@ -14070,6 +14071,22 @@
               <a:t>•  Run padb_csv_check.py (next slide) to catch the same class of issue before you even open the HTML</a:t>
             </a:r>
           </a:p>
+          <a:p>
+            <a:pPr>
+              <a:spcAft>
+                <a:spcPts val="1000"/>
+              </a:spcAft>
+            </a:pPr>
+            <a:r>
+              <a:rPr sz="1700">
+                <a:solidFill>
+                  <a:srgbClr val="1B2A4A"/>
+                </a:solidFill>
+                <a:latin typeface="Segoe UI"/>
+              </a:rPr>
+              <a:t>•  env_coverage, distribution, stat_summary, and summary now also show a static noise-sensitivity disclaimer — TI/KDE/normality math assumes reasonably well-behaved, low-noise data</a:t>
+            </a:r>
+          </a:p>
         </p:txBody>
       </p:sp>
     </p:spTree>
@@ -18899,7 +18916,7 @@
                 </a:solidFill>
                 <a:latin typeface="Segoe UI"/>
               </a:rPr>
-              <a:t>•  Tests each non-primary-site DUT's value at each frequency/temperature against the k×IQR fence built from the primary site's own population there</a:t>
+              <a:t>•  Tests each non-primary-site DUT's value at each frequency/temperature against the k×IQR fence built from the primary site's own population there — available on boxplot, stat_summary, and summary</a:t>
             </a:r>
           </a:p>
           <a:p>
@@ -18964,6 +18981,22 @@
                 <a:latin typeface="Segoe UI"/>
               </a:rPr>
               <a:t>•  Suggested triage tag per DUT: station/systemic &gt; bad DUT &gt; isolated &gt; below-population (benign) &gt; ambiguous — a suggestion, not a verdict</a:t>
+            </a:r>
+          </a:p>
+          <a:p>
+            <a:pPr>
+              <a:spcAft>
+                <a:spcPts val="1000"/>
+              </a:spcAft>
+            </a:pPr>
+            <a:r>
+              <a:rPr sz="1700">
+                <a:solidFill>
+                  <a:srgbClr val="1B2A4A"/>
+                </a:solidFill>
+                <a:latin typeface="Segoe UI"/>
+              </a:rPr>
+              <a:t>•  Export CSV (All) / (Outside only) — downloads the per-point detail table with a metadata header (timestamp, primary site, frequency window)</a:t>
             </a:r>
           </a:p>
           <a:p>
@@ -19219,7 +19252,7 @@
               </a:defRPr>
             </a:pPr>
             <a:r>
-              <a:t>44</a:t>
+              <a:t>45</a:t>
             </a:r>
           </a:p>
         </p:txBody>
@@ -19843,7 +19876,7 @@
               </a:defRPr>
             </a:pPr>
             <a:r>
-              <a:t>43</a:t>
+              <a:t>48</a:t>
             </a:r>
           </a:p>
         </p:txBody>
@@ -20316,7 +20349,7 @@
               </a:defRPr>
             </a:pPr>
             <a:r>
-              <a:t>44</a:t>
+              <a:t>49</a:t>
             </a:r>
           </a:p>
         </p:txBody>
@@ -20627,6 +20660,381 @@
                 <a:latin typeface="Segoe UI"/>
               </a:rPr>
               <a:t>–  working inside the repo</a:t>
+            </a:r>
+          </a:p>
+        </p:txBody>
+      </p:sp>
+    </p:spTree>
+  </p:cSld>
+  <p:clrMapOvr>
+    <a:masterClrMapping/>
+  </p:clrMapOvr>
+</p:sld>
+</file>
+
+<file path=ppt/slides/slide49.xml><?xml version="1.0" encoding="utf-8"?>
+<p:sld xmlns:a="http://schemas.openxmlformats.org/drawingml/2006/main" xmlns:p="http://schemas.openxmlformats.org/presentationml/2006/main" xmlns:r="http://schemas.openxmlformats.org/officeDocument/2006/relationships">
+  <p:cSld>
+    <p:spTree>
+      <p:nvGrpSpPr>
+        <p:cNvPr id="1" name=""/>
+        <p:cNvGrpSpPr/>
+        <p:nvPr/>
+      </p:nvGrpSpPr>
+      <p:grpSpPr/>
+      <p:sp>
+        <p:nvSpPr>
+          <p:cNvPr id="2" name="Rectangle 1"/>
+          <p:cNvSpPr/>
+          <p:nvPr/>
+        </p:nvSpPr>
+        <p:spPr>
+          <a:xfrm>
+            <a:off x="0" y="0"/>
+            <a:ext cx="12191695" cy="6858000"/>
+          </a:xfrm>
+          <a:prstGeom prst="rect">
+            <a:avLst/>
+          </a:prstGeom>
+          <a:solidFill>
+            <a:srgbClr val="FFFFFF"/>
+          </a:solidFill>
+          <a:ln>
+            <a:noFill/>
+          </a:ln>
+          <a:effectLst/>
+        </p:spPr>
+        <p:style>
+          <a:lnRef idx="1">
+            <a:schemeClr val="accent1"/>
+          </a:lnRef>
+          <a:fillRef idx="3">
+            <a:schemeClr val="accent1"/>
+          </a:fillRef>
+          <a:effectRef idx="2">
+            <a:schemeClr val="accent1"/>
+          </a:effectRef>
+          <a:fontRef idx="minor">
+            <a:schemeClr val="lt1"/>
+          </a:fontRef>
+        </p:style>
+        <p:txBody>
+          <a:bodyPr rtlCol="0" anchor="ctr"/>
+          <a:lstStyle/>
+          <a:p>
+            <a:pPr algn="ctr"/>
+          </a:p>
+        </p:txBody>
+      </p:sp>
+      <p:sp>
+        <p:nvSpPr>
+          <p:cNvPr id="3" name="TextBox 2"/>
+          <p:cNvSpPr txBox="1"/>
+          <p:nvPr/>
+        </p:nvSpPr>
+        <p:spPr>
+          <a:xfrm>
+            <a:off x="548640" y="320040"/>
+            <a:ext cx="7315200" cy="365760"/>
+          </a:xfrm>
+          <a:prstGeom prst="rect">
+            <a:avLst/>
+          </a:prstGeom>
+          <a:noFill/>
+        </p:spPr>
+        <p:txBody>
+          <a:bodyPr wrap="none">
+            <a:spAutoFit/>
+          </a:bodyPr>
+          <a:lstStyle/>
+          <a:p>
+            <a:pPr>
+              <a:defRPr sz="1600" b="1">
+                <a:solidFill>
+                  <a:srgbClr val="0066CC"/>
+                </a:solidFill>
+                <a:latin typeface="Segoe UI"/>
+              </a:defRPr>
+            </a:pPr>
+            <a:r>
+              <a:t>Multi-Site Testing</a:t>
+            </a:r>
+          </a:p>
+        </p:txBody>
+      </p:sp>
+      <p:sp>
+        <p:nvSpPr>
+          <p:cNvPr id="4" name="TextBox 3"/>
+          <p:cNvSpPr txBox="1"/>
+          <p:nvPr/>
+        </p:nvSpPr>
+        <p:spPr>
+          <a:xfrm>
+            <a:off x="548640" y="658368"/>
+            <a:ext cx="11064240" cy="822960"/>
+          </a:xfrm>
+          <a:prstGeom prst="rect">
+            <a:avLst/>
+          </a:prstGeom>
+          <a:noFill/>
+        </p:spPr>
+        <p:txBody>
+          <a:bodyPr wrap="square">
+            <a:spAutoFit/>
+          </a:bodyPr>
+          <a:lstStyle/>
+          <a:p>
+            <a:pPr>
+              <a:defRPr sz="3200" b="1">
+                <a:solidFill>
+                  <a:srgbClr val="1B2A4A"/>
+                </a:solidFill>
+                <a:latin typeface="Segoe UI"/>
+              </a:defRPr>
+            </a:pPr>
+            <a:r>
+              <a:t>Duplicate Test Runs — Why "n DUTs" Isn't Always DUT Count</a:t>
+            </a:r>
+          </a:p>
+        </p:txBody>
+      </p:sp>
+      <p:cxnSp>
+        <p:nvCxnSpPr>
+          <p:cNvPr id="5" name="Connector 4"/>
+          <p:cNvCxnSpPr/>
+          <p:nvPr/>
+        </p:nvCxnSpPr>
+        <p:spPr>
+          <a:xfrm>
+            <a:off x="548640" y="1417320"/>
+            <a:ext cx="11091672" cy="0"/>
+          </a:xfrm>
+          <a:prstGeom prst="line">
+            <a:avLst/>
+          </a:prstGeom>
+          <a:ln w="28575">
+            <a:solidFill>
+              <a:srgbClr val="0066CC"/>
+            </a:solidFill>
+          </a:ln>
+        </p:spPr>
+        <p:style>
+          <a:lnRef idx="2">
+            <a:schemeClr val="accent1"/>
+          </a:lnRef>
+          <a:fillRef idx="0">
+            <a:schemeClr val="accent1"/>
+          </a:fillRef>
+          <a:effectRef idx="1">
+            <a:schemeClr val="accent1"/>
+          </a:effectRef>
+          <a:fontRef idx="minor">
+            <a:schemeClr val="tx1"/>
+          </a:fontRef>
+        </p:style>
+      </p:cxnSp>
+      <p:sp>
+        <p:nvSpPr>
+          <p:cNvPr id="6" name="TextBox 5"/>
+          <p:cNvSpPr txBox="1"/>
+          <p:nvPr/>
+        </p:nvSpPr>
+        <p:spPr>
+          <a:xfrm>
+            <a:off x="548640" y="6473952"/>
+            <a:ext cx="8229600" cy="320040"/>
+          </a:xfrm>
+          <a:prstGeom prst="rect">
+            <a:avLst/>
+          </a:prstGeom>
+          <a:noFill/>
+        </p:spPr>
+        <p:txBody>
+          <a:bodyPr wrap="none">
+            <a:spAutoFit/>
+          </a:bodyPr>
+          <a:lstStyle/>
+          <a:p>
+            <a:pPr>
+              <a:defRPr sz="1100">
+                <a:solidFill>
+                  <a:srgbClr val="555555"/>
+                </a:solidFill>
+                <a:latin typeface="Segoe UI"/>
+              </a:defRPr>
+            </a:pPr>
+            <a:r>
+              <a:t>padb-tools</a:t>
+            </a:r>
+          </a:p>
+        </p:txBody>
+      </p:sp>
+      <p:sp>
+        <p:nvSpPr>
+          <p:cNvPr id="7" name="TextBox 6"/>
+          <p:cNvSpPr txBox="1"/>
+          <p:nvPr/>
+        </p:nvSpPr>
+        <p:spPr>
+          <a:xfrm>
+            <a:off x="11338560" y="6473952"/>
+            <a:ext cx="548640" cy="320040"/>
+          </a:xfrm>
+          <a:prstGeom prst="rect">
+            <a:avLst/>
+          </a:prstGeom>
+          <a:noFill/>
+        </p:spPr>
+        <p:txBody>
+          <a:bodyPr wrap="none">
+            <a:spAutoFit/>
+          </a:bodyPr>
+          <a:lstStyle/>
+          <a:p>
+            <a:pPr algn="r">
+              <a:defRPr sz="1100">
+                <a:solidFill>
+                  <a:srgbClr val="555555"/>
+                </a:solidFill>
+              </a:defRPr>
+            </a:pPr>
+            <a:r>
+              <a:t>44</a:t>
+            </a:r>
+          </a:p>
+        </p:txBody>
+      </p:sp>
+      <p:sp>
+        <p:nvSpPr>
+          <p:cNvPr id="8" name="TextBox 7"/>
+          <p:cNvSpPr txBox="1"/>
+          <p:nvPr/>
+        </p:nvSpPr>
+        <p:spPr>
+          <a:xfrm>
+            <a:off x="548640" y="1645920"/>
+            <a:ext cx="11064240" cy="4754880"/>
+          </a:xfrm>
+          <a:prstGeom prst="rect">
+            <a:avLst/>
+          </a:prstGeom>
+          <a:noFill/>
+        </p:spPr>
+        <p:txBody>
+          <a:bodyPr wrap="square">
+            <a:spAutoFit/>
+          </a:bodyPr>
+          <a:lstStyle/>
+          <a:p>
+            <a:pPr>
+              <a:spcAft>
+                <a:spcPts val="1000"/>
+              </a:spcAft>
+            </a:pPr>
+            <a:r>
+              <a:rPr sz="1700">
+                <a:solidFill>
+                  <a:srgbClr val="1B2A4A"/>
+                </a:solidFill>
+                <a:latin typeface="Segoe UI"/>
+              </a:rPr>
+              <a:t>•  Statistics Table's n counts raw CSV rows, not distinct DUTs — a DUT measured twice at the same point is counted twice</a:t>
+            </a:r>
+          </a:p>
+          <a:p>
+            <a:pPr>
+              <a:spcAft>
+                <a:spcPts val="1000"/>
+              </a:spcAft>
+            </a:pPr>
+            <a:r>
+              <a:rPr sz="1700">
+                <a:solidFill>
+                  <a:srgbClr val="1B2A4A"/>
+                </a:solidFill>
+                <a:latin typeface="Segoe UI"/>
+              </a:rPr>
+              <a:t>•  "Dup runs" column sums the extras across every duplicated DUT — 3 DUTs with 1 dup each is not the same as 1 DUT with 3 dups</a:t>
+            </a:r>
+          </a:p>
+          <a:p>
+            <a:pPr>
+              <a:spcAft>
+                <a:spcPts val="1000"/>
+              </a:spcAft>
+            </a:pPr>
+            <a:r>
+              <a:rPr sz="1700">
+                <a:solidFill>
+                  <a:srgbClr val="1B2A4A"/>
+                </a:solidFill>
+                <a:latin typeface="Segoe UI"/>
+              </a:rPr>
+              <a:t>•  Site Population Check's "Genuinely repeated freqs" / "SR dup pts" break duplicates down per-DUT instead of one ambiguous total</a:t>
+            </a:r>
+          </a:p>
+          <a:p>
+            <a:pPr>
+              <a:spcAft>
+                <a:spcPts val="1000"/>
+              </a:spcAft>
+            </a:pPr>
+            <a:r>
+              <a:rPr sz="1700">
+                <a:solidFill>
+                  <a:srgbClr val="1B2A4A"/>
+                </a:solidFill>
+                <a:latin typeface="Segoe UI"/>
+              </a:rPr>
+              <a:t>•  Port is part of the duplicate identity — a DUT's RF1 and RF2 rows are two real measurements, never counted as duplicates of each other</a:t>
+            </a:r>
+          </a:p>
+          <a:p>
+            <a:pPr lvl="1">
+              <a:spcAft>
+                <a:spcPts val="1000"/>
+              </a:spcAft>
+            </a:pPr>
+            <a:r>
+              <a:rPr sz="1500">
+                <a:solidFill>
+                  <a:srgbClr val="1B2A4A"/>
+                </a:solidFill>
+                <a:latin typeface="Segoe UI"/>
+              </a:rPr>
+              <a:t>–  Real bug fixed this session: an earlier version of this check missed that distinction</a:t>
+            </a:r>
+          </a:p>
+          <a:p>
+            <a:pPr>
+              <a:spcAft>
+                <a:spcPts val="1000"/>
+              </a:spcAft>
+            </a:pPr>
+            <a:r>
+              <a:rPr sz="1700">
+                <a:solidFill>
+                  <a:srgbClr val="1B2A4A"/>
+                </a:solidFill>
+                <a:latin typeface="Segoe UI"/>
+              </a:rPr>
+              <a:t>•  Condition pooling (e.g. Group by: Serial Number) is not a duplicate either — same DUT under different SpurTypes/conditions is real coverage, not a repeat</a:t>
+            </a:r>
+          </a:p>
+          <a:p>
+            <a:pPr>
+              <a:spcAft>
+                <a:spcPts val="1000"/>
+              </a:spcAft>
+            </a:pPr>
+            <a:r>
+              <a:rPr sz="1700">
+                <a:solidFill>
+                  <a:srgbClr val="1B2A4A"/>
+                </a:solidFill>
+                <a:latin typeface="Segoe UI"/>
+              </a:rPr>
+              <a:t>•  "Collapse dup runs" checkbox (boxplot) averages true duplicates before computing box stats — stat_summary/summary don't need it, their per-DUT data is already pre-averaged server-side</a:t>
             </a:r>
           </a:p>
         </p:txBody>

</xml_diff>

<commit_message>
Fix slide 44 title overflow in the training deck
Verified the 3 touched slides by actually rendering them via PowerPoint
COM automation -- caught the same title-overflow bug as the earlier
slide-43 fix: "Duplicate Test Runs -- Why "n DUTs" Isn't Always DUT
Count" wrapped onto a second line and struck through the divider rule.
Shortened to "Duplicate Test Runs vs. DUT Count", re-rendered to confirm
it now fits on one line like every other slide title.

Co-Authored-By: Claude Sonnet 5 <noreply@anthropic.com>
</commit_message>
<xml_diff>
--- a/PADB_Simple_and_Interactive.pptx
+++ b/PADB_Simple_and_Interactive.pptx
@@ -19146,7 +19146,7 @@
               </a:defRPr>
             </a:pPr>
             <a:r>
-              <a:t>Webapp: Compare Two Datasets</a:t>
+              <a:t>Duplicate Test Runs vs. DUT Count</a:t>
             </a:r>
           </a:p>
         </p:txBody>
@@ -19252,7 +19252,7 @@
               </a:defRPr>
             </a:pPr>
             <a:r>
-              <a:t>45</a:t>
+              <a:t>44</a:t>
             </a:r>
           </a:p>
         </p:txBody>
@@ -19291,7 +19291,7 @@
                 </a:solidFill>
                 <a:latin typeface="Segoe UI"/>
               </a:rPr>
-              <a:t>•  Collapsed-by-default panel in the web app (a corner case — mainly useful the first time a new site comes online)</a:t>
+              <a:t>•  Statistics Table's n counts raw CSV rows, not distinct DUTs — a DUT measured twice at the same point is counted twice</a:t>
             </a:r>
           </a:p>
           <a:p>
@@ -19307,7 +19307,7 @@
                 </a:solidFill>
                 <a:latin typeface="Segoe UI"/>
               </a:rPr>
-              <a:t>•  Pick two already-extracted CSVs (auto-discovered from disk), name each site, pick the primary, and Create &amp; Run in one step — no hand-written job.json needed</a:t>
+              <a:t>•  "Dup runs" column sums the extras across every duplicated DUT — 3 DUTs with 1 dup each is not the same as 1 DUT with 3 dups</a:t>
             </a:r>
           </a:p>
           <a:p>
@@ -19323,7 +19323,23 @@
                 </a:solidFill>
                 <a:latin typeface="Segoe UI"/>
               </a:rPr>
-              <a:t>•  Validates first: a genuine measurement-unit mismatch (e.g. dBc vs. dBm) blocks with an explanation, with an explicit override to proceed anyway</a:t>
+              <a:t>•  Site Population Check's "Genuinely repeated freqs" / "SR dup pts" break duplicates down per-DUT instead of one ambiguous total</a:t>
+            </a:r>
+          </a:p>
+          <a:p>
+            <a:pPr>
+              <a:spcAft>
+                <a:spcPts val="1000"/>
+              </a:spcAft>
+            </a:pPr>
+            <a:r>
+              <a:rPr sz="1700">
+                <a:solidFill>
+                  <a:srgbClr val="1B2A4A"/>
+                </a:solidFill>
+                <a:latin typeface="Segoe UI"/>
+              </a:rPr>
+              <a:t>•  Port is part of the duplicate identity — a DUT's RF1 and RF2 rows are two real measurements, never counted as duplicates of each other</a:t>
             </a:r>
           </a:p>
           <a:p>
@@ -19339,7 +19355,7 @@
                 </a:solidFill>
                 <a:latin typeface="Segoe UI"/>
               </a:rPr>
-              <a:t>–  Softer gaps — missing temperatures/ports, non-overlapping frequency ranges — only warn, never block</a:t>
+              <a:t>–  Real bug fixed this session: an earlier version of this check missed that distinction</a:t>
             </a:r>
           </a:p>
           <a:p>
@@ -19355,7 +19371,7 @@
                 </a:solidFill>
                 <a:latin typeface="Segoe UI"/>
               </a:rPr>
-              <a:t>•  New job defaults to local-only (publish_to left empty) — publishing an ad-hoc comparison test is a deliberate, separate choice</a:t>
+              <a:t>•  Condition pooling (e.g. Group by: Serial Number) is not a duplicate either — same DUT under different SpurTypes/conditions is real coverage, not a repeat</a:t>
             </a:r>
           </a:p>
           <a:p>
@@ -19371,7 +19387,7 @@
                 </a:solidFill>
                 <a:latin typeface="Segoe UI"/>
               </a:rPr>
-              <a:t>•  "Show tooltip help" checkbox (top of every page) toggles hover help across the whole app on/off, remembered across reloads</a:t>
+              <a:t>•  "Collapse dup runs" checkbox (boxplot) averages true duplicates before computing box stats — stat_summary/summary don't need it, their per-DUT data is already pre-averaged server-side</a:t>
             </a:r>
           </a:p>
         </p:txBody>
@@ -19409,7 +19425,7 @@
             <a:avLst/>
           </a:prstGeom>
           <a:solidFill>
-            <a:srgbClr val="1B2A4A"/>
+            <a:srgbClr val="FFFFFF"/>
           </a:solidFill>
           <a:ln>
             <a:noFill/>
@@ -19446,8 +19462,8 @@
         </p:nvSpPr>
         <p:spPr>
           <a:xfrm>
-            <a:off x="822960" y="2743200"/>
-            <a:ext cx="10515600" cy="1097280"/>
+            <a:off x="548640" y="320040"/>
+            <a:ext cx="7315200" cy="365760"/>
           </a:xfrm>
           <a:prstGeom prst="rect">
             <a:avLst/>
@@ -19461,14 +19477,15 @@
           <a:lstStyle/>
           <a:p>
             <a:pPr>
-              <a:defRPr sz="4800" b="1">
-                <a:solidFill>
-                  <a:srgbClr val="FFFFFF"/>
-                </a:solidFill>
+              <a:defRPr sz="1600" b="1">
+                <a:solidFill>
+                  <a:srgbClr val="0066CC"/>
+                </a:solidFill>
+                <a:latin typeface="Segoe UI"/>
               </a:defRPr>
             </a:pPr>
             <a:r>
-              <a:t>Questions?</a:t>
+              <a:t>Multi-Site Testing</a:t>
             </a:r>
           </a:p>
         </p:txBody>
@@ -19481,8 +19498,79 @@
         </p:nvSpPr>
         <p:spPr>
           <a:xfrm>
-            <a:off x="822960" y="3749039"/>
-            <a:ext cx="10515600" cy="640080"/>
+            <a:off x="548640" y="658368"/>
+            <a:ext cx="11064240" cy="822960"/>
+          </a:xfrm>
+          <a:prstGeom prst="rect">
+            <a:avLst/>
+          </a:prstGeom>
+          <a:noFill/>
+        </p:spPr>
+        <p:txBody>
+          <a:bodyPr wrap="square">
+            <a:spAutoFit/>
+          </a:bodyPr>
+          <a:lstStyle/>
+          <a:p>
+            <a:pPr>
+              <a:defRPr sz="3200" b="1">
+                <a:solidFill>
+                  <a:srgbClr val="1B2A4A"/>
+                </a:solidFill>
+                <a:latin typeface="Segoe UI"/>
+              </a:defRPr>
+            </a:pPr>
+            <a:r>
+              <a:t>Webapp: Compare Two Datasets</a:t>
+            </a:r>
+          </a:p>
+        </p:txBody>
+      </p:sp>
+      <p:cxnSp>
+        <p:nvCxnSpPr>
+          <p:cNvPr id="5" name="Connector 4"/>
+          <p:cNvCxnSpPr/>
+          <p:nvPr/>
+        </p:nvCxnSpPr>
+        <p:spPr>
+          <a:xfrm>
+            <a:off x="548640" y="1417320"/>
+            <a:ext cx="11091672" cy="0"/>
+          </a:xfrm>
+          <a:prstGeom prst="line">
+            <a:avLst/>
+          </a:prstGeom>
+          <a:ln w="28575">
+            <a:solidFill>
+              <a:srgbClr val="0066CC"/>
+            </a:solidFill>
+          </a:ln>
+        </p:spPr>
+        <p:style>
+          <a:lnRef idx="2">
+            <a:schemeClr val="accent1"/>
+          </a:lnRef>
+          <a:fillRef idx="0">
+            <a:schemeClr val="accent1"/>
+          </a:fillRef>
+          <a:effectRef idx="1">
+            <a:schemeClr val="accent1"/>
+          </a:effectRef>
+          <a:fontRef idx="minor">
+            <a:schemeClr val="tx1"/>
+          </a:fontRef>
+        </p:style>
+      </p:cxnSp>
+      <p:sp>
+        <p:nvSpPr>
+          <p:cNvPr id="6" name="TextBox 5"/>
+          <p:cNvSpPr txBox="1"/>
+          <p:nvPr/>
+        </p:nvSpPr>
+        <p:spPr>
+          <a:xfrm>
+            <a:off x="548640" y="6473952"/>
+            <a:ext cx="8229600" cy="320040"/>
           </a:xfrm>
           <a:prstGeom prst="rect">
             <a:avLst/>
@@ -19496,15 +19584,169 @@
           <a:lstStyle/>
           <a:p>
             <a:pPr>
-              <a:defRPr sz="1800">
-                <a:solidFill>
-                  <a:srgbClr val="9FC5FF"/>
-                </a:solidFill>
-                <a:latin typeface="Consolas"/>
+              <a:defRPr sz="1100">
+                <a:solidFill>
+                  <a:srgbClr val="555555"/>
+                </a:solidFill>
+                <a:latin typeface="Segoe UI"/>
               </a:defRPr>
             </a:pPr>
             <a:r>
-              <a:t>C:\apps\padb\tools   |   /padb-tools</a:t>
+              <a:t>padb-tools</a:t>
+            </a:r>
+          </a:p>
+        </p:txBody>
+      </p:sp>
+      <p:sp>
+        <p:nvSpPr>
+          <p:cNvPr id="7" name="TextBox 6"/>
+          <p:cNvSpPr txBox="1"/>
+          <p:nvPr/>
+        </p:nvSpPr>
+        <p:spPr>
+          <a:xfrm>
+            <a:off x="11338560" y="6473952"/>
+            <a:ext cx="548640" cy="320040"/>
+          </a:xfrm>
+          <a:prstGeom prst="rect">
+            <a:avLst/>
+          </a:prstGeom>
+          <a:noFill/>
+        </p:spPr>
+        <p:txBody>
+          <a:bodyPr wrap="none">
+            <a:spAutoFit/>
+          </a:bodyPr>
+          <a:lstStyle/>
+          <a:p>
+            <a:pPr algn="r">
+              <a:defRPr sz="1100">
+                <a:solidFill>
+                  <a:srgbClr val="555555"/>
+                </a:solidFill>
+              </a:defRPr>
+            </a:pPr>
+            <a:r>
+              <a:t>45</a:t>
+            </a:r>
+          </a:p>
+        </p:txBody>
+      </p:sp>
+      <p:sp>
+        <p:nvSpPr>
+          <p:cNvPr id="8" name="TextBox 7"/>
+          <p:cNvSpPr txBox="1"/>
+          <p:nvPr/>
+        </p:nvSpPr>
+        <p:spPr>
+          <a:xfrm>
+            <a:off x="548640" y="1645920"/>
+            <a:ext cx="11064240" cy="4754880"/>
+          </a:xfrm>
+          <a:prstGeom prst="rect">
+            <a:avLst/>
+          </a:prstGeom>
+          <a:noFill/>
+        </p:spPr>
+        <p:txBody>
+          <a:bodyPr wrap="square">
+            <a:spAutoFit/>
+          </a:bodyPr>
+          <a:lstStyle/>
+          <a:p>
+            <a:pPr>
+              <a:spcAft>
+                <a:spcPts val="1000"/>
+              </a:spcAft>
+            </a:pPr>
+            <a:r>
+              <a:rPr sz="1700">
+                <a:solidFill>
+                  <a:srgbClr val="1B2A4A"/>
+                </a:solidFill>
+                <a:latin typeface="Segoe UI"/>
+              </a:rPr>
+              <a:t>•  Collapsed-by-default panel in the web app (a corner case — mainly useful the first time a new site comes online)</a:t>
+            </a:r>
+          </a:p>
+          <a:p>
+            <a:pPr>
+              <a:spcAft>
+                <a:spcPts val="1000"/>
+              </a:spcAft>
+            </a:pPr>
+            <a:r>
+              <a:rPr sz="1700">
+                <a:solidFill>
+                  <a:srgbClr val="1B2A4A"/>
+                </a:solidFill>
+                <a:latin typeface="Segoe UI"/>
+              </a:rPr>
+              <a:t>•  Pick two already-extracted CSVs (auto-discovered from disk), name each site, pick the primary, and Create &amp; Run in one step — no hand-written job.json needed</a:t>
+            </a:r>
+          </a:p>
+          <a:p>
+            <a:pPr>
+              <a:spcAft>
+                <a:spcPts val="1000"/>
+              </a:spcAft>
+            </a:pPr>
+            <a:r>
+              <a:rPr sz="1700">
+                <a:solidFill>
+                  <a:srgbClr val="1B2A4A"/>
+                </a:solidFill>
+                <a:latin typeface="Segoe UI"/>
+              </a:rPr>
+              <a:t>•  Validates first: a genuine measurement-unit mismatch (e.g. dBc vs. dBm) blocks with an explanation, with an explicit override to proceed anyway</a:t>
+            </a:r>
+          </a:p>
+          <a:p>
+            <a:pPr lvl="1">
+              <a:spcAft>
+                <a:spcPts val="1000"/>
+              </a:spcAft>
+            </a:pPr>
+            <a:r>
+              <a:rPr sz="1500">
+                <a:solidFill>
+                  <a:srgbClr val="1B2A4A"/>
+                </a:solidFill>
+                <a:latin typeface="Segoe UI"/>
+              </a:rPr>
+              <a:t>–  Softer gaps — missing temperatures/ports, non-overlapping frequency ranges — only warn, never block</a:t>
+            </a:r>
+          </a:p>
+          <a:p>
+            <a:pPr>
+              <a:spcAft>
+                <a:spcPts val="1000"/>
+              </a:spcAft>
+            </a:pPr>
+            <a:r>
+              <a:rPr sz="1700">
+                <a:solidFill>
+                  <a:srgbClr val="1B2A4A"/>
+                </a:solidFill>
+                <a:latin typeface="Segoe UI"/>
+              </a:rPr>
+              <a:t>•  New job defaults to local-only (publish_to left empty) — publishing an ad-hoc comparison test is a deliberate, separate choice</a:t>
+            </a:r>
+          </a:p>
+          <a:p>
+            <a:pPr>
+              <a:spcAft>
+                <a:spcPts val="1000"/>
+              </a:spcAft>
+            </a:pPr>
+            <a:r>
+              <a:rPr sz="1700">
+                <a:solidFill>
+                  <a:srgbClr val="1B2A4A"/>
+                </a:solidFill>
+                <a:latin typeface="Segoe UI"/>
+              </a:rPr>
+              <a:t>•  "Show tooltip help" checkbox (top of every page) toggles hover help across the whole app on/off, remembered across reloads</a:t>
             </a:r>
           </a:p>
         </p:txBody>
@@ -19542,7 +19784,7 @@
             <a:avLst/>
           </a:prstGeom>
           <a:solidFill>
-            <a:srgbClr val="F2F4F8"/>
+            <a:srgbClr val="1B2A4A"/>
           </a:solidFill>
           <a:ln>
             <a:noFill/>
@@ -19580,7 +19822,7 @@
         <p:spPr>
           <a:xfrm>
             <a:off x="822960" y="2743200"/>
-            <a:ext cx="10515600" cy="914400"/>
+            <a:ext cx="10515600" cy="1097280"/>
           </a:xfrm>
           <a:prstGeom prst="rect">
             <a:avLst/>
@@ -19594,14 +19836,14 @@
           <a:lstStyle/>
           <a:p>
             <a:pPr>
-              <a:defRPr sz="4400" b="1">
-                <a:solidFill>
-                  <a:srgbClr val="1B2A4A"/>
+              <a:defRPr sz="4800" b="1">
+                <a:solidFill>
+                  <a:srgbClr val="FFFFFF"/>
                 </a:solidFill>
               </a:defRPr>
             </a:pPr>
             <a:r>
-              <a:t>Appendix</a:t>
+              <a:t>Questions?</a:t>
             </a:r>
           </a:p>
         </p:txBody>
@@ -19614,7 +19856,7 @@
         </p:nvSpPr>
         <p:spPr>
           <a:xfrm>
-            <a:off x="822960" y="3566160"/>
+            <a:off x="822960" y="3749039"/>
             <a:ext cx="10515600" cy="640080"/>
           </a:xfrm>
           <a:prstGeom prst="rect">
@@ -19629,14 +19871,15 @@
           <a:lstStyle/>
           <a:p>
             <a:pPr>
-              <a:defRPr sz="2200">
-                <a:solidFill>
-                  <a:srgbClr val="0066CC"/>
-                </a:solidFill>
+              <a:defRPr sz="1800">
+                <a:solidFill>
+                  <a:srgbClr val="9FC5FF"/>
+                </a:solidFill>
+                <a:latin typeface="Consolas"/>
               </a:defRPr>
             </a:pPr>
             <a:r>
-              <a:t>Setting Up From Zero — Assumes No Prior Access</a:t>
+              <a:t>C:\apps\padb\tools   |   /padb-tools</a:t>
             </a:r>
           </a:p>
         </p:txBody>
@@ -19674,7 +19917,7 @@
             <a:avLst/>
           </a:prstGeom>
           <a:solidFill>
-            <a:srgbClr val="FFFFFF"/>
+            <a:srgbClr val="F2F4F8"/>
           </a:solidFill>
           <a:ln>
             <a:noFill/>
@@ -19711,8 +19954,8 @@
         </p:nvSpPr>
         <p:spPr>
           <a:xfrm>
-            <a:off x="548640" y="320040"/>
-            <a:ext cx="7315200" cy="365760"/>
+            <a:off x="822960" y="2743200"/>
+            <a:ext cx="10515600" cy="914400"/>
           </a:xfrm>
           <a:prstGeom prst="rect">
             <a:avLst/>
@@ -19726,390 +19969,49 @@
           <a:lstStyle/>
           <a:p>
             <a:pPr>
-              <a:defRPr sz="1600" b="1">
+              <a:defRPr sz="4400" b="1">
+                <a:solidFill>
+                  <a:srgbClr val="1B2A4A"/>
+                </a:solidFill>
+              </a:defRPr>
+            </a:pPr>
+            <a:r>
+              <a:t>Appendix</a:t>
+            </a:r>
+          </a:p>
+        </p:txBody>
+      </p:sp>
+      <p:sp>
+        <p:nvSpPr>
+          <p:cNvPr id="4" name="TextBox 3"/>
+          <p:cNvSpPr txBox="1"/>
+          <p:nvPr/>
+        </p:nvSpPr>
+        <p:spPr>
+          <a:xfrm>
+            <a:off x="822960" y="3566160"/>
+            <a:ext cx="10515600" cy="640080"/>
+          </a:xfrm>
+          <a:prstGeom prst="rect">
+            <a:avLst/>
+          </a:prstGeom>
+          <a:noFill/>
+        </p:spPr>
+        <p:txBody>
+          <a:bodyPr wrap="none">
+            <a:spAutoFit/>
+          </a:bodyPr>
+          <a:lstStyle/>
+          <a:p>
+            <a:pPr>
+              <a:defRPr sz="2200">
                 <a:solidFill>
                   <a:srgbClr val="0066CC"/>
                 </a:solidFill>
-                <a:latin typeface="Segoe UI"/>
               </a:defRPr>
             </a:pPr>
             <a:r>
-              <a:t>Appendix</a:t>
-            </a:r>
-          </a:p>
-        </p:txBody>
-      </p:sp>
-      <p:sp>
-        <p:nvSpPr>
-          <p:cNvPr id="4" name="TextBox 3"/>
-          <p:cNvSpPr txBox="1"/>
-          <p:nvPr/>
-        </p:nvSpPr>
-        <p:spPr>
-          <a:xfrm>
-            <a:off x="548640" y="658368"/>
-            <a:ext cx="11064240" cy="822960"/>
-          </a:xfrm>
-          <a:prstGeom prst="rect">
-            <a:avLst/>
-          </a:prstGeom>
-          <a:noFill/>
-        </p:spPr>
-        <p:txBody>
-          <a:bodyPr wrap="square">
-            <a:spAutoFit/>
-          </a:bodyPr>
-          <a:lstStyle/>
-          <a:p>
-            <a:pPr>
-              <a:defRPr sz="3200" b="1">
-                <a:solidFill>
-                  <a:srgbClr val="1B2A4A"/>
-                </a:solidFill>
-                <a:latin typeface="Segoe UI"/>
-              </a:defRPr>
-            </a:pPr>
-            <a:r>
-              <a:t>Getting the Code</a:t>
-            </a:r>
-          </a:p>
-        </p:txBody>
-      </p:sp>
-      <p:cxnSp>
-        <p:nvCxnSpPr>
-          <p:cNvPr id="5" name="Connector 4"/>
-          <p:cNvCxnSpPr/>
-          <p:nvPr/>
-        </p:nvCxnSpPr>
-        <p:spPr>
-          <a:xfrm>
-            <a:off x="548640" y="1417320"/>
-            <a:ext cx="11091672" cy="0"/>
-          </a:xfrm>
-          <a:prstGeom prst="line">
-            <a:avLst/>
-          </a:prstGeom>
-          <a:ln w="28575">
-            <a:solidFill>
-              <a:srgbClr val="0066CC"/>
-            </a:solidFill>
-          </a:ln>
-        </p:spPr>
-        <p:style>
-          <a:lnRef idx="2">
-            <a:schemeClr val="accent1"/>
-          </a:lnRef>
-          <a:fillRef idx="0">
-            <a:schemeClr val="accent1"/>
-          </a:fillRef>
-          <a:effectRef idx="1">
-            <a:schemeClr val="accent1"/>
-          </a:effectRef>
-          <a:fontRef idx="minor">
-            <a:schemeClr val="tx1"/>
-          </a:fontRef>
-        </p:style>
-      </p:cxnSp>
-      <p:sp>
-        <p:nvSpPr>
-          <p:cNvPr id="6" name="TextBox 5"/>
-          <p:cNvSpPr txBox="1"/>
-          <p:nvPr/>
-        </p:nvSpPr>
-        <p:spPr>
-          <a:xfrm>
-            <a:off x="548640" y="6473952"/>
-            <a:ext cx="8229600" cy="320040"/>
-          </a:xfrm>
-          <a:prstGeom prst="rect">
-            <a:avLst/>
-          </a:prstGeom>
-          <a:noFill/>
-        </p:spPr>
-        <p:txBody>
-          <a:bodyPr wrap="none">
-            <a:spAutoFit/>
-          </a:bodyPr>
-          <a:lstStyle/>
-          <a:p>
-            <a:pPr>
-              <a:defRPr sz="1100">
-                <a:solidFill>
-                  <a:srgbClr val="555555"/>
-                </a:solidFill>
-                <a:latin typeface="Segoe UI"/>
-              </a:defRPr>
-            </a:pPr>
-            <a:r>
-              <a:t>padb-tools</a:t>
-            </a:r>
-          </a:p>
-        </p:txBody>
-      </p:sp>
-      <p:sp>
-        <p:nvSpPr>
-          <p:cNvPr id="7" name="TextBox 6"/>
-          <p:cNvSpPr txBox="1"/>
-          <p:nvPr/>
-        </p:nvSpPr>
-        <p:spPr>
-          <a:xfrm>
-            <a:off x="11338560" y="6473952"/>
-            <a:ext cx="548640" cy="320040"/>
-          </a:xfrm>
-          <a:prstGeom prst="rect">
-            <a:avLst/>
-          </a:prstGeom>
-          <a:noFill/>
-        </p:spPr>
-        <p:txBody>
-          <a:bodyPr wrap="none">
-            <a:spAutoFit/>
-          </a:bodyPr>
-          <a:lstStyle/>
-          <a:p>
-            <a:pPr algn="r">
-              <a:defRPr sz="1100">
-                <a:solidFill>
-                  <a:srgbClr val="555555"/>
-                </a:solidFill>
-              </a:defRPr>
-            </a:pPr>
-            <a:r>
-              <a:t>48</a:t>
-            </a:r>
-          </a:p>
-        </p:txBody>
-      </p:sp>
-      <p:sp>
-        <p:nvSpPr>
-          <p:cNvPr id="8" name="TextBox 7"/>
-          <p:cNvSpPr txBox="1"/>
-          <p:nvPr/>
-        </p:nvSpPr>
-        <p:spPr>
-          <a:xfrm>
-            <a:off x="548640" y="1691640"/>
-            <a:ext cx="11064240" cy="365760"/>
-          </a:xfrm>
-          <a:prstGeom prst="rect">
-            <a:avLst/>
-          </a:prstGeom>
-          <a:noFill/>
-        </p:spPr>
-        <p:txBody>
-          <a:bodyPr wrap="square">
-            <a:spAutoFit/>
-          </a:bodyPr>
-          <a:lstStyle/>
-          <a:p>
-            <a:pPr>
-              <a:spcAft>
-                <a:spcPts val="1000"/>
-              </a:spcAft>
-            </a:pPr>
-            <a:r>
-              <a:rPr sz="1900">
-                <a:solidFill>
-                  <a:srgbClr val="1B2A4A"/>
-                </a:solidFill>
-                <a:latin typeface="Segoe UI"/>
-              </a:rPr>
-              <a:t>•  This repo isn't on a company-wide share by default — copy it from:</a:t>
-            </a:r>
-          </a:p>
-        </p:txBody>
-      </p:sp>
-      <p:sp>
-        <p:nvSpPr>
-          <p:cNvPr id="9" name="Rounded Rectangle 8"/>
-          <p:cNvSpPr/>
-          <p:nvPr/>
-        </p:nvSpPr>
-        <p:spPr>
-          <a:xfrm>
-            <a:off x="548640" y="2103120"/>
-            <a:ext cx="11064240" cy="502920"/>
-          </a:xfrm>
-          <a:prstGeom prst="roundRect">
-            <a:avLst>
-              <a:gd name="adj" fmla="val 4000"/>
-            </a:avLst>
-          </a:prstGeom>
-          <a:solidFill>
-            <a:srgbClr val="282C34"/>
-          </a:solidFill>
-          <a:ln>
-            <a:solidFill>
-              <a:srgbClr val="111318"/>
-            </a:solidFill>
-          </a:ln>
-          <a:effectLst/>
-        </p:spPr>
-        <p:style>
-          <a:lnRef idx="1">
-            <a:schemeClr val="accent1"/>
-          </a:lnRef>
-          <a:fillRef idx="3">
-            <a:schemeClr val="accent1"/>
-          </a:fillRef>
-          <a:effectRef idx="2">
-            <a:schemeClr val="accent1"/>
-          </a:effectRef>
-          <a:fontRef idx="minor">
-            <a:schemeClr val="lt1"/>
-          </a:fontRef>
-        </p:style>
-        <p:txBody>
-          <a:bodyPr rtlCol="0" anchor="t" wrap="square" lIns="228600" rIns="228600" tIns="164592" bIns="164592"/>
-          <a:lstStyle/>
-          <a:p>
-            <a:pPr algn="l">
-              <a:spcAft>
-                <a:spcPts val="200"/>
-              </a:spcAft>
-            </a:pPr>
-            <a:r>
-              <a:rPr sz="1350">
-                <a:solidFill>
-                  <a:srgbClr val="E6E6E6"/>
-                </a:solidFill>
-                <a:latin typeface="Consolas"/>
-              </a:rPr>
-              <a:t>\\srsnas01.srs.is.keysight.com\prod\MIDRF3\SG6311A\Padb-tools\tools</a:t>
-            </a:r>
-          </a:p>
-        </p:txBody>
-      </p:sp>
-      <p:sp>
-        <p:nvSpPr>
-          <p:cNvPr id="10" name="TextBox 9"/>
-          <p:cNvSpPr txBox="1"/>
-          <p:nvPr/>
-        </p:nvSpPr>
-        <p:spPr>
-          <a:xfrm>
-            <a:off x="548640" y="2788920"/>
-            <a:ext cx="11064240" cy="365760"/>
-          </a:xfrm>
-          <a:prstGeom prst="rect">
-            <a:avLst/>
-          </a:prstGeom>
-          <a:noFill/>
-        </p:spPr>
-        <p:txBody>
-          <a:bodyPr wrap="square">
-            <a:spAutoFit/>
-          </a:bodyPr>
-          <a:lstStyle/>
-          <a:p>
-            <a:pPr>
-              <a:spcAft>
-                <a:spcPts val="1000"/>
-              </a:spcAft>
-            </a:pPr>
-            <a:r>
-              <a:rPr sz="1800">
-                <a:solidFill>
-                  <a:srgbClr val="1B2A4A"/>
-                </a:solidFill>
-                <a:latin typeface="Segoe UI"/>
-              </a:rPr>
-              <a:t>•  Copy that whole "tools" folder to a local path, e.g. C:\apps\padb\tools</a:t>
-            </a:r>
-          </a:p>
-        </p:txBody>
-      </p:sp>
-      <p:sp>
-        <p:nvSpPr>
-          <p:cNvPr id="11" name="TextBox 10"/>
-          <p:cNvSpPr txBox="1"/>
-          <p:nvPr/>
-        </p:nvSpPr>
-        <p:spPr>
-          <a:xfrm>
-            <a:off x="548640" y="3429000"/>
-            <a:ext cx="11064240" cy="914400"/>
-          </a:xfrm>
-          <a:prstGeom prst="rect">
-            <a:avLst/>
-          </a:prstGeom>
-          <a:noFill/>
-        </p:spPr>
-        <p:txBody>
-          <a:bodyPr wrap="square">
-            <a:spAutoFit/>
-          </a:bodyPr>
-          <a:lstStyle/>
-          <a:p>
-            <a:pPr>
-              <a:spcAft>
-                <a:spcPts val="1000"/>
-              </a:spcAft>
-            </a:pPr>
-            <a:r>
-              <a:rPr sz="1700">
-                <a:solidFill>
-                  <a:srgbClr val="1B2A4A"/>
-                </a:solidFill>
-                <a:latin typeface="Segoe UI"/>
-              </a:rPr>
-              <a:t>•  padb_batch.py is bundled directly inside the tools folder (added 2026-08-05) —</a:t>
-            </a:r>
-          </a:p>
-          <a:p>
-            <a:pPr lvl="1">
-              <a:spcAft>
-                <a:spcPts val="600"/>
-              </a:spcAft>
-            </a:pPr>
-            <a:r>
-              <a:rPr sz="1500">
-                <a:solidFill>
-                  <a:srgbClr val="555555"/>
-                </a:solidFill>
-                <a:latin typeface="Segoe UI"/>
-              </a:rPr>
-              <a:t>–  no separate dependency to track down; the whole repo is self-contained</a:t>
-            </a:r>
-          </a:p>
-        </p:txBody>
-      </p:sp>
-      <p:sp>
-        <p:nvSpPr>
-          <p:cNvPr id="12" name="TextBox 11"/>
-          <p:cNvSpPr txBox="1"/>
-          <p:nvPr/>
-        </p:nvSpPr>
-        <p:spPr>
-          <a:xfrm>
-            <a:off x="548640" y="4480560"/>
-            <a:ext cx="11064240" cy="457200"/>
-          </a:xfrm>
-          <a:prstGeom prst="rect">
-            <a:avLst/>
-          </a:prstGeom>
-          <a:noFill/>
-        </p:spPr>
-        <p:txBody>
-          <a:bodyPr wrap="square">
-            <a:spAutoFit/>
-          </a:bodyPr>
-          <a:lstStyle/>
-          <a:p>
-            <a:pPr>
-              <a:spcAft>
-                <a:spcPts val="1000"/>
-              </a:spcAft>
-            </a:pPr>
-            <a:r>
-              <a:rPr sz="1650">
-                <a:solidFill>
-                  <a:srgbClr val="1B2A4A"/>
-                </a:solidFill>
-                <a:latin typeface="Segoe UI"/>
-              </a:rPr>
-              <a:t>•  Then follow the Prerequisites and Per-User Config slides earlier in this deck</a:t>
+              <a:t>Setting Up From Zero — Assumes No Prior Access</a:t>
             </a:r>
           </a:p>
         </p:txBody>
@@ -20243,7 +20145,7 @@
               </a:defRPr>
             </a:pPr>
             <a:r>
-              <a:t>First Commands to Verify Your Setup</a:t>
+              <a:t>Getting the Code</a:t>
             </a:r>
           </a:p>
         </p:txBody>
@@ -20349,7 +20251,7 @@
               </a:defRPr>
             </a:pPr>
             <a:r>
-              <a:t>49</a:t>
+              <a:t>48</a:t>
             </a:r>
           </a:p>
         </p:txBody>
@@ -20382,13 +20284,13 @@
               </a:spcAft>
             </a:pPr>
             <a:r>
-              <a:rPr sz="1800">
+              <a:rPr sz="1900">
                 <a:solidFill>
                   <a:srgbClr val="1B2A4A"/>
                 </a:solidFill>
                 <a:latin typeface="Segoe UI"/>
               </a:rPr>
-              <a:t>•  From inside the tools folder, confirm everything imports cleanly:</a:t>
+              <a:t>•  This repo isn't on a company-wide share by default — copy it from:</a:t>
             </a:r>
           </a:p>
         </p:txBody>
@@ -20443,13 +20345,13 @@
               </a:spcAft>
             </a:pPr>
             <a:r>
-              <a:rPr sz="1450">
+              <a:rPr sz="1350">
                 <a:solidFill>
                   <a:srgbClr val="E6E6E6"/>
                 </a:solidFill>
                 <a:latin typeface="Consolas"/>
               </a:rPr>
-              <a:t>py -c "import padb_run, padb_v2, padb_config"</a:t>
+              <a:t>\\srsnas01.srs.is.keysight.com\prod\MIDRF3\SG6311A\Padb-tools\tools</a:t>
             </a:r>
           </a:p>
         </p:txBody>
@@ -20462,7 +20364,7 @@
         </p:nvSpPr>
         <p:spPr>
           <a:xfrm>
-            <a:off x="548640" y="2743200"/>
+            <a:off x="548640" y="2788920"/>
             <a:ext cx="11064240" cy="365760"/>
           </a:xfrm>
           <a:prstGeom prst="rect">
@@ -20482,27 +20384,82 @@
               </a:spcAft>
             </a:pPr>
             <a:r>
+              <a:rPr sz="1800">
+                <a:solidFill>
+                  <a:srgbClr val="1B2A4A"/>
+                </a:solidFill>
+                <a:latin typeface="Segoe UI"/>
+              </a:rPr>
+              <a:t>•  Copy that whole "tools" folder to a local path, e.g. C:\apps\padb\tools</a:t>
+            </a:r>
+          </a:p>
+        </p:txBody>
+      </p:sp>
+      <p:sp>
+        <p:nvSpPr>
+          <p:cNvPr id="11" name="TextBox 10"/>
+          <p:cNvSpPr txBox="1"/>
+          <p:nvPr/>
+        </p:nvSpPr>
+        <p:spPr>
+          <a:xfrm>
+            <a:off x="548640" y="3429000"/>
+            <a:ext cx="11064240" cy="914400"/>
+          </a:xfrm>
+          <a:prstGeom prst="rect">
+            <a:avLst/>
+          </a:prstGeom>
+          <a:noFill/>
+        </p:spPr>
+        <p:txBody>
+          <a:bodyPr wrap="square">
+            <a:spAutoFit/>
+          </a:bodyPr>
+          <a:lstStyle/>
+          <a:p>
+            <a:pPr>
+              <a:spcAft>
+                <a:spcPts val="1000"/>
+              </a:spcAft>
+            </a:pPr>
+            <a:r>
               <a:rPr sz="1700">
                 <a:solidFill>
                   <a:srgbClr val="1B2A4A"/>
                 </a:solidFill>
                 <a:latin typeface="Segoe UI"/>
               </a:rPr>
-              <a:t>•  No output and no traceback = success</a:t>
-            </a:r>
-          </a:p>
-        </p:txBody>
-      </p:sp>
-      <p:sp>
-        <p:nvSpPr>
-          <p:cNvPr id="11" name="TextBox 10"/>
-          <p:cNvSpPr txBox="1"/>
-          <p:nvPr/>
-        </p:nvSpPr>
-        <p:spPr>
-          <a:xfrm>
-            <a:off x="548640" y="3291840"/>
-            <a:ext cx="11064240" cy="365760"/>
+              <a:t>•  padb_batch.py is bundled directly inside the tools folder (added 2026-08-05) —</a:t>
+            </a:r>
+          </a:p>
+          <a:p>
+            <a:pPr lvl="1">
+              <a:spcAft>
+                <a:spcPts val="600"/>
+              </a:spcAft>
+            </a:pPr>
+            <a:r>
+              <a:rPr sz="1500">
+                <a:solidFill>
+                  <a:srgbClr val="555555"/>
+                </a:solidFill>
+                <a:latin typeface="Segoe UI"/>
+              </a:rPr>
+              <a:t>–  no separate dependency to track down; the whole repo is self-contained</a:t>
+            </a:r>
+          </a:p>
+        </p:txBody>
+      </p:sp>
+      <p:sp>
+        <p:nvSpPr>
+          <p:cNvPr id="12" name="TextBox 11"/>
+          <p:cNvSpPr txBox="1"/>
+          <p:nvPr/>
+        </p:nvSpPr>
+        <p:spPr>
+          <a:xfrm>
+            <a:off x="548640" y="4480560"/>
+            <a:ext cx="11064240" cy="457200"/>
           </a:xfrm>
           <a:prstGeom prst="rect">
             <a:avLst/>
@@ -20521,145 +20478,13 @@
               </a:spcAft>
             </a:pPr>
             <a:r>
-              <a:rPr sz="1800">
+              <a:rPr sz="1650">
                 <a:solidFill>
                   <a:srgbClr val="1B2A4A"/>
                 </a:solidFill>
                 <a:latin typeface="Segoe UI"/>
               </a:rPr>
-              <a:t>•  Then generate your first job.json from any pod you have access to:</a:t>
-            </a:r>
-          </a:p>
-        </p:txBody>
-      </p:sp>
-      <p:sp>
-        <p:nvSpPr>
-          <p:cNvPr id="12" name="Rounded Rectangle 11"/>
-          <p:cNvSpPr/>
-          <p:nvPr/>
-        </p:nvSpPr>
-        <p:spPr>
-          <a:xfrm>
-            <a:off x="548640" y="3703320"/>
-            <a:ext cx="11064240" cy="502920"/>
-          </a:xfrm>
-          <a:prstGeom prst="roundRect">
-            <a:avLst>
-              <a:gd name="adj" fmla="val 4000"/>
-            </a:avLst>
-          </a:prstGeom>
-          <a:solidFill>
-            <a:srgbClr val="282C34"/>
-          </a:solidFill>
-          <a:ln>
-            <a:solidFill>
-              <a:srgbClr val="111318"/>
-            </a:solidFill>
-          </a:ln>
-          <a:effectLst/>
-        </p:spPr>
-        <p:style>
-          <a:lnRef idx="1">
-            <a:schemeClr val="accent1"/>
-          </a:lnRef>
-          <a:fillRef idx="3">
-            <a:schemeClr val="accent1"/>
-          </a:fillRef>
-          <a:effectRef idx="2">
-            <a:schemeClr val="accent1"/>
-          </a:effectRef>
-          <a:fontRef idx="minor">
-            <a:schemeClr val="lt1"/>
-          </a:fontRef>
-        </p:style>
-        <p:txBody>
-          <a:bodyPr rtlCol="0" anchor="t" wrap="square" lIns="228600" rIns="228600" tIns="164592" bIns="164592"/>
-          <a:lstStyle/>
-          <a:p>
-            <a:pPr algn="l">
-              <a:spcAft>
-                <a:spcPts val="200"/>
-              </a:spcAft>
-            </a:pPr>
-            <a:r>
-              <a:rPr sz="1450">
-                <a:solidFill>
-                  <a:srgbClr val="E6E6E6"/>
-                </a:solidFill>
-                <a:latin typeface="Consolas"/>
-              </a:rPr>
-              <a:t>py padb_make_job.py YourPod.pod --module YourModule</a:t>
-            </a:r>
-          </a:p>
-        </p:txBody>
-      </p:sp>
-      <p:sp>
-        <p:nvSpPr>
-          <p:cNvPr id="13" name="TextBox 12"/>
-          <p:cNvSpPr txBox="1"/>
-          <p:nvPr/>
-        </p:nvSpPr>
-        <p:spPr>
-          <a:xfrm>
-            <a:off x="548640" y="4343400"/>
-            <a:ext cx="11064240" cy="1463040"/>
-          </a:xfrm>
-          <a:prstGeom prst="rect">
-            <a:avLst/>
-          </a:prstGeom>
-          <a:noFill/>
-        </p:spPr>
-        <p:txBody>
-          <a:bodyPr wrap="square">
-            <a:spAutoFit/>
-          </a:bodyPr>
-          <a:lstStyle/>
-          <a:p>
-            <a:pPr>
-              <a:spcAft>
-                <a:spcPts val="1000"/>
-              </a:spcAft>
-            </a:pPr>
-            <a:r>
-              <a:rPr sz="1700">
-                <a:solidFill>
-                  <a:srgbClr val="1B2A4A"/>
-                </a:solidFill>
-                <a:latin typeface="Segoe UI"/>
-              </a:rPr>
-              <a:t>•  If PADB-R.exe launches and a real window briefly appears, you're fully set up</a:t>
-            </a:r>
-          </a:p>
-          <a:p>
-            <a:pPr>
-              <a:spcAft>
-                <a:spcPts val="1000"/>
-              </a:spcAft>
-            </a:pPr>
-            <a:r>
-              <a:rPr sz="1700">
-                <a:solidFill>
-                  <a:srgbClr val="1B2A4A"/>
-                </a:solidFill>
-                <a:latin typeface="Segoe UI"/>
-              </a:rPr>
-              <a:t>•  Stuck? GETTING_STARTED.md → Quick_Start.md, or type /padb-tools once you're</a:t>
-            </a:r>
-          </a:p>
-          <a:p>
-            <a:pPr lvl="1">
-              <a:spcAft>
-                <a:spcPts val="600"/>
-              </a:spcAft>
-            </a:pPr>
-            <a:r>
-              <a:rPr sz="1500">
-                <a:solidFill>
-                  <a:srgbClr val="555555"/>
-                </a:solidFill>
-                <a:latin typeface="Segoe UI"/>
-              </a:rPr>
-              <a:t>–  working inside the repo</a:t>
+              <a:t>•  Then follow the Prerequisites and Per-User Config slides earlier in this deck</a:t>
             </a:r>
           </a:p>
         </p:txBody>
@@ -20757,7 +20582,7 @@
               </a:defRPr>
             </a:pPr>
             <a:r>
-              <a:t>Multi-Site Testing</a:t>
+              <a:t>Appendix</a:t>
             </a:r>
           </a:p>
         </p:txBody>
@@ -20793,7 +20618,7 @@
               </a:defRPr>
             </a:pPr>
             <a:r>
-              <a:t>Duplicate Test Runs — Why "n DUTs" Isn't Always DUT Count</a:t>
+              <a:t>First Commands to Verify Your Setup</a:t>
             </a:r>
           </a:p>
         </p:txBody>
@@ -20899,7 +20724,7 @@
               </a:defRPr>
             </a:pPr>
             <a:r>
-              <a:t>44</a:t>
+              <a:t>49</a:t>
             </a:r>
           </a:p>
         </p:txBody>
@@ -20912,8 +20737,8 @@
         </p:nvSpPr>
         <p:spPr>
           <a:xfrm>
-            <a:off x="548640" y="1645920"/>
-            <a:ext cx="11064240" cy="4754880"/>
+            <a:off x="548640" y="1691640"/>
+            <a:ext cx="11064240" cy="365760"/>
           </a:xfrm>
           <a:prstGeom prst="rect">
             <a:avLst/>
@@ -20932,15 +20757,138 @@
               </a:spcAft>
             </a:pPr>
             <a:r>
+              <a:rPr sz="1800">
+                <a:solidFill>
+                  <a:srgbClr val="1B2A4A"/>
+                </a:solidFill>
+                <a:latin typeface="Segoe UI"/>
+              </a:rPr>
+              <a:t>•  From inside the tools folder, confirm everything imports cleanly:</a:t>
+            </a:r>
+          </a:p>
+        </p:txBody>
+      </p:sp>
+      <p:sp>
+        <p:nvSpPr>
+          <p:cNvPr id="9" name="Rounded Rectangle 8"/>
+          <p:cNvSpPr/>
+          <p:nvPr/>
+        </p:nvSpPr>
+        <p:spPr>
+          <a:xfrm>
+            <a:off x="548640" y="2103120"/>
+            <a:ext cx="11064240" cy="502920"/>
+          </a:xfrm>
+          <a:prstGeom prst="roundRect">
+            <a:avLst>
+              <a:gd name="adj" fmla="val 4000"/>
+            </a:avLst>
+          </a:prstGeom>
+          <a:solidFill>
+            <a:srgbClr val="282C34"/>
+          </a:solidFill>
+          <a:ln>
+            <a:solidFill>
+              <a:srgbClr val="111318"/>
+            </a:solidFill>
+          </a:ln>
+          <a:effectLst/>
+        </p:spPr>
+        <p:style>
+          <a:lnRef idx="1">
+            <a:schemeClr val="accent1"/>
+          </a:lnRef>
+          <a:fillRef idx="3">
+            <a:schemeClr val="accent1"/>
+          </a:fillRef>
+          <a:effectRef idx="2">
+            <a:schemeClr val="accent1"/>
+          </a:effectRef>
+          <a:fontRef idx="minor">
+            <a:schemeClr val="lt1"/>
+          </a:fontRef>
+        </p:style>
+        <p:txBody>
+          <a:bodyPr rtlCol="0" anchor="t" wrap="square" lIns="228600" rIns="228600" tIns="164592" bIns="164592"/>
+          <a:lstStyle/>
+          <a:p>
+            <a:pPr algn="l">
+              <a:spcAft>
+                <a:spcPts val="200"/>
+              </a:spcAft>
+            </a:pPr>
+            <a:r>
+              <a:rPr sz="1450">
+                <a:solidFill>
+                  <a:srgbClr val="E6E6E6"/>
+                </a:solidFill>
+                <a:latin typeface="Consolas"/>
+              </a:rPr>
+              <a:t>py -c "import padb_run, padb_v2, padb_config"</a:t>
+            </a:r>
+          </a:p>
+        </p:txBody>
+      </p:sp>
+      <p:sp>
+        <p:nvSpPr>
+          <p:cNvPr id="10" name="TextBox 9"/>
+          <p:cNvSpPr txBox="1"/>
+          <p:nvPr/>
+        </p:nvSpPr>
+        <p:spPr>
+          <a:xfrm>
+            <a:off x="548640" y="2743200"/>
+            <a:ext cx="11064240" cy="365760"/>
+          </a:xfrm>
+          <a:prstGeom prst="rect">
+            <a:avLst/>
+          </a:prstGeom>
+          <a:noFill/>
+        </p:spPr>
+        <p:txBody>
+          <a:bodyPr wrap="square">
+            <a:spAutoFit/>
+          </a:bodyPr>
+          <a:lstStyle/>
+          <a:p>
+            <a:pPr>
+              <a:spcAft>
+                <a:spcPts val="1000"/>
+              </a:spcAft>
+            </a:pPr>
+            <a:r>
               <a:rPr sz="1700">
                 <a:solidFill>
                   <a:srgbClr val="1B2A4A"/>
                 </a:solidFill>
                 <a:latin typeface="Segoe UI"/>
               </a:rPr>
-              <a:t>•  Statistics Table's n counts raw CSV rows, not distinct DUTs — a DUT measured twice at the same point is counted twice</a:t>
-            </a:r>
-          </a:p>
+              <a:t>•  No output and no traceback = success</a:t>
+            </a:r>
+          </a:p>
+        </p:txBody>
+      </p:sp>
+      <p:sp>
+        <p:nvSpPr>
+          <p:cNvPr id="11" name="TextBox 10"/>
+          <p:cNvSpPr txBox="1"/>
+          <p:nvPr/>
+        </p:nvSpPr>
+        <p:spPr>
+          <a:xfrm>
+            <a:off x="548640" y="3291840"/>
+            <a:ext cx="11064240" cy="365760"/>
+          </a:xfrm>
+          <a:prstGeom prst="rect">
+            <a:avLst/>
+          </a:prstGeom>
+          <a:noFill/>
+        </p:spPr>
+        <p:txBody>
+          <a:bodyPr wrap="square">
+            <a:spAutoFit/>
+          </a:bodyPr>
+          <a:lstStyle/>
           <a:p>
             <a:pPr>
               <a:spcAft>
@@ -20948,13 +20896,113 @@
               </a:spcAft>
             </a:pPr>
             <a:r>
+              <a:rPr sz="1800">
+                <a:solidFill>
+                  <a:srgbClr val="1B2A4A"/>
+                </a:solidFill>
+                <a:latin typeface="Segoe UI"/>
+              </a:rPr>
+              <a:t>•  Then generate your first job.json from any pod you have access to:</a:t>
+            </a:r>
+          </a:p>
+        </p:txBody>
+      </p:sp>
+      <p:sp>
+        <p:nvSpPr>
+          <p:cNvPr id="12" name="Rounded Rectangle 11"/>
+          <p:cNvSpPr/>
+          <p:nvPr/>
+        </p:nvSpPr>
+        <p:spPr>
+          <a:xfrm>
+            <a:off x="548640" y="3703320"/>
+            <a:ext cx="11064240" cy="502920"/>
+          </a:xfrm>
+          <a:prstGeom prst="roundRect">
+            <a:avLst>
+              <a:gd name="adj" fmla="val 4000"/>
+            </a:avLst>
+          </a:prstGeom>
+          <a:solidFill>
+            <a:srgbClr val="282C34"/>
+          </a:solidFill>
+          <a:ln>
+            <a:solidFill>
+              <a:srgbClr val="111318"/>
+            </a:solidFill>
+          </a:ln>
+          <a:effectLst/>
+        </p:spPr>
+        <p:style>
+          <a:lnRef idx="1">
+            <a:schemeClr val="accent1"/>
+          </a:lnRef>
+          <a:fillRef idx="3">
+            <a:schemeClr val="accent1"/>
+          </a:fillRef>
+          <a:effectRef idx="2">
+            <a:schemeClr val="accent1"/>
+          </a:effectRef>
+          <a:fontRef idx="minor">
+            <a:schemeClr val="lt1"/>
+          </a:fontRef>
+        </p:style>
+        <p:txBody>
+          <a:bodyPr rtlCol="0" anchor="t" wrap="square" lIns="228600" rIns="228600" tIns="164592" bIns="164592"/>
+          <a:lstStyle/>
+          <a:p>
+            <a:pPr algn="l">
+              <a:spcAft>
+                <a:spcPts val="200"/>
+              </a:spcAft>
+            </a:pPr>
+            <a:r>
+              <a:rPr sz="1450">
+                <a:solidFill>
+                  <a:srgbClr val="E6E6E6"/>
+                </a:solidFill>
+                <a:latin typeface="Consolas"/>
+              </a:rPr>
+              <a:t>py padb_make_job.py YourPod.pod --module YourModule</a:t>
+            </a:r>
+          </a:p>
+        </p:txBody>
+      </p:sp>
+      <p:sp>
+        <p:nvSpPr>
+          <p:cNvPr id="13" name="TextBox 12"/>
+          <p:cNvSpPr txBox="1"/>
+          <p:nvPr/>
+        </p:nvSpPr>
+        <p:spPr>
+          <a:xfrm>
+            <a:off x="548640" y="4343400"/>
+            <a:ext cx="11064240" cy="1463040"/>
+          </a:xfrm>
+          <a:prstGeom prst="rect">
+            <a:avLst/>
+          </a:prstGeom>
+          <a:noFill/>
+        </p:spPr>
+        <p:txBody>
+          <a:bodyPr wrap="square">
+            <a:spAutoFit/>
+          </a:bodyPr>
+          <a:lstStyle/>
+          <a:p>
+            <a:pPr>
+              <a:spcAft>
+                <a:spcPts val="1000"/>
+              </a:spcAft>
+            </a:pPr>
+            <a:r>
               <a:rPr sz="1700">
                 <a:solidFill>
                   <a:srgbClr val="1B2A4A"/>
                 </a:solidFill>
                 <a:latin typeface="Segoe UI"/>
               </a:rPr>
-              <a:t>•  "Dup runs" column sums the extras across every duplicated DUT — 3 DUTs with 1 dup each is not the same as 1 DUT with 3 dups</a:t>
+              <a:t>•  If PADB-R.exe launches and a real window briefly appears, you're fully set up</a:t>
             </a:r>
           </a:p>
           <a:p>
@@ -20970,71 +21018,23 @@
                 </a:solidFill>
                 <a:latin typeface="Segoe UI"/>
               </a:rPr>
-              <a:t>•  Site Population Check's "Genuinely repeated freqs" / "SR dup pts" break duplicates down per-DUT instead of one ambiguous total</a:t>
-            </a:r>
-          </a:p>
-          <a:p>
-            <a:pPr>
-              <a:spcAft>
-                <a:spcPts val="1000"/>
-              </a:spcAft>
-            </a:pPr>
-            <a:r>
-              <a:rPr sz="1700">
-                <a:solidFill>
-                  <a:srgbClr val="1B2A4A"/>
-                </a:solidFill>
-                <a:latin typeface="Segoe UI"/>
-              </a:rPr>
-              <a:t>•  Port is part of the duplicate identity — a DUT's RF1 and RF2 rows are two real measurements, never counted as duplicates of each other</a:t>
+              <a:t>•  Stuck? GETTING_STARTED.md → Quick_Start.md, or type /padb-tools once you're</a:t>
             </a:r>
           </a:p>
           <a:p>
             <a:pPr lvl="1">
               <a:spcAft>
-                <a:spcPts val="1000"/>
+                <a:spcPts val="600"/>
               </a:spcAft>
             </a:pPr>
             <a:r>
               <a:rPr sz="1500">
                 <a:solidFill>
-                  <a:srgbClr val="1B2A4A"/>
-                </a:solidFill>
-                <a:latin typeface="Segoe UI"/>
-              </a:rPr>
-              <a:t>–  Real bug fixed this session: an earlier version of this check missed that distinction</a:t>
-            </a:r>
-          </a:p>
-          <a:p>
-            <a:pPr>
-              <a:spcAft>
-                <a:spcPts val="1000"/>
-              </a:spcAft>
-            </a:pPr>
-            <a:r>
-              <a:rPr sz="1700">
-                <a:solidFill>
-                  <a:srgbClr val="1B2A4A"/>
-                </a:solidFill>
-                <a:latin typeface="Segoe UI"/>
-              </a:rPr>
-              <a:t>•  Condition pooling (e.g. Group by: Serial Number) is not a duplicate either — same DUT under different SpurTypes/conditions is real coverage, not a repeat</a:t>
-            </a:r>
-          </a:p>
-          <a:p>
-            <a:pPr>
-              <a:spcAft>
-                <a:spcPts val="1000"/>
-              </a:spcAft>
-            </a:pPr>
-            <a:r>
-              <a:rPr sz="1700">
-                <a:solidFill>
-                  <a:srgbClr val="1B2A4A"/>
-                </a:solidFill>
-                <a:latin typeface="Segoe UI"/>
-              </a:rPr>
-              <a:t>•  "Collapse dup runs" checkbox (boxplot) averages true duplicates before computing box stats — stat_summary/summary don't need it, their per-DUT data is already pre-averaged server-side</a:t>
+                  <a:srgbClr val="555555"/>
+                </a:solidFill>
+                <a:latin typeface="Segoe UI"/>
+              </a:rPr>
+              <a:t>–  working inside the repo</a:t>
             </a:r>
           </a:p>
         </p:txBody>

</xml_diff>

<commit_message>
Fix two more pre-existing overlap bugs found during a full-deck review
Requested a full visual pass over all 49 rendered slides (not just the
ones touched this session) via PowerPoint COM automation. Found two
pre-existing bugs, unrelated to this session's edits:

- Slide 27 ("The Result -- Spec Pass/Fail"): 4 separate bullet
  paragraphs pushed the last two down far enough to render behind the
  screenshot beneath them. Merged into 2 tighter bullets and shortened
  wording so both clear the image.
- Slide 34 ("Pre-Flight Check -- padb_csv_check.py"): the first bullet
  wrapped to a second line that rendered behind the code block below
  it. Shortened to fit on one line.

Re-rendered both after the fix to confirm the text now fully clears the
image/code block in each case. All 49 slides reviewed; no other
overlap or overflow issues found.

Co-Authored-By: Claude Sonnet 5 <noreply@anthropic.com>
</commit_message>
<xml_diff>
--- a/PADB_Simple_and_Interactive.pptx
+++ b/PADB_Simple_and_Interactive.pptx
@@ -11128,7 +11128,7 @@
                 </a:solidFill>
                 <a:latin typeface="Segoe UI"/>
               </a:rPr>
-              <a:t>•  This pod's CSV has real Upper (30 dBm) and Lower (23 dBm) limits, so both are detected</a:t>
+              <a:t>•  This pod's CSV has real Upper (30 dBm) and Lower (23 dBm) limits, so both are detected automatically — no manual override needed (data beats config)</a:t>
             </a:r>
           </a:p>
           <a:p>
@@ -11144,39 +11144,7 @@
                 </a:solidFill>
                 <a:latin typeface="Segoe UI"/>
               </a:rPr>
-              <a:t>•  automatically -- no manual override needed, and no live selector to switch (data beats config)</a:t>
-            </a:r>
-          </a:p>
-          <a:p>
-            <a:pPr>
-              <a:spcAft>
-                <a:spcPts val="1000"/>
-              </a:spcAft>
-            </a:pPr>
-            <a:r>
-              <a:rPr sz="1500">
-                <a:solidFill>
-                  <a:srgbClr val="1B2A4A"/>
-                </a:solidFill>
-                <a:latin typeface="Segoe UI"/>
-              </a:rPr>
-              <a:t>•  MaxPower is a guaranteed-minimum-power measurement, so the Lower limit is the one that</a:t>
-            </a:r>
-          </a:p>
-          <a:p>
-            <a:pPr>
-              <a:spcAft>
-                <a:spcPts val="1000"/>
-              </a:spcAft>
-            </a:pPr>
-            <a:r>
-              <a:rPr sz="1500">
-                <a:solidFill>
-                  <a:srgbClr val="1B2A4A"/>
-                </a:solidFill>
-                <a:latin typeface="Segoe UI"/>
-              </a:rPr>
-              <a:t>•  actually matters here -- watch the dashed lower spec line against the TTL band as you filter</a:t>
+              <a:t>•  MaxPower's guaranteed minimum means the Lower limit is what matters — watch it against the TTL band below</a:t>
             </a:r>
           </a:p>
         </p:txBody>
@@ -14363,7 +14331,7 @@
                 </a:solidFill>
                 <a:latin typeface="Segoe UI"/>
               </a:rPr>
-              <a:t>•  Run it between Step 2 (extraction) and Step 4 (build views) — before spending time on a build that turns out wrong:</a:t>
+              <a:t>•  Run it between Step 2 (extraction) and Step 4 (build views):</a:t>
             </a:r>
           </a:p>
         </p:txBody>

</xml_diff>